<commit_message>
Switch deck to Times New Roman; add slide preview renderer
</commit_message>
<xml_diff>
--- a/Epstein_Transnational_Justice.pptx
+++ b/Epstein_Transnational_Justice.pptx
@@ -3179,7 +3179,7 @@
                 <a:solidFill>
                   <a:srgbClr val="C08A2B"/>
                 </a:solidFill>
-                <a:latin typeface="Calibri"/>
+                <a:latin typeface="Times New Roman"/>
               </a:rPr>
               <a:t>TRANSNATIONAL CRIME &amp; THE LIMITS OF INTERNATIONAL JUSTICE</a:t>
             </a:r>
@@ -3218,7 +3218,7 @@
                 <a:solidFill>
                   <a:srgbClr val="FFFFFF"/>
                 </a:solidFill>
-                <a:latin typeface="Calibri"/>
+                <a:latin typeface="Times New Roman"/>
               </a:rPr>
               <a:t>What the Epstein Case Reveals</a:t>
             </a:r>
@@ -3257,7 +3257,7 @@
                 <a:solidFill>
                   <a:srgbClr val="F2F4F7"/>
                 </a:solidFill>
-                <a:latin typeface="Calibri"/>
+                <a:latin typeface="Times New Roman"/>
               </a:rPr>
               <a:t>A case study in cross-border exploitation, jurisdiction, and accountability</a:t>
             </a:r>
@@ -3296,7 +3296,7 @@
                 <a:solidFill>
                   <a:srgbClr val="6B7682"/>
                 </a:solidFill>
-                <a:latin typeface="Calibri"/>
+                <a:latin typeface="Times New Roman"/>
               </a:rPr>
               <a:t>Group Presentation  •  Faculty of Law  •  2026</a:t>
             </a:r>
@@ -3449,7 +3449,7 @@
                 <a:solidFill>
                   <a:srgbClr val="C08A2B"/>
                 </a:solidFill>
-                <a:latin typeface="Calibri"/>
+                <a:latin typeface="Times New Roman"/>
               </a:rPr>
               <a:t>OVERVIEW</a:t>
             </a:r>
@@ -3488,7 +3488,7 @@
                 <a:solidFill>
                   <a:srgbClr val="FFFFFF"/>
                 </a:solidFill>
-                <a:latin typeface="Calibri"/>
+                <a:latin typeface="Times New Roman"/>
               </a:rPr>
               <a:t>Our Central Question &amp; Roadmap</a:t>
             </a:r>
@@ -3571,7 +3571,7 @@
                 <a:solidFill>
                   <a:srgbClr val="0F2A43"/>
                 </a:solidFill>
-                <a:latin typeface="Calibri"/>
+                <a:latin typeface="Times New Roman"/>
               </a:rPr>
               <a:t>Why is transnational sexual exploitation so hard to prosecute — and what do</a:t>
             </a:r>
@@ -3587,7 +3587,7 @@
                 <a:solidFill>
                   <a:srgbClr val="0F2A43"/>
                 </a:solidFill>
-                <a:latin typeface="Calibri"/>
+                <a:latin typeface="Times New Roman"/>
               </a:rPr>
               <a:t>international law and cross-border cooperation need in order to work?</a:t>
             </a:r>
@@ -3629,7 +3629,7 @@
                 <a:solidFill>
                   <a:srgbClr val="334455"/>
                 </a:solidFill>
-                <a:latin typeface="Calibri"/>
+                <a:latin typeface="Times New Roman"/>
               </a:rPr>
               <a:t>•  Part 1 — Framing &amp; the international scope of the case</a:t>
             </a:r>
@@ -3648,7 +3648,7 @@
                 <a:solidFill>
                   <a:srgbClr val="334455"/>
                 </a:solidFill>
-                <a:latin typeface="Calibri"/>
+                <a:latin typeface="Times New Roman"/>
               </a:rPr>
               <a:t>•  Part 2 — The international legal framework (Palermo Protocol, UNTOC, jurisdiction &amp; extradition)</a:t>
             </a:r>
@@ -3667,7 +3667,7 @@
                 <a:solidFill>
                   <a:srgbClr val="334455"/>
                 </a:solidFill>
-                <a:latin typeface="Calibri"/>
+                <a:latin typeface="Times New Roman"/>
               </a:rPr>
               <a:t>•  Part 3 — Wealth, mobility, and the problem of "elite impunity"</a:t>
             </a:r>
@@ -3686,7 +3686,7 @@
                 <a:solidFill>
                   <a:srgbClr val="334455"/>
                 </a:solidFill>
-                <a:latin typeface="Calibri"/>
+                <a:latin typeface="Times New Roman"/>
               </a:rPr>
               <a:t>•  Part 4 — Accountability, transparency &amp; lessons (incl. a Japan comparison)</a:t>
             </a:r>
@@ -3725,7 +3725,7 @@
                 <a:solidFill>
                   <a:srgbClr val="6B7682"/>
                 </a:solidFill>
-                <a:latin typeface="Calibri"/>
+                <a:latin typeface="Times New Roman"/>
               </a:rPr>
               <a:t>Note: This presentation centres victims and legal systems — not sensational detail.</a:t>
             </a:r>
@@ -3878,7 +3878,7 @@
                 <a:solidFill>
                   <a:srgbClr val="C08A2B"/>
                 </a:solidFill>
-                <a:latin typeface="Calibri"/>
+                <a:latin typeface="Times New Roman"/>
               </a:rPr>
               <a:t>PART 1  •  FRAMING</a:t>
             </a:r>
@@ -3917,7 +3917,7 @@
                 <a:solidFill>
                   <a:srgbClr val="FFFFFF"/>
                 </a:solidFill>
-                <a:latin typeface="Calibri"/>
+                <a:latin typeface="Times New Roman"/>
               </a:rPr>
               <a:t>Why This Is an International Story</a:t>
             </a:r>
@@ -3959,7 +3959,7 @@
                 <a:solidFill>
                   <a:srgbClr val="0F2A43"/>
                 </a:solidFill>
-                <a:latin typeface="Calibri"/>
+                <a:latin typeface="Times New Roman"/>
               </a:rPr>
               <a:t>•  Who: </a:t>
             </a:r>
@@ -3968,7 +3968,7 @@
                 <a:solidFill>
                   <a:srgbClr val="334455"/>
                 </a:solidFill>
-                <a:latin typeface="Calibri"/>
+                <a:latin typeface="Times New Roman"/>
               </a:rPr>
               <a:t>Jeffrey Epstein, a financier whose network spanned multiple countries.</a:t>
             </a:r>
@@ -3987,7 +3987,7 @@
                 <a:solidFill>
                   <a:srgbClr val="0F2A43"/>
                 </a:solidFill>
-                <a:latin typeface="Calibri"/>
+                <a:latin typeface="Times New Roman"/>
               </a:rPr>
               <a:t>•  2008: </a:t>
             </a:r>
@@ -3996,7 +3996,7 @@
                 <a:solidFill>
                   <a:srgbClr val="334455"/>
                 </a:solidFill>
-                <a:latin typeface="Calibri"/>
+                <a:latin typeface="Times New Roman"/>
               </a:rPr>
               <a:t>A lenient Florida plea deal — state charges, limited accountability.</a:t>
             </a:r>
@@ -4015,7 +4015,7 @@
                 <a:solidFill>
                   <a:srgbClr val="0F2A43"/>
                 </a:solidFill>
-                <a:latin typeface="Calibri"/>
+                <a:latin typeface="Times New Roman"/>
               </a:rPr>
               <a:t>•  2019: </a:t>
             </a:r>
@@ -4024,7 +4024,7 @@
                 <a:solidFill>
                   <a:srgbClr val="334455"/>
                 </a:solidFill>
-                <a:latin typeface="Calibri"/>
+                <a:latin typeface="Times New Roman"/>
               </a:rPr>
               <a:t>Federal sex-trafficking charges in New York; Epstein died in custody.</a:t>
             </a:r>
@@ -4043,7 +4043,7 @@
                 <a:solidFill>
                   <a:srgbClr val="334455"/>
                 </a:solidFill>
-                <a:latin typeface="Calibri"/>
+                <a:latin typeface="Times New Roman"/>
               </a:rPr>
               <a:t>•  Cross-border recruitment of victims, including minors and foreign nationals.</a:t>
             </a:r>
@@ -4062,7 +4062,7 @@
                 <a:solidFill>
                   <a:srgbClr val="334455"/>
                 </a:solidFill>
-                <a:latin typeface="Calibri"/>
+                <a:latin typeface="Times New Roman"/>
               </a:rPr>
               <a:t>•  Offshore wealth and properties across the US, US Virgin Islands and Paris.</a:t>
             </a:r>
@@ -4081,7 +4081,7 @@
                 <a:solidFill>
                   <a:srgbClr val="334455"/>
                 </a:solidFill>
-                <a:latin typeface="Calibri"/>
+                <a:latin typeface="Times New Roman"/>
               </a:rPr>
               <a:t>•  A globe-spanning social network of internationally prominent figures.</a:t>
             </a:r>
@@ -4164,7 +4164,7 @@
                 <a:solidFill>
                   <a:srgbClr val="C08A2B"/>
                 </a:solidFill>
-                <a:latin typeface="Calibri"/>
+                <a:latin typeface="Times New Roman"/>
               </a:rPr>
               <a:t>WHY IT'S "INTERNATIONAL"</a:t>
             </a:r>
@@ -4206,7 +4206,7 @@
                 <a:solidFill>
                   <a:srgbClr val="334455"/>
                 </a:solidFill>
-                <a:latin typeface="Calibri"/>
+                <a:latin typeface="Times New Roman"/>
               </a:rPr>
               <a:t>•  Victims moved across borders</a:t>
             </a:r>
@@ -4225,7 +4225,7 @@
                 <a:solidFill>
                   <a:srgbClr val="334455"/>
                 </a:solidFill>
-                <a:latin typeface="Calibri"/>
+                <a:latin typeface="Times New Roman"/>
               </a:rPr>
               <a:t>•  Money held offshore</a:t>
             </a:r>
@@ -4244,7 +4244,7 @@
                 <a:solidFill>
                   <a:srgbClr val="334455"/>
                 </a:solidFill>
-                <a:latin typeface="Calibri"/>
+                <a:latin typeface="Times New Roman"/>
               </a:rPr>
               <a:t>•  Multiple jurisdictions involved</a:t>
             </a:r>
@@ -4263,7 +4263,7 @@
                 <a:solidFill>
                   <a:srgbClr val="334455"/>
                 </a:solidFill>
-                <a:latin typeface="Calibri"/>
+                <a:latin typeface="Times New Roman"/>
               </a:rPr>
               <a:t>•  Foreign &amp; quasi-diplomatic figures</a:t>
             </a:r>
@@ -4282,7 +4282,7 @@
                 <a:solidFill>
                   <a:srgbClr val="334455"/>
                 </a:solidFill>
-                <a:latin typeface="Calibri"/>
+                <a:latin typeface="Times New Roman"/>
               </a:rPr>
               <a:t>•  → A test for international justice</a:t>
             </a:r>
@@ -4435,7 +4435,7 @@
                 <a:solidFill>
                   <a:srgbClr val="C08A2B"/>
                 </a:solidFill>
-                <a:latin typeface="Calibri"/>
+                <a:latin typeface="Times New Roman"/>
               </a:rPr>
               <a:t>PART 2  •  LEGAL FRAMEWORK</a:t>
             </a:r>
@@ -4474,7 +4474,7 @@
                 <a:solidFill>
                   <a:srgbClr val="FFFFFF"/>
                 </a:solidFill>
-                <a:latin typeface="Calibri"/>
+                <a:latin typeface="Times New Roman"/>
               </a:rPr>
               <a:t>Trafficking as a Transnational Crime</a:t>
             </a:r>
@@ -4516,7 +4516,7 @@
                 <a:solidFill>
                   <a:srgbClr val="0F2A43"/>
                 </a:solidFill>
-                <a:latin typeface="Calibri"/>
+                <a:latin typeface="Times New Roman"/>
               </a:rPr>
               <a:t>•  UN Palermo Protocol (2000): </a:t>
             </a:r>
@@ -4525,7 +4525,7 @@
                 <a:solidFill>
                   <a:srgbClr val="334455"/>
                 </a:solidFill>
-                <a:latin typeface="Calibri"/>
+                <a:latin typeface="Times New Roman"/>
               </a:rPr>
               <a:t>Defines trafficking in persons and obliges states to criminalise it.</a:t>
             </a:r>
@@ -4544,7 +4544,7 @@
                 <a:solidFill>
                   <a:srgbClr val="0F2A43"/>
                 </a:solidFill>
-                <a:latin typeface="Calibri"/>
+                <a:latin typeface="Times New Roman"/>
               </a:rPr>
               <a:t>•  UN Convention against Transnational Organized Crime (UNTOC): </a:t>
             </a:r>
@@ -4553,7 +4553,7 @@
                 <a:solidFill>
                   <a:srgbClr val="334455"/>
                 </a:solidFill>
-                <a:latin typeface="Calibri"/>
+                <a:latin typeface="Times New Roman"/>
               </a:rPr>
               <a:t>The parent framework for cooperation.</a:t>
             </a:r>
@@ -4572,7 +4572,7 @@
                 <a:solidFill>
                   <a:srgbClr val="0F2A43"/>
                 </a:solidFill>
-                <a:latin typeface="Calibri"/>
+                <a:latin typeface="Times New Roman"/>
               </a:rPr>
               <a:t>•  Jurisdiction: </a:t>
             </a:r>
@@ -4581,7 +4581,7 @@
                 <a:solidFill>
                   <a:srgbClr val="334455"/>
                 </a:solidFill>
-                <a:latin typeface="Calibri"/>
+                <a:latin typeface="Times New Roman"/>
               </a:rPr>
               <a:t>Which state may prosecute when conduct spans several countries?</a:t>
             </a:r>
@@ -4600,7 +4600,7 @@
                 <a:solidFill>
                   <a:srgbClr val="0F2A43"/>
                 </a:solidFill>
-                <a:latin typeface="Calibri"/>
+                <a:latin typeface="Times New Roman"/>
               </a:rPr>
               <a:t>•  Extradition &amp; MLATs: </a:t>
             </a:r>
@@ -4609,7 +4609,7 @@
                 <a:solidFill>
                   <a:srgbClr val="334455"/>
                 </a:solidFill>
-                <a:latin typeface="Calibri"/>
+                <a:latin typeface="Times New Roman"/>
               </a:rPr>
               <a:t>Mutual Legal Assistance Treaties enable evidence-sharing across borders.</a:t>
             </a:r>
@@ -4628,7 +4628,7 @@
                 <a:solidFill>
                   <a:srgbClr val="0F2A43"/>
                 </a:solidFill>
-                <a:latin typeface="Calibri"/>
+                <a:latin typeface="Times New Roman"/>
               </a:rPr>
               <a:t>•  Foreign nationals: </a:t>
             </a:r>
@@ -4637,7 +4637,7 @@
                 <a:solidFill>
                   <a:srgbClr val="334455"/>
                 </a:solidFill>
-                <a:latin typeface="Calibri"/>
+                <a:latin typeface="Times New Roman"/>
               </a:rPr>
               <a:t>Ghislaine Maxwell (UK) — convicted 2021 of sex-trafficking conspiracy.</a:t>
             </a:r>
@@ -4656,7 +4656,7 @@
                 <a:solidFill>
                   <a:srgbClr val="0F2A43"/>
                 </a:solidFill>
-                <a:latin typeface="Calibri"/>
+                <a:latin typeface="Times New Roman"/>
               </a:rPr>
               <a:t>•  Quasi-diplomatic complications: </a:t>
             </a:r>
@@ -4665,7 +4665,7 @@
                 <a:solidFill>
                   <a:srgbClr val="334455"/>
                 </a:solidFill>
-                <a:latin typeface="Calibri"/>
+                <a:latin typeface="Times New Roman"/>
               </a:rPr>
               <a:t>Prince Andrew settled a US civil case (2022) and later lost titles.</a:t>
             </a:r>
@@ -4704,7 +4704,7 @@
                 <a:solidFill>
                   <a:srgbClr val="0F2A43"/>
                 </a:solidFill>
-                <a:latin typeface="Calibri"/>
+                <a:latin typeface="Times New Roman"/>
               </a:rPr>
               <a:t>Takeaway: The law exists — the difficulty is coordinating sovereign systems.</a:t>
             </a:r>
@@ -4857,7 +4857,7 @@
                 <a:solidFill>
                   <a:srgbClr val="C08A2B"/>
                 </a:solidFill>
-                <a:latin typeface="Calibri"/>
+                <a:latin typeface="Times New Roman"/>
               </a:rPr>
               <a:t>PART 3  •  WEALTH &amp; MOBILITY</a:t>
             </a:r>
@@ -4896,7 +4896,7 @@
                 <a:solidFill>
                   <a:srgbClr val="FFFFFF"/>
                 </a:solidFill>
-                <a:latin typeface="Calibri"/>
+                <a:latin typeface="Times New Roman"/>
               </a:rPr>
               <a:t>How Wealth Enabled "Elite Impunity"</a:t>
             </a:r>
@@ -4938,7 +4938,7 @@
                 <a:solidFill>
                   <a:srgbClr val="334455"/>
                 </a:solidFill>
-                <a:latin typeface="Calibri"/>
+                <a:latin typeface="Times New Roman"/>
               </a:rPr>
               <a:t>•  Offshore structures and private wealth obscured assets and ownership.</a:t>
             </a:r>
@@ -4957,7 +4957,7 @@
                 <a:solidFill>
                   <a:srgbClr val="334455"/>
                 </a:solidFill>
-                <a:latin typeface="Calibri"/>
+                <a:latin typeface="Times New Roman"/>
               </a:rPr>
               <a:t>•  Property in several jurisdictions enabled mobility and evasion.</a:t>
             </a:r>
@@ -4976,7 +4976,7 @@
                 <a:solidFill>
                   <a:srgbClr val="0F2A43"/>
                 </a:solidFill>
-                <a:latin typeface="Calibri"/>
+                <a:latin typeface="Times New Roman"/>
               </a:rPr>
               <a:t>•  Identity documents: </a:t>
             </a:r>
@@ -4985,7 +4985,7 @@
                 <a:solidFill>
                   <a:srgbClr val="334455"/>
                 </a:solidFill>
-                <a:latin typeface="Calibri"/>
+                <a:latin typeface="Times New Roman"/>
               </a:rPr>
               <a:t>an expired passport bore Epstein's photo, a false name, and listed Saudi Arabia as residence.</a:t>
             </a:r>
@@ -5004,7 +5004,7 @@
                 <a:solidFill>
                   <a:srgbClr val="0F2A43"/>
                 </a:solidFill>
-                <a:latin typeface="Calibri"/>
+                <a:latin typeface="Times New Roman"/>
               </a:rPr>
               <a:t>•  Contrast: </a:t>
             </a:r>
@@ -5013,7 +5013,7 @@
                 <a:solidFill>
                   <a:srgbClr val="334455"/>
                 </a:solidFill>
-                <a:latin typeface="Calibri"/>
+                <a:latin typeface="Times New Roman"/>
               </a:rPr>
               <a:t>the lenient 2008 outcome vs. the 2019 federal prosecution.</a:t>
             </a:r>
@@ -5032,7 +5032,7 @@
                 <a:solidFill>
                   <a:srgbClr val="334455"/>
                 </a:solidFill>
-                <a:latin typeface="Calibri"/>
+                <a:latin typeface="Times New Roman"/>
               </a:rPr>
               <a:t>•  Maxwell's 2021 conviction showed accountability is possible — but slow.</a:t>
             </a:r>
@@ -5115,7 +5115,7 @@
                 <a:solidFill>
                   <a:srgbClr val="C08A2B"/>
                 </a:solidFill>
-                <a:latin typeface="Calibri"/>
+                <a:latin typeface="Times New Roman"/>
               </a:rPr>
               <a:t>COMPARATIVE QUESTION</a:t>
             </a:r>
@@ -5154,7 +5154,7 @@
                 <a:solidFill>
                   <a:srgbClr val="334455"/>
                 </a:solidFill>
-                <a:latin typeface="Calibri"/>
+                <a:latin typeface="Times New Roman"/>
               </a:rPr>
               <a:t>Would other legal systems — the UK, France, or Japan — have acted faster, or slower, against a defendant of comparable wealth and mobility?</a:t>
             </a:r>
@@ -5307,7 +5307,7 @@
                 <a:solidFill>
                   <a:srgbClr val="C08A2B"/>
                 </a:solidFill>
-                <a:latin typeface="Calibri"/>
+                <a:latin typeface="Times New Roman"/>
               </a:rPr>
               <a:t>PART 4  •  ACCOUNTABILITY</a:t>
             </a:r>
@@ -5346,7 +5346,7 @@
                 <a:solidFill>
                   <a:srgbClr val="FFFFFF"/>
                 </a:solidFill>
-                <a:latin typeface="Calibri"/>
+                <a:latin typeface="Times New Roman"/>
               </a:rPr>
               <a:t>Transparency, Survivors &amp; Lessons</a:t>
             </a:r>
@@ -5388,7 +5388,7 @@
                 <a:solidFill>
                   <a:srgbClr val="334455"/>
                 </a:solidFill>
-                <a:latin typeface="Calibri"/>
+                <a:latin typeface="Times New Roman"/>
               </a:rPr>
               <a:t>•  2025 document-release wave under US transparency legislation brought new scrutiny.</a:t>
             </a:r>
@@ -5407,7 +5407,7 @@
                 <a:solidFill>
                   <a:srgbClr val="0F2A43"/>
                 </a:solidFill>
-                <a:latin typeface="Calibri"/>
+                <a:latin typeface="Times New Roman"/>
               </a:rPr>
               <a:t>•  Survivors' concern: </a:t>
             </a:r>
@@ -5416,7 +5416,7 @@
                 <a:solidFill>
                   <a:srgbClr val="334455"/>
                 </a:solidFill>
-                <a:latin typeface="Calibri"/>
+                <a:latin typeface="Times New Roman"/>
               </a:rPr>
               <a:t>disclosures made it easy to identify victims — but not the enablers.</a:t>
             </a:r>
@@ -5435,7 +5435,7 @@
                 <a:solidFill>
                   <a:srgbClr val="0F2A43"/>
                 </a:solidFill>
-                <a:latin typeface="Calibri"/>
+                <a:latin typeface="Times New Roman"/>
               </a:rPr>
               <a:t>•  Lesson: </a:t>
             </a:r>
@@ -5444,7 +5444,7 @@
                 <a:solidFill>
                   <a:srgbClr val="334455"/>
                 </a:solidFill>
-                <a:latin typeface="Calibri"/>
+                <a:latin typeface="Times New Roman"/>
               </a:rPr>
               <a:t>transparency must be designed to protect victims while exposing accountability.</a:t>
             </a:r>
@@ -5463,7 +5463,7 @@
                 <a:solidFill>
                   <a:srgbClr val="0F2A43"/>
                 </a:solidFill>
-                <a:latin typeface="Calibri"/>
+                <a:latin typeface="Times New Roman"/>
               </a:rPr>
               <a:t>•  Reform: </a:t>
             </a:r>
@@ -5472,7 +5472,7 @@
                 <a:solidFill>
                   <a:srgbClr val="334455"/>
                 </a:solidFill>
-                <a:latin typeface="Calibri"/>
+                <a:latin typeface="Times New Roman"/>
               </a:rPr>
               <a:t>stronger MLATs, faster extradition, victim-centred disclosure, asset tracing.</a:t>
             </a:r>
@@ -5491,7 +5491,7 @@
                 <a:solidFill>
                   <a:srgbClr val="0F2A43"/>
                 </a:solidFill>
-                <a:latin typeface="Calibri"/>
+                <a:latin typeface="Times New Roman"/>
               </a:rPr>
               <a:t>•  Japan comparison: </a:t>
             </a:r>
@@ -5500,7 +5500,7 @@
                 <a:solidFill>
                   <a:srgbClr val="334455"/>
                 </a:solidFill>
-                <a:latin typeface="Calibri"/>
+                <a:latin typeface="Times New Roman"/>
               </a:rPr>
               <a:t>anti-trafficking framework &amp; US State Dept. TIP assessments offer a benchmark.</a:t>
             </a:r>
@@ -5583,7 +5583,7 @@
                 <a:solidFill>
                   <a:srgbClr val="FFFFFF"/>
                 </a:solidFill>
-                <a:latin typeface="Calibri"/>
+                <a:latin typeface="Times New Roman"/>
               </a:rPr>
               <a:t>Closing: Justice across borders depends less on new laws than on the will to cooperate.</a:t>
             </a:r>
@@ -5736,7 +5736,7 @@
                 <a:solidFill>
                   <a:srgbClr val="C08A2B"/>
                 </a:solidFill>
-                <a:latin typeface="Calibri"/>
+                <a:latin typeface="Times New Roman"/>
               </a:rPr>
               <a:t>CONCLUSION</a:t>
             </a:r>
@@ -5775,7 +5775,7 @@
                 <a:solidFill>
                   <a:srgbClr val="FFFFFF"/>
                 </a:solidFill>
-                <a:latin typeface="Calibri"/>
+                <a:latin typeface="Times New Roman"/>
               </a:rPr>
               <a:t>Four Takeaways</a:t>
             </a:r>
@@ -5858,7 +5858,7 @@
                 <a:solidFill>
                   <a:srgbClr val="FFFFFF"/>
                 </a:solidFill>
-                <a:latin typeface="Calibri"/>
+                <a:latin typeface="Times New Roman"/>
               </a:rPr>
               <a:t>01</a:t>
             </a:r>
@@ -5897,7 +5897,7 @@
                 <a:solidFill>
                   <a:srgbClr val="0F2A43"/>
                 </a:solidFill>
-                <a:latin typeface="Calibri"/>
+                <a:latin typeface="Times New Roman"/>
               </a:rPr>
               <a:t>Crime crosses borders — justice often doesn't.</a:t>
             </a:r>
@@ -5936,7 +5936,7 @@
                 <a:solidFill>
                   <a:srgbClr val="334455"/>
                 </a:solidFill>
-                <a:latin typeface="Calibri"/>
+                <a:latin typeface="Times New Roman"/>
               </a:rPr>
               <a:t>Networks are global; enforcement is national.</a:t>
             </a:r>
@@ -6019,7 +6019,7 @@
                 <a:solidFill>
                   <a:srgbClr val="FFFFFF"/>
                 </a:solidFill>
-                <a:latin typeface="Calibri"/>
+                <a:latin typeface="Times New Roman"/>
               </a:rPr>
               <a:t>02</a:t>
             </a:r>
@@ -6058,7 +6058,7 @@
                 <a:solidFill>
                   <a:srgbClr val="0F2A43"/>
                 </a:solidFill>
-                <a:latin typeface="Calibri"/>
+                <a:latin typeface="Times New Roman"/>
               </a:rPr>
               <a:t>The legal tools exist.</a:t>
             </a:r>
@@ -6097,7 +6097,7 @@
                 <a:solidFill>
                   <a:srgbClr val="334455"/>
                 </a:solidFill>
-                <a:latin typeface="Calibri"/>
+                <a:latin typeface="Times New Roman"/>
               </a:rPr>
               <a:t>Palermo &amp; UNTOC provide the framework; coordination is the gap.</a:t>
             </a:r>
@@ -6180,7 +6180,7 @@
                 <a:solidFill>
                   <a:srgbClr val="FFFFFF"/>
                 </a:solidFill>
-                <a:latin typeface="Calibri"/>
+                <a:latin typeface="Times New Roman"/>
               </a:rPr>
               <a:t>03</a:t>
             </a:r>
@@ -6219,7 +6219,7 @@
                 <a:solidFill>
                   <a:srgbClr val="0F2A43"/>
                 </a:solidFill>
-                <a:latin typeface="Calibri"/>
+                <a:latin typeface="Times New Roman"/>
               </a:rPr>
               <a:t>Wealth buys time, not immunity.</a:t>
             </a:r>
@@ -6258,7 +6258,7 @@
                 <a:solidFill>
                   <a:srgbClr val="334455"/>
                 </a:solidFill>
-                <a:latin typeface="Calibri"/>
+                <a:latin typeface="Times New Roman"/>
               </a:rPr>
               <a:t>Mobility delayed — but did not prevent — accountability.</a:t>
             </a:r>
@@ -6341,7 +6341,7 @@
                 <a:solidFill>
                   <a:srgbClr val="FFFFFF"/>
                 </a:solidFill>
-                <a:latin typeface="Calibri"/>
+                <a:latin typeface="Times New Roman"/>
               </a:rPr>
               <a:t>04</a:t>
             </a:r>
@@ -6380,7 +6380,7 @@
                 <a:solidFill>
                   <a:srgbClr val="0F2A43"/>
                 </a:solidFill>
-                <a:latin typeface="Calibri"/>
+                <a:latin typeface="Times New Roman"/>
               </a:rPr>
               <a:t>Transparency must protect victims.</a:t>
             </a:r>
@@ -6419,7 +6419,7 @@
                 <a:solidFill>
                   <a:srgbClr val="334455"/>
                 </a:solidFill>
-                <a:latin typeface="Calibri"/>
+                <a:latin typeface="Times New Roman"/>
               </a:rPr>
               <a:t>Disclosure should expose enablers, not endanger survivors.</a:t>
             </a:r>
@@ -6528,7 +6528,7 @@
                 <a:solidFill>
                   <a:srgbClr val="FFFFFF"/>
                 </a:solidFill>
-                <a:latin typeface="Calibri"/>
+                <a:latin typeface="Times New Roman"/>
               </a:rPr>
               <a:t>Thank You</a:t>
             </a:r>
@@ -6567,7 +6567,7 @@
                 <a:solidFill>
                   <a:srgbClr val="F2F4F7"/>
                 </a:solidFill>
-                <a:latin typeface="Calibri"/>
+                <a:latin typeface="Times New Roman"/>
               </a:rPr>
               <a:t>Questions &amp; Discussion</a:t>
             </a:r>
@@ -6606,7 +6606,7 @@
                 <a:solidFill>
                   <a:srgbClr val="C08A2B"/>
                 </a:solidFill>
-                <a:latin typeface="Calibri"/>
+                <a:latin typeface="Times New Roman"/>
               </a:rPr>
               <a:t>SELECTED SOURCES &amp; INSTRUMENTS</a:t>
             </a:r>
@@ -6648,7 +6648,7 @@
                 <a:solidFill>
                   <a:srgbClr val="F2F4F7"/>
                 </a:solidFill>
-                <a:latin typeface="Calibri"/>
+                <a:latin typeface="Times New Roman"/>
               </a:rPr>
               <a:t>•  UN Protocol to Prevent, Suppress and Punish Trafficking in Persons (Palermo Protocol, 2000)</a:t>
             </a:r>
@@ -6667,7 +6667,7 @@
                 <a:solidFill>
                   <a:srgbClr val="F2F4F7"/>
                 </a:solidFill>
-                <a:latin typeface="Calibri"/>
+                <a:latin typeface="Times New Roman"/>
               </a:rPr>
               <a:t>•  UN Convention against Transnational Organized Crime (UNTOC)</a:t>
             </a:r>
@@ -6686,7 +6686,7 @@
                 <a:solidFill>
                   <a:srgbClr val="F2F4F7"/>
                 </a:solidFill>
-                <a:latin typeface="Calibri"/>
+                <a:latin typeface="Times New Roman"/>
               </a:rPr>
               <a:t>•  US Dept. of Justice filings: US v. Epstein (2019); US v. Maxwell (2021)</a:t>
             </a:r>
@@ -6705,7 +6705,7 @@
                 <a:solidFill>
                   <a:srgbClr val="F2F4F7"/>
                 </a:solidFill>
-                <a:latin typeface="Calibri"/>
+                <a:latin typeface="Times New Roman"/>
               </a:rPr>
               <a:t>•  US State Department Trafficking in Persons (TIP) Reports</a:t>
             </a:r>
@@ -6724,7 +6724,7 @@
                 <a:solidFill>
                   <a:srgbClr val="F2F4F7"/>
                 </a:solidFill>
-                <a:latin typeface="Calibri"/>
+                <a:latin typeface="Times New Roman"/>
               </a:rPr>
               <a:t>•  Contemporary news reporting on 2025 document disclosures</a:t>
             </a:r>

</xml_diff>

<commit_message>
Enlarge all text ~10% via global font scale
</commit_message>
<xml_diff>
--- a/Epstein_Transnational_Justice.pptx
+++ b/Epstein_Transnational_Justice.pptx
@@ -3231,7 +3231,7 @@
               </a:lnSpc>
             </a:pPr>
             <a:r>
-              <a:rPr sz="1600" b="1" i="0">
+              <a:rPr sz="1760" b="1" i="0">
                 <a:solidFill>
                   <a:srgbClr val="C08A2B"/>
                 </a:solidFill>
@@ -3270,7 +3270,7 @@
               </a:lnSpc>
             </a:pPr>
             <a:r>
-              <a:rPr sz="4000" b="1" i="0">
+              <a:rPr sz="4400" b="1" i="0">
                 <a:solidFill>
                   <a:srgbClr val="FFFFFF"/>
                 </a:solidFill>
@@ -3353,7 +3353,7 @@
               </a:lnSpc>
             </a:pPr>
             <a:r>
-              <a:rPr sz="1800" b="0" i="1">
+              <a:rPr sz="1980" b="0" i="1">
                 <a:solidFill>
                   <a:srgbClr val="F2F4F7"/>
                 </a:solidFill>
@@ -3392,7 +3392,7 @@
               </a:lnSpc>
             </a:pPr>
             <a:r>
-              <a:rPr sz="1300" b="0" i="0">
+              <a:rPr sz="1430" b="0" i="0">
                 <a:solidFill>
                   <a:srgbClr val="909CAA"/>
                 </a:solidFill>
@@ -3545,7 +3545,7 @@
               </a:lnSpc>
             </a:pPr>
             <a:r>
-              <a:rPr sz="1300" b="1" i="0">
+              <a:rPr sz="1430" b="1" i="0">
                 <a:solidFill>
                   <a:srgbClr val="C08A2B"/>
                 </a:solidFill>
@@ -3584,7 +3584,7 @@
               </a:lnSpc>
             </a:pPr>
             <a:r>
-              <a:rPr sz="2600" b="1" i="0">
+              <a:rPr sz="2860" b="1" i="0">
                 <a:solidFill>
                   <a:srgbClr val="FFFFFF"/>
                 </a:solidFill>
@@ -3626,7 +3626,7 @@
               </a:spcAft>
             </a:pPr>
             <a:r>
-              <a:rPr sz="1900" b="1">
+              <a:rPr sz="2090" b="1">
                 <a:solidFill>
                   <a:srgbClr val="0F2A43"/>
                 </a:solidFill>
@@ -3635,7 +3635,7 @@
               <a:t>•  Parent treaty: </a:t>
             </a:r>
             <a:r>
-              <a:rPr sz="1900">
+              <a:rPr sz="2090">
                 <a:solidFill>
                   <a:srgbClr val="334455"/>
                 </a:solidFill>
@@ -3654,7 +3654,7 @@
               </a:spcAft>
             </a:pPr>
             <a:r>
-              <a:rPr sz="1900">
+              <a:rPr sz="2090">
                 <a:solidFill>
                   <a:srgbClr val="334455"/>
                 </a:solidFill>
@@ -3673,7 +3673,7 @@
               </a:spcAft>
             </a:pPr>
             <a:r>
-              <a:rPr sz="1900">
+              <a:rPr sz="2090">
                 <a:solidFill>
                   <a:srgbClr val="334455"/>
                 </a:solidFill>
@@ -3692,7 +3692,7 @@
               </a:spcAft>
             </a:pPr>
             <a:r>
-              <a:rPr sz="1900">
+              <a:rPr sz="2090">
                 <a:solidFill>
                   <a:srgbClr val="334455"/>
                 </a:solidFill>
@@ -3711,7 +3711,7 @@
               </a:spcAft>
             </a:pPr>
             <a:r>
-              <a:rPr sz="1900">
+              <a:rPr sz="2090">
                 <a:solidFill>
                   <a:srgbClr val="334455"/>
                 </a:solidFill>
@@ -3838,7 +3838,7 @@
               </a:lnSpc>
             </a:pPr>
             <a:r>
-              <a:rPr sz="1500" b="0" i="1">
+              <a:rPr sz="1650" b="0" i="1">
                 <a:solidFill>
                   <a:srgbClr val="0F2A43"/>
                 </a:solidFill>
@@ -3921,7 +3921,7 @@
               </a:lnSpc>
             </a:pPr>
             <a:r>
-              <a:rPr sz="1100" b="0" i="0">
+              <a:rPr sz="1210" b="0" i="0">
                 <a:solidFill>
                   <a:srgbClr val="6B7682"/>
                 </a:solidFill>
@@ -4074,7 +4074,7 @@
               </a:lnSpc>
             </a:pPr>
             <a:r>
-              <a:rPr sz="1300" b="1" i="0">
+              <a:rPr sz="1430" b="1" i="0">
                 <a:solidFill>
                   <a:srgbClr val="C08A2B"/>
                 </a:solidFill>
@@ -4113,7 +4113,7 @@
               </a:lnSpc>
             </a:pPr>
             <a:r>
-              <a:rPr sz="2600" b="1" i="0">
+              <a:rPr sz="2860" b="1" i="0">
                 <a:solidFill>
                   <a:srgbClr val="FFFFFF"/>
                 </a:solidFill>
@@ -4155,7 +4155,7 @@
               </a:spcAft>
             </a:pPr>
             <a:r>
-              <a:rPr sz="1900" b="1">
+              <a:rPr sz="2090" b="1">
                 <a:solidFill>
                   <a:srgbClr val="0F2A43"/>
                 </a:solidFill>
@@ -4164,7 +4164,7 @@
               <a:t>•  Jurisdiction: </a:t>
             </a:r>
             <a:r>
-              <a:rPr sz="1900">
+              <a:rPr sz="2090">
                 <a:solidFill>
                   <a:srgbClr val="334455"/>
                 </a:solidFill>
@@ -4183,7 +4183,7 @@
               </a:spcAft>
             </a:pPr>
             <a:r>
-              <a:rPr sz="1900" b="1">
+              <a:rPr sz="2090" b="1">
                 <a:solidFill>
                   <a:srgbClr val="0F2A43"/>
                 </a:solidFill>
@@ -4192,7 +4192,7 @@
               <a:t>•  Concurrent claims: </a:t>
             </a:r>
             <a:r>
-              <a:rPr sz="1900">
+              <a:rPr sz="2090">
                 <a:solidFill>
                   <a:srgbClr val="334455"/>
                 </a:solidFill>
@@ -4211,7 +4211,7 @@
               </a:spcAft>
             </a:pPr>
             <a:r>
-              <a:rPr sz="1900" b="1">
+              <a:rPr sz="2090" b="1">
                 <a:solidFill>
                   <a:srgbClr val="0F2A43"/>
                 </a:solidFill>
@@ -4220,7 +4220,7 @@
               <a:t>•  Extradition: </a:t>
             </a:r>
             <a:r>
-              <a:rPr sz="1900">
+              <a:rPr sz="2090">
                 <a:solidFill>
                   <a:srgbClr val="334455"/>
                 </a:solidFill>
@@ -4239,7 +4239,7 @@
               </a:spcAft>
             </a:pPr>
             <a:r>
-              <a:rPr sz="1900" b="1">
+              <a:rPr sz="2090" b="1">
                 <a:solidFill>
                   <a:srgbClr val="0F2A43"/>
                 </a:solidFill>
@@ -4248,7 +4248,7 @@
               <a:t>•  MLATs: </a:t>
             </a:r>
             <a:r>
-              <a:rPr sz="1900">
+              <a:rPr sz="2090">
                 <a:solidFill>
                   <a:srgbClr val="334455"/>
                 </a:solidFill>
@@ -4267,7 +4267,7 @@
               </a:spcAft>
             </a:pPr>
             <a:r>
-              <a:rPr sz="1900" b="1">
+              <a:rPr sz="2090" b="1">
                 <a:solidFill>
                   <a:srgbClr val="0F2A43"/>
                 </a:solidFill>
@@ -4276,7 +4276,7 @@
               <a:t>•  The friction: </a:t>
             </a:r>
             <a:r>
-              <a:rPr sz="1900">
+              <a:rPr sz="2090">
                 <a:solidFill>
                   <a:srgbClr val="334455"/>
                 </a:solidFill>
@@ -4403,7 +4403,7 @@
               </a:lnSpc>
             </a:pPr>
             <a:r>
-              <a:rPr sz="1500" b="0" i="1">
+              <a:rPr sz="1650" b="0" i="1">
                 <a:solidFill>
                   <a:srgbClr val="0F2A43"/>
                 </a:solidFill>
@@ -4486,7 +4486,7 @@
               </a:lnSpc>
             </a:pPr>
             <a:r>
-              <a:rPr sz="1100" b="0" i="0">
+              <a:rPr sz="1210" b="0" i="0">
                 <a:solidFill>
                   <a:srgbClr val="6B7682"/>
                 </a:solidFill>
@@ -4639,7 +4639,7 @@
               </a:lnSpc>
             </a:pPr>
             <a:r>
-              <a:rPr sz="1300" b="1" i="0">
+              <a:rPr sz="1430" b="1" i="0">
                 <a:solidFill>
                   <a:srgbClr val="C08A2B"/>
                 </a:solidFill>
@@ -4678,7 +4678,7 @@
               </a:lnSpc>
             </a:pPr>
             <a:r>
-              <a:rPr sz="2600" b="1" i="0">
+              <a:rPr sz="2860" b="1" i="0">
                 <a:solidFill>
                   <a:srgbClr val="FFFFFF"/>
                 </a:solidFill>
@@ -4720,7 +4720,7 @@
               </a:spcAft>
             </a:pPr>
             <a:r>
-              <a:rPr sz="1900" b="1">
+              <a:rPr sz="2090" b="1">
                 <a:solidFill>
                   <a:srgbClr val="0F2A43"/>
                 </a:solidFill>
@@ -4729,7 +4729,7 @@
               <a:t>•  Ghislaine Maxwell (UK): </a:t>
             </a:r>
             <a:r>
-              <a:rPr sz="1900">
+              <a:rPr sz="2090">
                 <a:solidFill>
                   <a:srgbClr val="334455"/>
                 </a:solidFill>
@@ -4748,7 +4748,7 @@
               </a:spcAft>
             </a:pPr>
             <a:r>
-              <a:rPr sz="1900" b="1">
+              <a:rPr sz="2090" b="1">
                 <a:solidFill>
                   <a:srgbClr val="0F2A43"/>
                 </a:solidFill>
@@ -4757,7 +4757,7 @@
               <a:t>•  Prince Andrew: </a:t>
             </a:r>
             <a:r>
-              <a:rPr sz="1900">
+              <a:rPr sz="2090">
                 <a:solidFill>
                   <a:srgbClr val="334455"/>
                 </a:solidFill>
@@ -4776,7 +4776,7 @@
               </a:spcAft>
             </a:pPr>
             <a:r>
-              <a:rPr sz="1900">
+              <a:rPr sz="2090">
                 <a:solidFill>
                   <a:srgbClr val="334455"/>
                 </a:solidFill>
@@ -4795,7 +4795,7 @@
               </a:spcAft>
             </a:pPr>
             <a:r>
-              <a:rPr sz="1900">
+              <a:rPr sz="2090">
                 <a:solidFill>
                   <a:srgbClr val="334455"/>
                 </a:solidFill>
@@ -4922,7 +4922,7 @@
               </a:lnSpc>
             </a:pPr>
             <a:r>
-              <a:rPr sz="1500" b="0" i="1">
+              <a:rPr sz="1650" b="0" i="1">
                 <a:solidFill>
                   <a:srgbClr val="0F2A43"/>
                 </a:solidFill>
@@ -5005,7 +5005,7 @@
               </a:lnSpc>
             </a:pPr>
             <a:r>
-              <a:rPr sz="1100" b="0" i="0">
+              <a:rPr sz="1210" b="0" i="0">
                 <a:solidFill>
                   <a:srgbClr val="6B7682"/>
                 </a:solidFill>
@@ -5070,7 +5070,7 @@
               </a:lnSpc>
             </a:pPr>
             <a:r>
-              <a:rPr sz="21000" b="1" i="0">
+              <a:rPr sz="23100" b="1" i="0">
                 <a:solidFill>
                   <a:srgbClr val="1C3A56"/>
                 </a:solidFill>
@@ -5109,7 +5109,7 @@
               </a:lnSpc>
             </a:pPr>
             <a:r>
-              <a:rPr sz="1300" b="1" i="0">
+              <a:rPr sz="1430" b="1" i="0">
                 <a:solidFill>
                   <a:srgbClr val="C08A2B"/>
                 </a:solidFill>
@@ -5192,7 +5192,7 @@
               </a:lnSpc>
             </a:pPr>
             <a:r>
-              <a:rPr sz="3300" b="1" i="0">
+              <a:rPr sz="3630" b="1" i="0">
                 <a:solidFill>
                   <a:srgbClr val="FFFFFF"/>
                 </a:solidFill>
@@ -5208,7 +5208,7 @@
               </a:lnSpc>
             </a:pPr>
             <a:r>
-              <a:rPr sz="3300" b="1" i="0">
+              <a:rPr sz="3630" b="1" i="0">
                 <a:solidFill>
                   <a:srgbClr val="FFFFFF"/>
                 </a:solidFill>
@@ -5247,7 +5247,7 @@
               </a:lnSpc>
             </a:pPr>
             <a:r>
-              <a:rPr sz="1800" b="0" i="1">
+              <a:rPr sz="1980" b="0" i="1">
                 <a:solidFill>
                   <a:srgbClr val="F2F4F7"/>
                 </a:solidFill>
@@ -5330,7 +5330,7 @@
               </a:lnSpc>
             </a:pPr>
             <a:r>
-              <a:rPr sz="1100" b="0" i="0">
+              <a:rPr sz="1210" b="0" i="0">
                 <a:solidFill>
                   <a:srgbClr val="909CAA"/>
                 </a:solidFill>
@@ -5483,7 +5483,7 @@
               </a:lnSpc>
             </a:pPr>
             <a:r>
-              <a:rPr sz="1300" b="1" i="0">
+              <a:rPr sz="1430" b="1" i="0">
                 <a:solidFill>
                   <a:srgbClr val="C08A2B"/>
                 </a:solidFill>
@@ -5522,7 +5522,7 @@
               </a:lnSpc>
             </a:pPr>
             <a:r>
-              <a:rPr sz="2600" b="1" i="0">
+              <a:rPr sz="2860" b="1" i="0">
                 <a:solidFill>
                   <a:srgbClr val="FFFFFF"/>
                 </a:solidFill>
@@ -5564,7 +5564,7 @@
               </a:spcAft>
             </a:pPr>
             <a:r>
-              <a:rPr sz="1900">
+              <a:rPr sz="2090">
                 <a:solidFill>
                   <a:srgbClr val="334455"/>
                 </a:solidFill>
@@ -5583,7 +5583,7 @@
               </a:spcAft>
             </a:pPr>
             <a:r>
-              <a:rPr sz="1900">
+              <a:rPr sz="2090">
                 <a:solidFill>
                   <a:srgbClr val="334455"/>
                 </a:solidFill>
@@ -5602,7 +5602,7 @@
               </a:spcAft>
             </a:pPr>
             <a:r>
-              <a:rPr sz="1900">
+              <a:rPr sz="2090">
                 <a:solidFill>
                   <a:srgbClr val="334455"/>
                 </a:solidFill>
@@ -5621,7 +5621,7 @@
               </a:spcAft>
             </a:pPr>
             <a:r>
-              <a:rPr sz="1900">
+              <a:rPr sz="2090">
                 <a:solidFill>
                   <a:srgbClr val="334455"/>
                 </a:solidFill>
@@ -5640,7 +5640,7 @@
               </a:spcAft>
             </a:pPr>
             <a:r>
-              <a:rPr sz="1900">
+              <a:rPr sz="2090">
                 <a:solidFill>
                   <a:srgbClr val="334455"/>
                 </a:solidFill>
@@ -5767,7 +5767,7 @@
               </a:lnSpc>
             </a:pPr>
             <a:r>
-              <a:rPr sz="1500" b="0" i="1">
+              <a:rPr sz="1650" b="0" i="1">
                 <a:solidFill>
                   <a:srgbClr val="0F2A43"/>
                 </a:solidFill>
@@ -5850,7 +5850,7 @@
               </a:lnSpc>
             </a:pPr>
             <a:r>
-              <a:rPr sz="1100" b="0" i="0">
+              <a:rPr sz="1210" b="0" i="0">
                 <a:solidFill>
                   <a:srgbClr val="6B7682"/>
                 </a:solidFill>
@@ -6003,7 +6003,7 @@
               </a:lnSpc>
             </a:pPr>
             <a:r>
-              <a:rPr sz="1300" b="1" i="0">
+              <a:rPr sz="1430" b="1" i="0">
                 <a:solidFill>
                   <a:srgbClr val="C08A2B"/>
                 </a:solidFill>
@@ -6042,7 +6042,7 @@
               </a:lnSpc>
             </a:pPr>
             <a:r>
-              <a:rPr sz="2600" b="1" i="0">
+              <a:rPr sz="2860" b="1" i="0">
                 <a:solidFill>
                   <a:srgbClr val="FFFFFF"/>
                 </a:solidFill>
@@ -6169,7 +6169,7 @@
               </a:lnSpc>
             </a:pPr>
             <a:r>
-              <a:rPr sz="1600" b="1" i="0">
+              <a:rPr sz="1760" b="1" i="0">
                 <a:solidFill>
                   <a:srgbClr val="C08A2B"/>
                 </a:solidFill>
@@ -6211,7 +6211,7 @@
               </a:spcAft>
             </a:pPr>
             <a:r>
-              <a:rPr sz="1500">
+              <a:rPr sz="1650">
                 <a:solidFill>
                   <a:srgbClr val="334455"/>
                 </a:solidFill>
@@ -6230,7 +6230,7 @@
               </a:spcAft>
             </a:pPr>
             <a:r>
-              <a:rPr sz="1500">
+              <a:rPr sz="1650">
                 <a:solidFill>
                   <a:srgbClr val="334455"/>
                 </a:solidFill>
@@ -6249,7 +6249,7 @@
               </a:spcAft>
             </a:pPr>
             <a:r>
-              <a:rPr sz="1500">
+              <a:rPr sz="1650">
                 <a:solidFill>
                   <a:srgbClr val="334455"/>
                 </a:solidFill>
@@ -6268,7 +6268,7 @@
               </a:spcAft>
             </a:pPr>
             <a:r>
-              <a:rPr sz="1500">
+              <a:rPr sz="1650">
                 <a:solidFill>
                   <a:srgbClr val="334455"/>
                 </a:solidFill>
@@ -6395,7 +6395,7 @@
               </a:lnSpc>
             </a:pPr>
             <a:r>
-              <a:rPr sz="1600" b="1" i="0">
+              <a:rPr sz="1760" b="1" i="0">
                 <a:solidFill>
                   <a:srgbClr val="C08A2B"/>
                 </a:solidFill>
@@ -6437,7 +6437,7 @@
               </a:spcAft>
             </a:pPr>
             <a:r>
-              <a:rPr sz="1500">
+              <a:rPr sz="1650">
                 <a:solidFill>
                   <a:srgbClr val="F2F4F7"/>
                 </a:solidFill>
@@ -6456,7 +6456,7 @@
               </a:spcAft>
             </a:pPr>
             <a:r>
-              <a:rPr sz="1500">
+              <a:rPr sz="1650">
                 <a:solidFill>
                   <a:srgbClr val="F2F4F7"/>
                 </a:solidFill>
@@ -6475,7 +6475,7 @@
               </a:spcAft>
             </a:pPr>
             <a:r>
-              <a:rPr sz="1500">
+              <a:rPr sz="1650">
                 <a:solidFill>
                   <a:srgbClr val="F2F4F7"/>
                 </a:solidFill>
@@ -6494,7 +6494,7 @@
               </a:spcAft>
             </a:pPr>
             <a:r>
-              <a:rPr sz="1500">
+              <a:rPr sz="1650">
                 <a:solidFill>
                   <a:srgbClr val="F2F4F7"/>
                 </a:solidFill>
@@ -6621,7 +6621,7 @@
               </a:lnSpc>
             </a:pPr>
             <a:r>
-              <a:rPr sz="1500" b="0" i="1">
+              <a:rPr sz="1650" b="0" i="1">
                 <a:solidFill>
                   <a:srgbClr val="0F2A43"/>
                 </a:solidFill>
@@ -6704,7 +6704,7 @@
               </a:lnSpc>
             </a:pPr>
             <a:r>
-              <a:rPr sz="1100" b="0" i="0">
+              <a:rPr sz="1210" b="0" i="0">
                 <a:solidFill>
                   <a:srgbClr val="6B7682"/>
                 </a:solidFill>
@@ -6857,7 +6857,7 @@
               </a:lnSpc>
             </a:pPr>
             <a:r>
-              <a:rPr sz="1300" b="1" i="0">
+              <a:rPr sz="1430" b="1" i="0">
                 <a:solidFill>
                   <a:srgbClr val="C08A2B"/>
                 </a:solidFill>
@@ -6896,7 +6896,7 @@
               </a:lnSpc>
             </a:pPr>
             <a:r>
-              <a:rPr sz="2600" b="1" i="0">
+              <a:rPr sz="2860" b="1" i="0">
                 <a:solidFill>
                   <a:srgbClr val="FFFFFF"/>
                 </a:solidFill>
@@ -6938,7 +6938,7 @@
               </a:spcAft>
             </a:pPr>
             <a:r>
-              <a:rPr sz="1900" b="1">
+              <a:rPr sz="2090" b="1">
                 <a:solidFill>
                   <a:srgbClr val="0F2A43"/>
                 </a:solidFill>
@@ -6947,7 +6947,7 @@
               <a:t>•  Adversarial vs inquisitorial: </a:t>
             </a:r>
             <a:r>
-              <a:rPr sz="1900">
+              <a:rPr sz="2090">
                 <a:solidFill>
                   <a:srgbClr val="334455"/>
                 </a:solidFill>
@@ -6966,7 +6966,7 @@
               </a:spcAft>
             </a:pPr>
             <a:r>
-              <a:rPr sz="1900" b="1">
+              <a:rPr sz="2090" b="1">
                 <a:solidFill>
                   <a:srgbClr val="0F2A43"/>
                 </a:solidFill>
@@ -6975,7 +6975,7 @@
               <a:t>•  Victim participation: </a:t>
             </a:r>
             <a:r>
-              <a:rPr sz="1900">
+              <a:rPr sz="2090">
                 <a:solidFill>
                   <a:srgbClr val="334455"/>
                 </a:solidFill>
@@ -6994,7 +6994,7 @@
               </a:spcAft>
             </a:pPr>
             <a:r>
-              <a:rPr sz="1900" b="1">
+              <a:rPr sz="2090" b="1">
                 <a:solidFill>
                   <a:srgbClr val="0F2A43"/>
                 </a:solidFill>
@@ -7003,7 +7003,7 @@
               <a:t>•  Limitation periods: </a:t>
             </a:r>
             <a:r>
-              <a:rPr sz="1900">
+              <a:rPr sz="2090">
                 <a:solidFill>
                   <a:srgbClr val="334455"/>
                 </a:solidFill>
@@ -7022,7 +7022,7 @@
               </a:spcAft>
             </a:pPr>
             <a:r>
-              <a:rPr sz="1900" b="1">
+              <a:rPr sz="2090" b="1">
                 <a:solidFill>
                   <a:srgbClr val="0F2A43"/>
                 </a:solidFill>
@@ -7031,7 +7031,7 @@
               <a:t>•  Plea bargaining: </a:t>
             </a:r>
             <a:r>
-              <a:rPr sz="1900">
+              <a:rPr sz="2090">
                 <a:solidFill>
                   <a:srgbClr val="334455"/>
                 </a:solidFill>
@@ -7158,7 +7158,7 @@
               </a:lnSpc>
             </a:pPr>
             <a:r>
-              <a:rPr sz="1500" b="0" i="1">
+              <a:rPr sz="1650" b="0" i="1">
                 <a:solidFill>
                   <a:srgbClr val="0F2A43"/>
                 </a:solidFill>
@@ -7241,7 +7241,7 @@
               </a:lnSpc>
             </a:pPr>
             <a:r>
-              <a:rPr sz="1100" b="0" i="0">
+              <a:rPr sz="1210" b="0" i="0">
                 <a:solidFill>
                   <a:srgbClr val="6B7682"/>
                 </a:solidFill>
@@ -7306,7 +7306,7 @@
               </a:lnSpc>
             </a:pPr>
             <a:r>
-              <a:rPr sz="21000" b="1" i="0">
+              <a:rPr sz="23100" b="1" i="0">
                 <a:solidFill>
                   <a:srgbClr val="1C3A56"/>
                 </a:solidFill>
@@ -7345,7 +7345,7 @@
               </a:lnSpc>
             </a:pPr>
             <a:r>
-              <a:rPr sz="1300" b="1" i="0">
+              <a:rPr sz="1430" b="1" i="0">
                 <a:solidFill>
                   <a:srgbClr val="C08A2B"/>
                 </a:solidFill>
@@ -7428,7 +7428,7 @@
               </a:lnSpc>
             </a:pPr>
             <a:r>
-              <a:rPr sz="3300" b="1" i="0">
+              <a:rPr sz="3630" b="1" i="0">
                 <a:solidFill>
                   <a:srgbClr val="FFFFFF"/>
                 </a:solidFill>
@@ -7444,7 +7444,7 @@
               </a:lnSpc>
             </a:pPr>
             <a:r>
-              <a:rPr sz="3300" b="1" i="0">
+              <a:rPr sz="3630" b="1" i="0">
                 <a:solidFill>
                   <a:srgbClr val="FFFFFF"/>
                 </a:solidFill>
@@ -7483,7 +7483,7 @@
               </a:lnSpc>
             </a:pPr>
             <a:r>
-              <a:rPr sz="1800" b="0" i="1">
+              <a:rPr sz="1980" b="0" i="1">
                 <a:solidFill>
                   <a:srgbClr val="F2F4F7"/>
                 </a:solidFill>
@@ -7566,7 +7566,7 @@
               </a:lnSpc>
             </a:pPr>
             <a:r>
-              <a:rPr sz="1100" b="0" i="0">
+              <a:rPr sz="1210" b="0" i="0">
                 <a:solidFill>
                   <a:srgbClr val="909CAA"/>
                 </a:solidFill>
@@ -7719,7 +7719,7 @@
               </a:lnSpc>
             </a:pPr>
             <a:r>
-              <a:rPr sz="1300" b="1" i="0">
+              <a:rPr sz="1430" b="1" i="0">
                 <a:solidFill>
                   <a:srgbClr val="C08A2B"/>
                 </a:solidFill>
@@ -7758,7 +7758,7 @@
               </a:lnSpc>
             </a:pPr>
             <a:r>
-              <a:rPr sz="2600" b="1" i="0">
+              <a:rPr sz="2860" b="1" i="0">
                 <a:solidFill>
                   <a:srgbClr val="FFFFFF"/>
                 </a:solidFill>
@@ -7800,7 +7800,7 @@
               </a:spcAft>
             </a:pPr>
             <a:r>
-              <a:rPr sz="1900">
+              <a:rPr sz="2090">
                 <a:solidFill>
                   <a:srgbClr val="334455"/>
                 </a:solidFill>
@@ -7819,7 +7819,7 @@
               </a:spcAft>
             </a:pPr>
             <a:r>
-              <a:rPr sz="1900">
+              <a:rPr sz="2090">
                 <a:solidFill>
                   <a:srgbClr val="334455"/>
                 </a:solidFill>
@@ -7838,7 +7838,7 @@
               </a:spcAft>
             </a:pPr>
             <a:r>
-              <a:rPr sz="1900" b="1">
+              <a:rPr sz="2090" b="1">
                 <a:solidFill>
                   <a:srgbClr val="0F2A43"/>
                 </a:solidFill>
@@ -7847,7 +7847,7 @@
               <a:t>•  Survivors' concern: </a:t>
             </a:r>
             <a:r>
-              <a:rPr sz="1900">
+              <a:rPr sz="2090">
                 <a:solidFill>
                   <a:srgbClr val="334455"/>
                 </a:solidFill>
@@ -7866,7 +7866,7 @@
               </a:spcAft>
             </a:pPr>
             <a:r>
-              <a:rPr sz="1900">
+              <a:rPr sz="2090">
                 <a:solidFill>
                   <a:srgbClr val="334455"/>
                 </a:solidFill>
@@ -7993,7 +7993,7 @@
               </a:lnSpc>
             </a:pPr>
             <a:r>
-              <a:rPr sz="1500" b="0" i="1">
+              <a:rPr sz="1650" b="0" i="1">
                 <a:solidFill>
                   <a:srgbClr val="0F2A43"/>
                 </a:solidFill>
@@ -8076,7 +8076,7 @@
               </a:lnSpc>
             </a:pPr>
             <a:r>
-              <a:rPr sz="1100" b="0" i="0">
+              <a:rPr sz="1210" b="0" i="0">
                 <a:solidFill>
                   <a:srgbClr val="6B7682"/>
                 </a:solidFill>
@@ -8229,7 +8229,7 @@
               </a:lnSpc>
             </a:pPr>
             <a:r>
-              <a:rPr sz="1300" b="1" i="0">
+              <a:rPr sz="1430" b="1" i="0">
                 <a:solidFill>
                   <a:srgbClr val="C08A2B"/>
                 </a:solidFill>
@@ -8268,7 +8268,7 @@
               </a:lnSpc>
             </a:pPr>
             <a:r>
-              <a:rPr sz="2600" b="1" i="0">
+              <a:rPr sz="2860" b="1" i="0">
                 <a:solidFill>
                   <a:srgbClr val="FFFFFF"/>
                 </a:solidFill>
@@ -8310,7 +8310,7 @@
               </a:spcAft>
             </a:pPr>
             <a:r>
-              <a:rPr sz="1800">
+              <a:rPr sz="1980">
                 <a:solidFill>
                   <a:srgbClr val="334455"/>
                 </a:solidFill>
@@ -8329,7 +8329,7 @@
               </a:spcAft>
             </a:pPr>
             <a:r>
-              <a:rPr sz="1800">
+              <a:rPr sz="1980">
                 <a:solidFill>
                   <a:srgbClr val="334455"/>
                 </a:solidFill>
@@ -8348,7 +8348,7 @@
               </a:spcAft>
             </a:pPr>
             <a:r>
-              <a:rPr sz="1800">
+              <a:rPr sz="1980">
                 <a:solidFill>
                   <a:srgbClr val="334455"/>
                 </a:solidFill>
@@ -8367,7 +8367,7 @@
               </a:spcAft>
             </a:pPr>
             <a:r>
-              <a:rPr sz="1800">
+              <a:rPr sz="1980">
                 <a:solidFill>
                   <a:srgbClr val="334455"/>
                 </a:solidFill>
@@ -8494,7 +8494,7 @@
               </a:lnSpc>
             </a:pPr>
             <a:r>
-              <a:rPr sz="1400" b="1" i="0">
+              <a:rPr sz="1540" b="1" i="0">
                 <a:solidFill>
                   <a:srgbClr val="C08A2B"/>
                 </a:solidFill>
@@ -8533,7 +8533,7 @@
               </a:lnSpc>
             </a:pPr>
             <a:r>
-              <a:rPr sz="1500" b="0" i="1">
+              <a:rPr sz="1650" b="0" i="1">
                 <a:solidFill>
                   <a:srgbClr val="334455"/>
                 </a:solidFill>
@@ -8660,7 +8660,7 @@
               </a:lnSpc>
             </a:pPr>
             <a:r>
-              <a:rPr sz="1500" b="0" i="1">
+              <a:rPr sz="1650" b="0" i="1">
                 <a:solidFill>
                   <a:srgbClr val="0F2A43"/>
                 </a:solidFill>
@@ -8743,7 +8743,7 @@
               </a:lnSpc>
             </a:pPr>
             <a:r>
-              <a:rPr sz="1100" b="0" i="0">
+              <a:rPr sz="1210" b="0" i="0">
                 <a:solidFill>
                   <a:srgbClr val="6B7682"/>
                 </a:solidFill>
@@ -8896,7 +8896,7 @@
               </a:lnSpc>
             </a:pPr>
             <a:r>
-              <a:rPr sz="1300" b="1" i="0">
+              <a:rPr sz="1430" b="1" i="0">
                 <a:solidFill>
                   <a:srgbClr val="C08A2B"/>
                 </a:solidFill>
@@ -8935,7 +8935,7 @@
               </a:lnSpc>
             </a:pPr>
             <a:r>
-              <a:rPr sz="2600" b="1" i="0">
+              <a:rPr sz="2860" b="1" i="0">
                 <a:solidFill>
                   <a:srgbClr val="FFFFFF"/>
                 </a:solidFill>
@@ -9062,7 +9062,7 @@
               </a:lnSpc>
             </a:pPr>
             <a:r>
-              <a:rPr sz="1900" b="1" i="1">
+              <a:rPr sz="2090" b="1" i="1">
                 <a:solidFill>
                   <a:srgbClr val="0F2A43"/>
                 </a:solidFill>
@@ -9104,7 +9104,7 @@
               </a:spcAft>
             </a:pPr>
             <a:r>
-              <a:rPr sz="1900">
+              <a:rPr sz="2090">
                 <a:solidFill>
                   <a:srgbClr val="334455"/>
                 </a:solidFill>
@@ -9123,7 +9123,7 @@
               </a:spcAft>
             </a:pPr>
             <a:r>
-              <a:rPr sz="1900">
+              <a:rPr sz="2090">
                 <a:solidFill>
                   <a:srgbClr val="334455"/>
                 </a:solidFill>
@@ -9142,7 +9142,7 @@
               </a:spcAft>
             </a:pPr>
             <a:r>
-              <a:rPr sz="1900">
+              <a:rPr sz="2090">
                 <a:solidFill>
                   <a:srgbClr val="334455"/>
                 </a:solidFill>
@@ -9161,7 +9161,7 @@
               </a:spcAft>
             </a:pPr>
             <a:r>
-              <a:rPr sz="1900">
+              <a:rPr sz="2090">
                 <a:solidFill>
                   <a:srgbClr val="334455"/>
                 </a:solidFill>
@@ -9288,7 +9288,7 @@
               </a:lnSpc>
             </a:pPr>
             <a:r>
-              <a:rPr sz="1500" b="0" i="1">
+              <a:rPr sz="1650" b="0" i="1">
                 <a:solidFill>
                   <a:srgbClr val="0F2A43"/>
                 </a:solidFill>
@@ -9371,7 +9371,7 @@
               </a:lnSpc>
             </a:pPr>
             <a:r>
-              <a:rPr sz="1100" b="0" i="0">
+              <a:rPr sz="1210" b="0" i="0">
                 <a:solidFill>
                   <a:srgbClr val="6B7682"/>
                 </a:solidFill>
@@ -9524,7 +9524,7 @@
               </a:lnSpc>
             </a:pPr>
             <a:r>
-              <a:rPr sz="1300" b="1" i="0">
+              <a:rPr sz="1430" b="1" i="0">
                 <a:solidFill>
                   <a:srgbClr val="C08A2B"/>
                 </a:solidFill>
@@ -9563,7 +9563,7 @@
               </a:lnSpc>
             </a:pPr>
             <a:r>
-              <a:rPr sz="2600" b="1" i="0">
+              <a:rPr sz="2860" b="1" i="0">
                 <a:solidFill>
                   <a:srgbClr val="FFFFFF"/>
                 </a:solidFill>
@@ -9646,7 +9646,7 @@
               </a:lnSpc>
             </a:pPr>
             <a:r>
-              <a:rPr sz="2400" b="1" i="0">
+              <a:rPr sz="2640" b="1" i="0">
                 <a:solidFill>
                   <a:srgbClr val="FFFFFF"/>
                 </a:solidFill>
@@ -9685,7 +9685,7 @@
               </a:lnSpc>
             </a:pPr>
             <a:r>
-              <a:rPr sz="1800" b="1" i="0">
+              <a:rPr sz="1980" b="1" i="0">
                 <a:solidFill>
                   <a:srgbClr val="0F2A43"/>
                 </a:solidFill>
@@ -9724,7 +9724,7 @@
               </a:lnSpc>
             </a:pPr>
             <a:r>
-              <a:rPr sz="1400" b="0" i="1">
+              <a:rPr sz="1540" b="0" i="1">
                 <a:solidFill>
                   <a:srgbClr val="334455"/>
                 </a:solidFill>
@@ -9807,7 +9807,7 @@
               </a:lnSpc>
             </a:pPr>
             <a:r>
-              <a:rPr sz="2400" b="1" i="0">
+              <a:rPr sz="2640" b="1" i="0">
                 <a:solidFill>
                   <a:srgbClr val="FFFFFF"/>
                 </a:solidFill>
@@ -9846,7 +9846,7 @@
               </a:lnSpc>
             </a:pPr>
             <a:r>
-              <a:rPr sz="1800" b="1" i="0">
+              <a:rPr sz="1980" b="1" i="0">
                 <a:solidFill>
                   <a:srgbClr val="0F2A43"/>
                 </a:solidFill>
@@ -9885,7 +9885,7 @@
               </a:lnSpc>
             </a:pPr>
             <a:r>
-              <a:rPr sz="1400" b="0" i="1">
+              <a:rPr sz="1540" b="0" i="1">
                 <a:solidFill>
                   <a:srgbClr val="334455"/>
                 </a:solidFill>
@@ -9968,7 +9968,7 @@
               </a:lnSpc>
             </a:pPr>
             <a:r>
-              <a:rPr sz="2400" b="1" i="0">
+              <a:rPr sz="2640" b="1" i="0">
                 <a:solidFill>
                   <a:srgbClr val="FFFFFF"/>
                 </a:solidFill>
@@ -10007,7 +10007,7 @@
               </a:lnSpc>
             </a:pPr>
             <a:r>
-              <a:rPr sz="1800" b="1" i="0">
+              <a:rPr sz="1980" b="1" i="0">
                 <a:solidFill>
                   <a:srgbClr val="0F2A43"/>
                 </a:solidFill>
@@ -10046,7 +10046,7 @@
               </a:lnSpc>
             </a:pPr>
             <a:r>
-              <a:rPr sz="1400" b="0" i="1">
+              <a:rPr sz="1540" b="0" i="1">
                 <a:solidFill>
                   <a:srgbClr val="334455"/>
                 </a:solidFill>
@@ -10129,7 +10129,7 @@
               </a:lnSpc>
             </a:pPr>
             <a:r>
-              <a:rPr sz="2400" b="1" i="0">
+              <a:rPr sz="2640" b="1" i="0">
                 <a:solidFill>
                   <a:srgbClr val="FFFFFF"/>
                 </a:solidFill>
@@ -10168,7 +10168,7 @@
               </a:lnSpc>
             </a:pPr>
             <a:r>
-              <a:rPr sz="1800" b="1" i="0">
+              <a:rPr sz="1980" b="1" i="0">
                 <a:solidFill>
                   <a:srgbClr val="0F2A43"/>
                 </a:solidFill>
@@ -10207,7 +10207,7 @@
               </a:lnSpc>
             </a:pPr>
             <a:r>
-              <a:rPr sz="1400" b="0" i="1">
+              <a:rPr sz="1540" b="0" i="1">
                 <a:solidFill>
                   <a:srgbClr val="334455"/>
                 </a:solidFill>
@@ -10334,7 +10334,7 @@
               </a:lnSpc>
             </a:pPr>
             <a:r>
-              <a:rPr sz="1100" b="1" i="0">
+              <a:rPr sz="1210" b="1" i="0">
                 <a:solidFill>
                   <a:srgbClr val="C08A2B"/>
                 </a:solidFill>
@@ -10373,7 +10373,7 @@
               </a:lnSpc>
             </a:pPr>
             <a:r>
-              <a:rPr sz="1100" b="0" i="0">
+              <a:rPr sz="1210" b="0" i="0">
                 <a:solidFill>
                   <a:srgbClr val="334455"/>
                 </a:solidFill>
@@ -10456,7 +10456,7 @@
               </a:lnSpc>
             </a:pPr>
             <a:r>
-              <a:rPr sz="1100" b="0" i="0">
+              <a:rPr sz="1210" b="0" i="0">
                 <a:solidFill>
                   <a:srgbClr val="6B7682"/>
                 </a:solidFill>
@@ -10521,7 +10521,7 @@
               </a:lnSpc>
             </a:pPr>
             <a:r>
-              <a:rPr sz="21000" b="1" i="0">
+              <a:rPr sz="23100" b="1" i="0">
                 <a:solidFill>
                   <a:srgbClr val="1C3A56"/>
                 </a:solidFill>
@@ -10560,7 +10560,7 @@
               </a:lnSpc>
             </a:pPr>
             <a:r>
-              <a:rPr sz="1300" b="1" i="0">
+              <a:rPr sz="1430" b="1" i="0">
                 <a:solidFill>
                   <a:srgbClr val="C08A2B"/>
                 </a:solidFill>
@@ -10643,7 +10643,7 @@
               </a:lnSpc>
             </a:pPr>
             <a:r>
-              <a:rPr sz="3300" b="1" i="0">
+              <a:rPr sz="3630" b="1" i="0">
                 <a:solidFill>
                   <a:srgbClr val="FFFFFF"/>
                 </a:solidFill>
@@ -10659,7 +10659,7 @@
               </a:lnSpc>
             </a:pPr>
             <a:r>
-              <a:rPr sz="3300" b="1" i="0">
+              <a:rPr sz="3630" b="1" i="0">
                 <a:solidFill>
                   <a:srgbClr val="FFFFFF"/>
                 </a:solidFill>
@@ -10698,7 +10698,7 @@
               </a:lnSpc>
             </a:pPr>
             <a:r>
-              <a:rPr sz="1800" b="0" i="1">
+              <a:rPr sz="1980" b="0" i="1">
                 <a:solidFill>
                   <a:srgbClr val="F2F4F7"/>
                 </a:solidFill>
@@ -10781,7 +10781,7 @@
               </a:lnSpc>
             </a:pPr>
             <a:r>
-              <a:rPr sz="1100" b="0" i="0">
+              <a:rPr sz="1210" b="0" i="0">
                 <a:solidFill>
                   <a:srgbClr val="909CAA"/>
                 </a:solidFill>
@@ -10934,7 +10934,7 @@
               </a:lnSpc>
             </a:pPr>
             <a:r>
-              <a:rPr sz="1300" b="1" i="0">
+              <a:rPr sz="1430" b="1" i="0">
                 <a:solidFill>
                   <a:srgbClr val="C08A2B"/>
                 </a:solidFill>
@@ -10973,7 +10973,7 @@
               </a:lnSpc>
             </a:pPr>
             <a:r>
-              <a:rPr sz="2600" b="1" i="0">
+              <a:rPr sz="2860" b="1" i="0">
                 <a:solidFill>
                   <a:srgbClr val="FFFFFF"/>
                 </a:solidFill>
@@ -11015,7 +11015,7 @@
               </a:spcAft>
             </a:pPr>
             <a:r>
-              <a:rPr sz="1800">
+              <a:rPr sz="1980">
                 <a:solidFill>
                   <a:srgbClr val="334455"/>
                 </a:solidFill>
@@ -11034,7 +11034,7 @@
               </a:spcAft>
             </a:pPr>
             <a:r>
-              <a:rPr sz="1800" b="1">
+              <a:rPr sz="1980" b="1">
                 <a:solidFill>
                   <a:srgbClr val="0F2A43"/>
                 </a:solidFill>
@@ -11043,7 +11043,7 @@
               <a:t>•  2005–06: </a:t>
             </a:r>
             <a:r>
-              <a:rPr sz="1800">
+              <a:rPr sz="1980">
                 <a:solidFill>
                   <a:srgbClr val="334455"/>
                 </a:solidFill>
@@ -11062,7 +11062,7 @@
               </a:spcAft>
             </a:pPr>
             <a:r>
-              <a:rPr sz="1800" b="1">
+              <a:rPr sz="1980" b="1">
                 <a:solidFill>
                   <a:srgbClr val="0F2A43"/>
                 </a:solidFill>
@@ -11071,7 +11071,7 @@
               <a:t>•  2008: </a:t>
             </a:r>
             <a:r>
-              <a:rPr sz="1800">
+              <a:rPr sz="1980">
                 <a:solidFill>
                   <a:srgbClr val="334455"/>
                 </a:solidFill>
@@ -11090,7 +11090,7 @@
               </a:spcAft>
             </a:pPr>
             <a:r>
-              <a:rPr sz="1800" b="1">
+              <a:rPr sz="1980" b="1">
                 <a:solidFill>
                   <a:srgbClr val="0F2A43"/>
                 </a:solidFill>
@@ -11099,7 +11099,7 @@
               <a:t>•  2019: </a:t>
             </a:r>
             <a:r>
-              <a:rPr sz="1800">
+              <a:rPr sz="1980">
                 <a:solidFill>
                   <a:srgbClr val="334455"/>
                 </a:solidFill>
@@ -11118,7 +11118,7 @@
               </a:spcAft>
             </a:pPr>
             <a:r>
-              <a:rPr sz="1800">
+              <a:rPr sz="1980">
                 <a:solidFill>
                   <a:srgbClr val="334455"/>
                 </a:solidFill>
@@ -11245,7 +11245,7 @@
               </a:lnSpc>
             </a:pPr>
             <a:r>
-              <a:rPr sz="1400" b="1" i="0">
+              <a:rPr sz="1540" b="1" i="0">
                 <a:solidFill>
                   <a:srgbClr val="C08A2B"/>
                 </a:solidFill>
@@ -11284,7 +11284,7 @@
               </a:lnSpc>
             </a:pPr>
             <a:r>
-              <a:rPr sz="1600" b="0" i="1">
+              <a:rPr sz="1760" b="0" i="1">
                 <a:solidFill>
                   <a:srgbClr val="334455"/>
                 </a:solidFill>
@@ -11411,7 +11411,7 @@
               </a:lnSpc>
             </a:pPr>
             <a:r>
-              <a:rPr sz="1500" b="0" i="1">
+              <a:rPr sz="1650" b="0" i="1">
                 <a:solidFill>
                   <a:srgbClr val="0F2A43"/>
                 </a:solidFill>
@@ -11494,7 +11494,7 @@
               </a:lnSpc>
             </a:pPr>
             <a:r>
-              <a:rPr sz="1100" b="0" i="0">
+              <a:rPr sz="1210" b="0" i="0">
                 <a:solidFill>
                   <a:srgbClr val="6B7682"/>
                 </a:solidFill>
@@ -11647,7 +11647,7 @@
               </a:lnSpc>
             </a:pPr>
             <a:r>
-              <a:rPr sz="1300" b="1" i="0">
+              <a:rPr sz="1430" b="1" i="0">
                 <a:solidFill>
                   <a:srgbClr val="C08A2B"/>
                 </a:solidFill>
@@ -11686,7 +11686,7 @@
               </a:lnSpc>
             </a:pPr>
             <a:r>
-              <a:rPr sz="2600" b="1" i="0">
+              <a:rPr sz="2860" b="1" i="0">
                 <a:solidFill>
                   <a:srgbClr val="FFFFFF"/>
                 </a:solidFill>
@@ -11813,7 +11813,7 @@
               </a:lnSpc>
             </a:pPr>
             <a:r>
-              <a:rPr sz="2800" b="1" i="0">
+              <a:rPr sz="3080" b="1" i="0">
                 <a:solidFill>
                   <a:srgbClr val="FFFFFF"/>
                 </a:solidFill>
@@ -11896,7 +11896,7 @@
               </a:lnSpc>
             </a:pPr>
             <a:r>
-              <a:rPr sz="1400" b="0" i="0">
+              <a:rPr sz="1540" b="0" i="0">
                 <a:solidFill>
                   <a:srgbClr val="334455"/>
                 </a:solidFill>
@@ -11979,7 +11979,7 @@
               </a:lnSpc>
             </a:pPr>
             <a:r>
-              <a:rPr sz="2800" b="1" i="0">
+              <a:rPr sz="3080" b="1" i="0">
                 <a:solidFill>
                   <a:srgbClr val="FFFFFF"/>
                 </a:solidFill>
@@ -12062,7 +12062,7 @@
               </a:lnSpc>
             </a:pPr>
             <a:r>
-              <a:rPr sz="1400" b="0" i="0">
+              <a:rPr sz="1540" b="0" i="0">
                 <a:solidFill>
                   <a:srgbClr val="334455"/>
                 </a:solidFill>
@@ -12145,7 +12145,7 @@
               </a:lnSpc>
             </a:pPr>
             <a:r>
-              <a:rPr sz="2800" b="1" i="0">
+              <a:rPr sz="3080" b="1" i="0">
                 <a:solidFill>
                   <a:srgbClr val="FFFFFF"/>
                 </a:solidFill>
@@ -12228,7 +12228,7 @@
               </a:lnSpc>
             </a:pPr>
             <a:r>
-              <a:rPr sz="1400" b="0" i="0">
+              <a:rPr sz="1540" b="0" i="0">
                 <a:solidFill>
                   <a:srgbClr val="334455"/>
                 </a:solidFill>
@@ -12311,7 +12311,7 @@
               </a:lnSpc>
             </a:pPr>
             <a:r>
-              <a:rPr sz="2800" b="1" i="0">
+              <a:rPr sz="3080" b="1" i="0">
                 <a:solidFill>
                   <a:srgbClr val="FFFFFF"/>
                 </a:solidFill>
@@ -12394,7 +12394,7 @@
               </a:lnSpc>
             </a:pPr>
             <a:r>
-              <a:rPr sz="1400" b="0" i="0">
+              <a:rPr sz="1540" b="0" i="0">
                 <a:solidFill>
                   <a:srgbClr val="334455"/>
                 </a:solidFill>
@@ -12521,7 +12521,7 @@
               </a:lnSpc>
             </a:pPr>
             <a:r>
-              <a:rPr sz="1500" b="0" i="1">
+              <a:rPr sz="1650" b="0" i="1">
                 <a:solidFill>
                   <a:srgbClr val="0F2A43"/>
                 </a:solidFill>
@@ -12604,7 +12604,7 @@
               </a:lnSpc>
             </a:pPr>
             <a:r>
-              <a:rPr sz="1100" b="0" i="0">
+              <a:rPr sz="1210" b="0" i="0">
                 <a:solidFill>
                   <a:srgbClr val="6B7682"/>
                 </a:solidFill>
@@ -12757,7 +12757,7 @@
               </a:lnSpc>
             </a:pPr>
             <a:r>
-              <a:rPr sz="1300" b="1" i="0">
+              <a:rPr sz="1430" b="1" i="0">
                 <a:solidFill>
                   <a:srgbClr val="C08A2B"/>
                 </a:solidFill>
@@ -12796,7 +12796,7 @@
               </a:lnSpc>
             </a:pPr>
             <a:r>
-              <a:rPr sz="2600" b="1" i="0">
+              <a:rPr sz="2860" b="1" i="0">
                 <a:solidFill>
                   <a:srgbClr val="FFFFFF"/>
                 </a:solidFill>
@@ -12838,7 +12838,7 @@
               </a:spcAft>
             </a:pPr>
             <a:r>
-              <a:rPr sz="1800" b="1">
+              <a:rPr sz="1980" b="1">
                 <a:solidFill>
                   <a:srgbClr val="0F2A43"/>
                 </a:solidFill>
@@ -12847,7 +12847,7 @@
               <a:t>•  Recruitment: </a:t>
             </a:r>
             <a:r>
-              <a:rPr sz="1800">
+              <a:rPr sz="1980">
                 <a:solidFill>
                   <a:srgbClr val="334455"/>
                 </a:solidFill>
@@ -12866,7 +12866,7 @@
               </a:spcAft>
             </a:pPr>
             <a:r>
-              <a:rPr sz="1800" b="1">
+              <a:rPr sz="1980" b="1">
                 <a:solidFill>
                   <a:srgbClr val="0F2A43"/>
                 </a:solidFill>
@@ -12875,7 +12875,7 @@
               <a:t>•  Finance: </a:t>
             </a:r>
             <a:r>
-              <a:rPr sz="1800">
+              <a:rPr sz="1980">
                 <a:solidFill>
                   <a:srgbClr val="334455"/>
                 </a:solidFill>
@@ -12894,7 +12894,7 @@
               </a:spcAft>
             </a:pPr>
             <a:r>
-              <a:rPr sz="1800" b="1">
+              <a:rPr sz="1980" b="1">
                 <a:solidFill>
                   <a:srgbClr val="0F2A43"/>
                 </a:solidFill>
@@ -12903,7 +12903,7 @@
               <a:t>•  Property: </a:t>
             </a:r>
             <a:r>
-              <a:rPr sz="1800">
+              <a:rPr sz="1980">
                 <a:solidFill>
                   <a:srgbClr val="334455"/>
                 </a:solidFill>
@@ -12922,7 +12922,7 @@
               </a:spcAft>
             </a:pPr>
             <a:r>
-              <a:rPr sz="1800" b="1">
+              <a:rPr sz="1980" b="1">
                 <a:solidFill>
                   <a:srgbClr val="0F2A43"/>
                 </a:solidFill>
@@ -12931,7 +12931,7 @@
               <a:t>•  Identity: </a:t>
             </a:r>
             <a:r>
-              <a:rPr sz="1800">
+              <a:rPr sz="1980">
                 <a:solidFill>
                   <a:srgbClr val="334455"/>
                 </a:solidFill>
@@ -12950,7 +12950,7 @@
               </a:spcAft>
             </a:pPr>
             <a:r>
-              <a:rPr sz="1800" b="1">
+              <a:rPr sz="1980" b="1">
                 <a:solidFill>
                   <a:srgbClr val="0F2A43"/>
                 </a:solidFill>
@@ -12959,7 +12959,7 @@
               <a:t>•  Network: </a:t>
             </a:r>
             <a:r>
-              <a:rPr sz="1800">
+              <a:rPr sz="1980">
                 <a:solidFill>
                   <a:srgbClr val="334455"/>
                 </a:solidFill>
@@ -13086,7 +13086,7 @@
               </a:lnSpc>
             </a:pPr>
             <a:r>
-              <a:rPr sz="1400" b="1" i="0">
+              <a:rPr sz="1540" b="1" i="0">
                 <a:solidFill>
                   <a:srgbClr val="C08A2B"/>
                 </a:solidFill>
@@ -13125,7 +13125,7 @@
               </a:lnSpc>
             </a:pPr>
             <a:r>
-              <a:rPr sz="1600" b="0" i="1">
+              <a:rPr sz="1760" b="0" i="1">
                 <a:solidFill>
                   <a:srgbClr val="334455"/>
                 </a:solidFill>
@@ -13252,7 +13252,7 @@
               </a:lnSpc>
             </a:pPr>
             <a:r>
-              <a:rPr sz="1500" b="0" i="1">
+              <a:rPr sz="1650" b="0" i="1">
                 <a:solidFill>
                   <a:srgbClr val="0F2A43"/>
                 </a:solidFill>
@@ -13335,7 +13335,7 @@
               </a:lnSpc>
             </a:pPr>
             <a:r>
-              <a:rPr sz="1100" b="0" i="0">
+              <a:rPr sz="1210" b="0" i="0">
                 <a:solidFill>
                   <a:srgbClr val="6B7682"/>
                 </a:solidFill>
@@ -13400,7 +13400,7 @@
               </a:lnSpc>
             </a:pPr>
             <a:r>
-              <a:rPr sz="21000" b="1" i="0">
+              <a:rPr sz="23100" b="1" i="0">
                 <a:solidFill>
                   <a:srgbClr val="1C3A56"/>
                 </a:solidFill>
@@ -13439,7 +13439,7 @@
               </a:lnSpc>
             </a:pPr>
             <a:r>
-              <a:rPr sz="1300" b="1" i="0">
+              <a:rPr sz="1430" b="1" i="0">
                 <a:solidFill>
                   <a:srgbClr val="C08A2B"/>
                 </a:solidFill>
@@ -13522,7 +13522,7 @@
               </a:lnSpc>
             </a:pPr>
             <a:r>
-              <a:rPr sz="3300" b="1" i="0">
+              <a:rPr sz="3630" b="1" i="0">
                 <a:solidFill>
                   <a:srgbClr val="FFFFFF"/>
                 </a:solidFill>
@@ -13538,7 +13538,7 @@
               </a:lnSpc>
             </a:pPr>
             <a:r>
-              <a:rPr sz="3300" b="1" i="0">
+              <a:rPr sz="3630" b="1" i="0">
                 <a:solidFill>
                   <a:srgbClr val="FFFFFF"/>
                 </a:solidFill>
@@ -13577,7 +13577,7 @@
               </a:lnSpc>
             </a:pPr>
             <a:r>
-              <a:rPr sz="1800" b="0" i="1">
+              <a:rPr sz="1980" b="0" i="1">
                 <a:solidFill>
                   <a:srgbClr val="F2F4F7"/>
                 </a:solidFill>
@@ -13660,7 +13660,7 @@
               </a:lnSpc>
             </a:pPr>
             <a:r>
-              <a:rPr sz="1100" b="0" i="0">
+              <a:rPr sz="1210" b="0" i="0">
                 <a:solidFill>
                   <a:srgbClr val="909CAA"/>
                 </a:solidFill>
@@ -13813,7 +13813,7 @@
               </a:lnSpc>
             </a:pPr>
             <a:r>
-              <a:rPr sz="1300" b="1" i="0">
+              <a:rPr sz="1430" b="1" i="0">
                 <a:solidFill>
                   <a:srgbClr val="C08A2B"/>
                 </a:solidFill>
@@ -13852,7 +13852,7 @@
               </a:lnSpc>
             </a:pPr>
             <a:r>
-              <a:rPr sz="2600" b="1" i="0">
+              <a:rPr sz="2860" b="1" i="0">
                 <a:solidFill>
                   <a:srgbClr val="FFFFFF"/>
                 </a:solidFill>
@@ -13894,7 +13894,7 @@
               </a:spcAft>
             </a:pPr>
             <a:r>
-              <a:rPr sz="1900">
+              <a:rPr sz="2090">
                 <a:solidFill>
                   <a:srgbClr val="334455"/>
                 </a:solidFill>
@@ -13913,7 +13913,7 @@
               </a:spcAft>
             </a:pPr>
             <a:r>
-              <a:rPr sz="1900">
+              <a:rPr sz="2090">
                 <a:solidFill>
                   <a:srgbClr val="334455"/>
                 </a:solidFill>
@@ -13932,7 +13932,7 @@
               </a:spcAft>
             </a:pPr>
             <a:r>
-              <a:rPr sz="1900">
+              <a:rPr sz="2090">
                 <a:solidFill>
                   <a:srgbClr val="334455"/>
                 </a:solidFill>
@@ -13951,7 +13951,7 @@
               </a:spcAft>
             </a:pPr>
             <a:r>
-              <a:rPr sz="1900">
+              <a:rPr sz="2090">
                 <a:solidFill>
                   <a:srgbClr val="334455"/>
                 </a:solidFill>
@@ -14078,7 +14078,7 @@
               </a:lnSpc>
             </a:pPr>
             <a:r>
-              <a:rPr sz="1500" b="0" i="1">
+              <a:rPr sz="1650" b="0" i="1">
                 <a:solidFill>
                   <a:srgbClr val="0F2A43"/>
                 </a:solidFill>
@@ -14161,7 +14161,7 @@
               </a:lnSpc>
             </a:pPr>
             <a:r>
-              <a:rPr sz="1100" b="0" i="0">
+              <a:rPr sz="1210" b="0" i="0">
                 <a:solidFill>
                   <a:srgbClr val="6B7682"/>
                 </a:solidFill>
@@ -14314,7 +14314,7 @@
               </a:lnSpc>
             </a:pPr>
             <a:r>
-              <a:rPr sz="1300" b="1" i="0">
+              <a:rPr sz="1430" b="1" i="0">
                 <a:solidFill>
                   <a:srgbClr val="C08A2B"/>
                 </a:solidFill>
@@ -14353,7 +14353,7 @@
               </a:lnSpc>
             </a:pPr>
             <a:r>
-              <a:rPr sz="2600" b="1" i="0">
+              <a:rPr sz="2860" b="1" i="0">
                 <a:solidFill>
                   <a:srgbClr val="FFFFFF"/>
                 </a:solidFill>
@@ -14395,7 +14395,7 @@
               </a:spcAft>
             </a:pPr>
             <a:r>
-              <a:rPr sz="1900" b="1">
+              <a:rPr sz="2090" b="1">
                 <a:solidFill>
                   <a:srgbClr val="0F2A43"/>
                 </a:solidFill>
@@ -14404,7 +14404,7 @@
               <a:t>•  Full name: </a:t>
             </a:r>
             <a:r>
-              <a:rPr sz="1900">
+              <a:rPr sz="2090">
                 <a:solidFill>
                   <a:srgbClr val="334455"/>
                 </a:solidFill>
@@ -14423,7 +14423,7 @@
               </a:spcAft>
             </a:pPr>
             <a:r>
-              <a:rPr sz="1900">
+              <a:rPr sz="2090">
                 <a:solidFill>
                   <a:srgbClr val="334455"/>
                 </a:solidFill>
@@ -14442,7 +14442,7 @@
               </a:spcAft>
             </a:pPr>
             <a:r>
-              <a:rPr sz="1900" b="1">
+              <a:rPr sz="2090" b="1">
                 <a:solidFill>
                   <a:srgbClr val="0F2A43"/>
                 </a:solidFill>
@@ -14451,7 +14451,7 @@
               <a:t>•  Three elements: </a:t>
             </a:r>
             <a:r>
-              <a:rPr sz="1900">
+              <a:rPr sz="2090">
                 <a:solidFill>
                   <a:srgbClr val="334455"/>
                 </a:solidFill>
@@ -14470,7 +14470,7 @@
               </a:spcAft>
             </a:pPr>
             <a:r>
-              <a:rPr sz="1900">
+              <a:rPr sz="2090">
                 <a:solidFill>
                   <a:srgbClr val="334455"/>
                 </a:solidFill>
@@ -14489,7 +14489,7 @@
               </a:spcAft>
             </a:pPr>
             <a:r>
-              <a:rPr sz="1900">
+              <a:rPr sz="2090">
                 <a:solidFill>
                   <a:srgbClr val="334455"/>
                 </a:solidFill>
@@ -14616,7 +14616,7 @@
               </a:lnSpc>
             </a:pPr>
             <a:r>
-              <a:rPr sz="1500" b="0" i="1">
+              <a:rPr sz="1650" b="0" i="1">
                 <a:solidFill>
                   <a:srgbClr val="0F2A43"/>
                 </a:solidFill>
@@ -14699,7 +14699,7 @@
               </a:lnSpc>
             </a:pPr>
             <a:r>
-              <a:rPr sz="1100" b="0" i="0">
+              <a:rPr sz="1210" b="0" i="0">
                 <a:solidFill>
                   <a:srgbClr val="6B7682"/>
                 </a:solidFill>

</xml_diff>

<commit_message>
Enlarge text to 1.18 scale; add 4-speaker presentation script
</commit_message>
<xml_diff>
--- a/Epstein_Transnational_Justice.pptx
+++ b/Epstein_Transnational_Justice.pptx
@@ -3231,7 +3231,7 @@
               </a:lnSpc>
             </a:pPr>
             <a:r>
-              <a:rPr sz="1760" b="1" i="0">
+              <a:rPr sz="1888" b="1" i="0">
                 <a:solidFill>
                   <a:srgbClr val="C08A2B"/>
                 </a:solidFill>
@@ -3270,7 +3270,7 @@
               </a:lnSpc>
             </a:pPr>
             <a:r>
-              <a:rPr sz="4400" b="1" i="0">
+              <a:rPr sz="4720" b="1" i="0">
                 <a:solidFill>
                   <a:srgbClr val="FFFFFF"/>
                 </a:solidFill>
@@ -3353,7 +3353,7 @@
               </a:lnSpc>
             </a:pPr>
             <a:r>
-              <a:rPr sz="1980" b="0" i="1">
+              <a:rPr sz="2124" b="0" i="1">
                 <a:solidFill>
                   <a:srgbClr val="F2F4F7"/>
                 </a:solidFill>
@@ -3392,7 +3392,7 @@
               </a:lnSpc>
             </a:pPr>
             <a:r>
-              <a:rPr sz="1430" b="0" i="0">
+              <a:rPr sz="1534" b="0" i="0">
                 <a:solidFill>
                   <a:srgbClr val="909CAA"/>
                 </a:solidFill>
@@ -3545,7 +3545,7 @@
               </a:lnSpc>
             </a:pPr>
             <a:r>
-              <a:rPr sz="1430" b="1" i="0">
+              <a:rPr sz="1534" b="1" i="0">
                 <a:solidFill>
                   <a:srgbClr val="C08A2B"/>
                 </a:solidFill>
@@ -3584,7 +3584,7 @@
               </a:lnSpc>
             </a:pPr>
             <a:r>
-              <a:rPr sz="2860" b="1" i="0">
+              <a:rPr sz="3068" b="1" i="0">
                 <a:solidFill>
                   <a:srgbClr val="FFFFFF"/>
                 </a:solidFill>
@@ -3626,7 +3626,7 @@
               </a:spcAft>
             </a:pPr>
             <a:r>
-              <a:rPr sz="2090" b="1">
+              <a:rPr sz="2242" b="1">
                 <a:solidFill>
                   <a:srgbClr val="0F2A43"/>
                 </a:solidFill>
@@ -3635,7 +3635,7 @@
               <a:t>•  Parent treaty: </a:t>
             </a:r>
             <a:r>
-              <a:rPr sz="2090">
+              <a:rPr sz="2242">
                 <a:solidFill>
                   <a:srgbClr val="334455"/>
                 </a:solidFill>
@@ -3654,7 +3654,7 @@
               </a:spcAft>
             </a:pPr>
             <a:r>
-              <a:rPr sz="2090">
+              <a:rPr sz="2242">
                 <a:solidFill>
                   <a:srgbClr val="334455"/>
                 </a:solidFill>
@@ -3673,7 +3673,7 @@
               </a:spcAft>
             </a:pPr>
             <a:r>
-              <a:rPr sz="2090">
+              <a:rPr sz="2242">
                 <a:solidFill>
                   <a:srgbClr val="334455"/>
                 </a:solidFill>
@@ -3692,7 +3692,7 @@
               </a:spcAft>
             </a:pPr>
             <a:r>
-              <a:rPr sz="2090">
+              <a:rPr sz="2242">
                 <a:solidFill>
                   <a:srgbClr val="334455"/>
                 </a:solidFill>
@@ -3711,7 +3711,7 @@
               </a:spcAft>
             </a:pPr>
             <a:r>
-              <a:rPr sz="2090">
+              <a:rPr sz="2242">
                 <a:solidFill>
                   <a:srgbClr val="334455"/>
                 </a:solidFill>
@@ -3838,7 +3838,7 @@
               </a:lnSpc>
             </a:pPr>
             <a:r>
-              <a:rPr sz="1650" b="0" i="1">
+              <a:rPr sz="1770" b="0" i="1">
                 <a:solidFill>
                   <a:srgbClr val="0F2A43"/>
                 </a:solidFill>
@@ -3921,7 +3921,7 @@
               </a:lnSpc>
             </a:pPr>
             <a:r>
-              <a:rPr sz="1210" b="0" i="0">
+              <a:rPr sz="1297" b="0" i="0">
                 <a:solidFill>
                   <a:srgbClr val="6B7682"/>
                 </a:solidFill>
@@ -4074,7 +4074,7 @@
               </a:lnSpc>
             </a:pPr>
             <a:r>
-              <a:rPr sz="1430" b="1" i="0">
+              <a:rPr sz="1534" b="1" i="0">
                 <a:solidFill>
                   <a:srgbClr val="C08A2B"/>
                 </a:solidFill>
@@ -4113,7 +4113,7 @@
               </a:lnSpc>
             </a:pPr>
             <a:r>
-              <a:rPr sz="2860" b="1" i="0">
+              <a:rPr sz="3068" b="1" i="0">
                 <a:solidFill>
                   <a:srgbClr val="FFFFFF"/>
                 </a:solidFill>
@@ -4155,7 +4155,7 @@
               </a:spcAft>
             </a:pPr>
             <a:r>
-              <a:rPr sz="2090" b="1">
+              <a:rPr sz="2242" b="1">
                 <a:solidFill>
                   <a:srgbClr val="0F2A43"/>
                 </a:solidFill>
@@ -4164,7 +4164,7 @@
               <a:t>•  Jurisdiction: </a:t>
             </a:r>
             <a:r>
-              <a:rPr sz="2090">
+              <a:rPr sz="2242">
                 <a:solidFill>
                   <a:srgbClr val="334455"/>
                 </a:solidFill>
@@ -4183,7 +4183,7 @@
               </a:spcAft>
             </a:pPr>
             <a:r>
-              <a:rPr sz="2090" b="1">
+              <a:rPr sz="2242" b="1">
                 <a:solidFill>
                   <a:srgbClr val="0F2A43"/>
                 </a:solidFill>
@@ -4192,7 +4192,7 @@
               <a:t>•  Concurrent claims: </a:t>
             </a:r>
             <a:r>
-              <a:rPr sz="2090">
+              <a:rPr sz="2242">
                 <a:solidFill>
                   <a:srgbClr val="334455"/>
                 </a:solidFill>
@@ -4211,7 +4211,7 @@
               </a:spcAft>
             </a:pPr>
             <a:r>
-              <a:rPr sz="2090" b="1">
+              <a:rPr sz="2242" b="1">
                 <a:solidFill>
                   <a:srgbClr val="0F2A43"/>
                 </a:solidFill>
@@ -4220,7 +4220,7 @@
               <a:t>•  Extradition: </a:t>
             </a:r>
             <a:r>
-              <a:rPr sz="2090">
+              <a:rPr sz="2242">
                 <a:solidFill>
                   <a:srgbClr val="334455"/>
                 </a:solidFill>
@@ -4239,7 +4239,7 @@
               </a:spcAft>
             </a:pPr>
             <a:r>
-              <a:rPr sz="2090" b="1">
+              <a:rPr sz="2242" b="1">
                 <a:solidFill>
                   <a:srgbClr val="0F2A43"/>
                 </a:solidFill>
@@ -4248,7 +4248,7 @@
               <a:t>•  MLATs: </a:t>
             </a:r>
             <a:r>
-              <a:rPr sz="2090">
+              <a:rPr sz="2242">
                 <a:solidFill>
                   <a:srgbClr val="334455"/>
                 </a:solidFill>
@@ -4267,7 +4267,7 @@
               </a:spcAft>
             </a:pPr>
             <a:r>
-              <a:rPr sz="2090" b="1">
+              <a:rPr sz="2242" b="1">
                 <a:solidFill>
                   <a:srgbClr val="0F2A43"/>
                 </a:solidFill>
@@ -4276,7 +4276,7 @@
               <a:t>•  The friction: </a:t>
             </a:r>
             <a:r>
-              <a:rPr sz="2090">
+              <a:rPr sz="2242">
                 <a:solidFill>
                   <a:srgbClr val="334455"/>
                 </a:solidFill>
@@ -4403,7 +4403,7 @@
               </a:lnSpc>
             </a:pPr>
             <a:r>
-              <a:rPr sz="1650" b="0" i="1">
+              <a:rPr sz="1770" b="0" i="1">
                 <a:solidFill>
                   <a:srgbClr val="0F2A43"/>
                 </a:solidFill>
@@ -4486,7 +4486,7 @@
               </a:lnSpc>
             </a:pPr>
             <a:r>
-              <a:rPr sz="1210" b="0" i="0">
+              <a:rPr sz="1297" b="0" i="0">
                 <a:solidFill>
                   <a:srgbClr val="6B7682"/>
                 </a:solidFill>
@@ -4639,7 +4639,7 @@
               </a:lnSpc>
             </a:pPr>
             <a:r>
-              <a:rPr sz="1430" b="1" i="0">
+              <a:rPr sz="1534" b="1" i="0">
                 <a:solidFill>
                   <a:srgbClr val="C08A2B"/>
                 </a:solidFill>
@@ -4678,7 +4678,7 @@
               </a:lnSpc>
             </a:pPr>
             <a:r>
-              <a:rPr sz="2860" b="1" i="0">
+              <a:rPr sz="3068" b="1" i="0">
                 <a:solidFill>
                   <a:srgbClr val="FFFFFF"/>
                 </a:solidFill>
@@ -4720,7 +4720,7 @@
               </a:spcAft>
             </a:pPr>
             <a:r>
-              <a:rPr sz="2090" b="1">
+              <a:rPr sz="2242" b="1">
                 <a:solidFill>
                   <a:srgbClr val="0F2A43"/>
                 </a:solidFill>
@@ -4729,7 +4729,7 @@
               <a:t>•  Ghislaine Maxwell (UK): </a:t>
             </a:r>
             <a:r>
-              <a:rPr sz="2090">
+              <a:rPr sz="2242">
                 <a:solidFill>
                   <a:srgbClr val="334455"/>
                 </a:solidFill>
@@ -4748,7 +4748,7 @@
               </a:spcAft>
             </a:pPr>
             <a:r>
-              <a:rPr sz="2090" b="1">
+              <a:rPr sz="2242" b="1">
                 <a:solidFill>
                   <a:srgbClr val="0F2A43"/>
                 </a:solidFill>
@@ -4757,7 +4757,7 @@
               <a:t>•  Prince Andrew: </a:t>
             </a:r>
             <a:r>
-              <a:rPr sz="2090">
+              <a:rPr sz="2242">
                 <a:solidFill>
                   <a:srgbClr val="334455"/>
                 </a:solidFill>
@@ -4776,7 +4776,7 @@
               </a:spcAft>
             </a:pPr>
             <a:r>
-              <a:rPr sz="2090">
+              <a:rPr sz="2242">
                 <a:solidFill>
                   <a:srgbClr val="334455"/>
                 </a:solidFill>
@@ -4795,7 +4795,7 @@
               </a:spcAft>
             </a:pPr>
             <a:r>
-              <a:rPr sz="2090">
+              <a:rPr sz="2242">
                 <a:solidFill>
                   <a:srgbClr val="334455"/>
                 </a:solidFill>
@@ -4922,7 +4922,7 @@
               </a:lnSpc>
             </a:pPr>
             <a:r>
-              <a:rPr sz="1650" b="0" i="1">
+              <a:rPr sz="1770" b="0" i="1">
                 <a:solidFill>
                   <a:srgbClr val="0F2A43"/>
                 </a:solidFill>
@@ -5005,7 +5005,7 @@
               </a:lnSpc>
             </a:pPr>
             <a:r>
-              <a:rPr sz="1210" b="0" i="0">
+              <a:rPr sz="1297" b="0" i="0">
                 <a:solidFill>
                   <a:srgbClr val="6B7682"/>
                 </a:solidFill>
@@ -5070,7 +5070,7 @@
               </a:lnSpc>
             </a:pPr>
             <a:r>
-              <a:rPr sz="23100" b="1" i="0">
+              <a:rPr sz="24780" b="1" i="0">
                 <a:solidFill>
                   <a:srgbClr val="1C3A56"/>
                 </a:solidFill>
@@ -5109,7 +5109,7 @@
               </a:lnSpc>
             </a:pPr>
             <a:r>
-              <a:rPr sz="1430" b="1" i="0">
+              <a:rPr sz="1534" b="1" i="0">
                 <a:solidFill>
                   <a:srgbClr val="C08A2B"/>
                 </a:solidFill>
@@ -5192,7 +5192,7 @@
               </a:lnSpc>
             </a:pPr>
             <a:r>
-              <a:rPr sz="3630" b="1" i="0">
+              <a:rPr sz="3894" b="1" i="0">
                 <a:solidFill>
                   <a:srgbClr val="FFFFFF"/>
                 </a:solidFill>
@@ -5208,7 +5208,7 @@
               </a:lnSpc>
             </a:pPr>
             <a:r>
-              <a:rPr sz="3630" b="1" i="0">
+              <a:rPr sz="3894" b="1" i="0">
                 <a:solidFill>
                   <a:srgbClr val="FFFFFF"/>
                 </a:solidFill>
@@ -5247,7 +5247,7 @@
               </a:lnSpc>
             </a:pPr>
             <a:r>
-              <a:rPr sz="1980" b="0" i="1">
+              <a:rPr sz="2124" b="0" i="1">
                 <a:solidFill>
                   <a:srgbClr val="F2F4F7"/>
                 </a:solidFill>
@@ -5330,7 +5330,7 @@
               </a:lnSpc>
             </a:pPr>
             <a:r>
-              <a:rPr sz="1210" b="0" i="0">
+              <a:rPr sz="1297" b="0" i="0">
                 <a:solidFill>
                   <a:srgbClr val="909CAA"/>
                 </a:solidFill>
@@ -5483,7 +5483,7 @@
               </a:lnSpc>
             </a:pPr>
             <a:r>
-              <a:rPr sz="1430" b="1" i="0">
+              <a:rPr sz="1534" b="1" i="0">
                 <a:solidFill>
                   <a:srgbClr val="C08A2B"/>
                 </a:solidFill>
@@ -5522,7 +5522,7 @@
               </a:lnSpc>
             </a:pPr>
             <a:r>
-              <a:rPr sz="2860" b="1" i="0">
+              <a:rPr sz="3068" b="1" i="0">
                 <a:solidFill>
                   <a:srgbClr val="FFFFFF"/>
                 </a:solidFill>
@@ -5564,7 +5564,7 @@
               </a:spcAft>
             </a:pPr>
             <a:r>
-              <a:rPr sz="2090">
+              <a:rPr sz="2242">
                 <a:solidFill>
                   <a:srgbClr val="334455"/>
                 </a:solidFill>
@@ -5583,7 +5583,7 @@
               </a:spcAft>
             </a:pPr>
             <a:r>
-              <a:rPr sz="2090">
+              <a:rPr sz="2242">
                 <a:solidFill>
                   <a:srgbClr val="334455"/>
                 </a:solidFill>
@@ -5602,7 +5602,7 @@
               </a:spcAft>
             </a:pPr>
             <a:r>
-              <a:rPr sz="2090">
+              <a:rPr sz="2242">
                 <a:solidFill>
                   <a:srgbClr val="334455"/>
                 </a:solidFill>
@@ -5621,7 +5621,7 @@
               </a:spcAft>
             </a:pPr>
             <a:r>
-              <a:rPr sz="2090">
+              <a:rPr sz="2242">
                 <a:solidFill>
                   <a:srgbClr val="334455"/>
                 </a:solidFill>
@@ -5640,7 +5640,7 @@
               </a:spcAft>
             </a:pPr>
             <a:r>
-              <a:rPr sz="2090">
+              <a:rPr sz="2242">
                 <a:solidFill>
                   <a:srgbClr val="334455"/>
                 </a:solidFill>
@@ -5767,7 +5767,7 @@
               </a:lnSpc>
             </a:pPr>
             <a:r>
-              <a:rPr sz="1650" b="0" i="1">
+              <a:rPr sz="1770" b="0" i="1">
                 <a:solidFill>
                   <a:srgbClr val="0F2A43"/>
                 </a:solidFill>
@@ -5850,7 +5850,7 @@
               </a:lnSpc>
             </a:pPr>
             <a:r>
-              <a:rPr sz="1210" b="0" i="0">
+              <a:rPr sz="1297" b="0" i="0">
                 <a:solidFill>
                   <a:srgbClr val="6B7682"/>
                 </a:solidFill>
@@ -6003,7 +6003,7 @@
               </a:lnSpc>
             </a:pPr>
             <a:r>
-              <a:rPr sz="1430" b="1" i="0">
+              <a:rPr sz="1534" b="1" i="0">
                 <a:solidFill>
                   <a:srgbClr val="C08A2B"/>
                 </a:solidFill>
@@ -6042,7 +6042,7 @@
               </a:lnSpc>
             </a:pPr>
             <a:r>
-              <a:rPr sz="2860" b="1" i="0">
+              <a:rPr sz="3068" b="1" i="0">
                 <a:solidFill>
                   <a:srgbClr val="FFFFFF"/>
                 </a:solidFill>
@@ -6169,7 +6169,7 @@
               </a:lnSpc>
             </a:pPr>
             <a:r>
-              <a:rPr sz="1760" b="1" i="0">
+              <a:rPr sz="1888" b="1" i="0">
                 <a:solidFill>
                   <a:srgbClr val="C08A2B"/>
                 </a:solidFill>
@@ -6211,7 +6211,7 @@
               </a:spcAft>
             </a:pPr>
             <a:r>
-              <a:rPr sz="1650">
+              <a:rPr sz="1770">
                 <a:solidFill>
                   <a:srgbClr val="334455"/>
                 </a:solidFill>
@@ -6230,7 +6230,7 @@
               </a:spcAft>
             </a:pPr>
             <a:r>
-              <a:rPr sz="1650">
+              <a:rPr sz="1770">
                 <a:solidFill>
                   <a:srgbClr val="334455"/>
                 </a:solidFill>
@@ -6249,7 +6249,7 @@
               </a:spcAft>
             </a:pPr>
             <a:r>
-              <a:rPr sz="1650">
+              <a:rPr sz="1770">
                 <a:solidFill>
                   <a:srgbClr val="334455"/>
                 </a:solidFill>
@@ -6268,7 +6268,7 @@
               </a:spcAft>
             </a:pPr>
             <a:r>
-              <a:rPr sz="1650">
+              <a:rPr sz="1770">
                 <a:solidFill>
                   <a:srgbClr val="334455"/>
                 </a:solidFill>
@@ -6395,7 +6395,7 @@
               </a:lnSpc>
             </a:pPr>
             <a:r>
-              <a:rPr sz="1760" b="1" i="0">
+              <a:rPr sz="1888" b="1" i="0">
                 <a:solidFill>
                   <a:srgbClr val="C08A2B"/>
                 </a:solidFill>
@@ -6437,7 +6437,7 @@
               </a:spcAft>
             </a:pPr>
             <a:r>
-              <a:rPr sz="1650">
+              <a:rPr sz="1770">
                 <a:solidFill>
                   <a:srgbClr val="F2F4F7"/>
                 </a:solidFill>
@@ -6456,7 +6456,7 @@
               </a:spcAft>
             </a:pPr>
             <a:r>
-              <a:rPr sz="1650">
+              <a:rPr sz="1770">
                 <a:solidFill>
                   <a:srgbClr val="F2F4F7"/>
                 </a:solidFill>
@@ -6475,7 +6475,7 @@
               </a:spcAft>
             </a:pPr>
             <a:r>
-              <a:rPr sz="1650">
+              <a:rPr sz="1770">
                 <a:solidFill>
                   <a:srgbClr val="F2F4F7"/>
                 </a:solidFill>
@@ -6494,7 +6494,7 @@
               </a:spcAft>
             </a:pPr>
             <a:r>
-              <a:rPr sz="1650">
+              <a:rPr sz="1770">
                 <a:solidFill>
                   <a:srgbClr val="F2F4F7"/>
                 </a:solidFill>
@@ -6621,7 +6621,7 @@
               </a:lnSpc>
             </a:pPr>
             <a:r>
-              <a:rPr sz="1650" b="0" i="1">
+              <a:rPr sz="1770" b="0" i="1">
                 <a:solidFill>
                   <a:srgbClr val="0F2A43"/>
                 </a:solidFill>
@@ -6704,7 +6704,7 @@
               </a:lnSpc>
             </a:pPr>
             <a:r>
-              <a:rPr sz="1210" b="0" i="0">
+              <a:rPr sz="1297" b="0" i="0">
                 <a:solidFill>
                   <a:srgbClr val="6B7682"/>
                 </a:solidFill>
@@ -6857,7 +6857,7 @@
               </a:lnSpc>
             </a:pPr>
             <a:r>
-              <a:rPr sz="1430" b="1" i="0">
+              <a:rPr sz="1534" b="1" i="0">
                 <a:solidFill>
                   <a:srgbClr val="C08A2B"/>
                 </a:solidFill>
@@ -6896,7 +6896,7 @@
               </a:lnSpc>
             </a:pPr>
             <a:r>
-              <a:rPr sz="2860" b="1" i="0">
+              <a:rPr sz="3068" b="1" i="0">
                 <a:solidFill>
                   <a:srgbClr val="FFFFFF"/>
                 </a:solidFill>
@@ -6938,7 +6938,7 @@
               </a:spcAft>
             </a:pPr>
             <a:r>
-              <a:rPr sz="2090" b="1">
+              <a:rPr sz="2242" b="1">
                 <a:solidFill>
                   <a:srgbClr val="0F2A43"/>
                 </a:solidFill>
@@ -6947,7 +6947,7 @@
               <a:t>•  Adversarial vs inquisitorial: </a:t>
             </a:r>
             <a:r>
-              <a:rPr sz="2090">
+              <a:rPr sz="2242">
                 <a:solidFill>
                   <a:srgbClr val="334455"/>
                 </a:solidFill>
@@ -6966,7 +6966,7 @@
               </a:spcAft>
             </a:pPr>
             <a:r>
-              <a:rPr sz="2090" b="1">
+              <a:rPr sz="2242" b="1">
                 <a:solidFill>
                   <a:srgbClr val="0F2A43"/>
                 </a:solidFill>
@@ -6975,7 +6975,7 @@
               <a:t>•  Victim participation: </a:t>
             </a:r>
             <a:r>
-              <a:rPr sz="2090">
+              <a:rPr sz="2242">
                 <a:solidFill>
                   <a:srgbClr val="334455"/>
                 </a:solidFill>
@@ -6994,7 +6994,7 @@
               </a:spcAft>
             </a:pPr>
             <a:r>
-              <a:rPr sz="2090" b="1">
+              <a:rPr sz="2242" b="1">
                 <a:solidFill>
                   <a:srgbClr val="0F2A43"/>
                 </a:solidFill>
@@ -7003,7 +7003,7 @@
               <a:t>•  Limitation periods: </a:t>
             </a:r>
             <a:r>
-              <a:rPr sz="2090">
+              <a:rPr sz="2242">
                 <a:solidFill>
                   <a:srgbClr val="334455"/>
                 </a:solidFill>
@@ -7022,7 +7022,7 @@
               </a:spcAft>
             </a:pPr>
             <a:r>
-              <a:rPr sz="2090" b="1">
+              <a:rPr sz="2242" b="1">
                 <a:solidFill>
                   <a:srgbClr val="0F2A43"/>
                 </a:solidFill>
@@ -7031,7 +7031,7 @@
               <a:t>•  Plea bargaining: </a:t>
             </a:r>
             <a:r>
-              <a:rPr sz="2090">
+              <a:rPr sz="2242">
                 <a:solidFill>
                   <a:srgbClr val="334455"/>
                 </a:solidFill>
@@ -7158,7 +7158,7 @@
               </a:lnSpc>
             </a:pPr>
             <a:r>
-              <a:rPr sz="1650" b="0" i="1">
+              <a:rPr sz="1770" b="0" i="1">
                 <a:solidFill>
                   <a:srgbClr val="0F2A43"/>
                 </a:solidFill>
@@ -7241,7 +7241,7 @@
               </a:lnSpc>
             </a:pPr>
             <a:r>
-              <a:rPr sz="1210" b="0" i="0">
+              <a:rPr sz="1297" b="0" i="0">
                 <a:solidFill>
                   <a:srgbClr val="6B7682"/>
                 </a:solidFill>
@@ -7306,7 +7306,7 @@
               </a:lnSpc>
             </a:pPr>
             <a:r>
-              <a:rPr sz="23100" b="1" i="0">
+              <a:rPr sz="24780" b="1" i="0">
                 <a:solidFill>
                   <a:srgbClr val="1C3A56"/>
                 </a:solidFill>
@@ -7345,7 +7345,7 @@
               </a:lnSpc>
             </a:pPr>
             <a:r>
-              <a:rPr sz="1430" b="1" i="0">
+              <a:rPr sz="1534" b="1" i="0">
                 <a:solidFill>
                   <a:srgbClr val="C08A2B"/>
                 </a:solidFill>
@@ -7428,7 +7428,7 @@
               </a:lnSpc>
             </a:pPr>
             <a:r>
-              <a:rPr sz="3630" b="1" i="0">
+              <a:rPr sz="3894" b="1" i="0">
                 <a:solidFill>
                   <a:srgbClr val="FFFFFF"/>
                 </a:solidFill>
@@ -7444,7 +7444,7 @@
               </a:lnSpc>
             </a:pPr>
             <a:r>
-              <a:rPr sz="3630" b="1" i="0">
+              <a:rPr sz="3894" b="1" i="0">
                 <a:solidFill>
                   <a:srgbClr val="FFFFFF"/>
                 </a:solidFill>
@@ -7483,7 +7483,7 @@
               </a:lnSpc>
             </a:pPr>
             <a:r>
-              <a:rPr sz="1980" b="0" i="1">
+              <a:rPr sz="2124" b="0" i="1">
                 <a:solidFill>
                   <a:srgbClr val="F2F4F7"/>
                 </a:solidFill>
@@ -7566,7 +7566,7 @@
               </a:lnSpc>
             </a:pPr>
             <a:r>
-              <a:rPr sz="1210" b="0" i="0">
+              <a:rPr sz="1297" b="0" i="0">
                 <a:solidFill>
                   <a:srgbClr val="909CAA"/>
                 </a:solidFill>
@@ -7719,7 +7719,7 @@
               </a:lnSpc>
             </a:pPr>
             <a:r>
-              <a:rPr sz="1430" b="1" i="0">
+              <a:rPr sz="1534" b="1" i="0">
                 <a:solidFill>
                   <a:srgbClr val="C08A2B"/>
                 </a:solidFill>
@@ -7758,7 +7758,7 @@
               </a:lnSpc>
             </a:pPr>
             <a:r>
-              <a:rPr sz="2860" b="1" i="0">
+              <a:rPr sz="3068" b="1" i="0">
                 <a:solidFill>
                   <a:srgbClr val="FFFFFF"/>
                 </a:solidFill>
@@ -7800,7 +7800,7 @@
               </a:spcAft>
             </a:pPr>
             <a:r>
-              <a:rPr sz="2090">
+              <a:rPr sz="2242">
                 <a:solidFill>
                   <a:srgbClr val="334455"/>
                 </a:solidFill>
@@ -7819,7 +7819,7 @@
               </a:spcAft>
             </a:pPr>
             <a:r>
-              <a:rPr sz="2090">
+              <a:rPr sz="2242">
                 <a:solidFill>
                   <a:srgbClr val="334455"/>
                 </a:solidFill>
@@ -7838,7 +7838,7 @@
               </a:spcAft>
             </a:pPr>
             <a:r>
-              <a:rPr sz="2090" b="1">
+              <a:rPr sz="2242" b="1">
                 <a:solidFill>
                   <a:srgbClr val="0F2A43"/>
                 </a:solidFill>
@@ -7847,7 +7847,7 @@
               <a:t>•  Survivors' concern: </a:t>
             </a:r>
             <a:r>
-              <a:rPr sz="2090">
+              <a:rPr sz="2242">
                 <a:solidFill>
                   <a:srgbClr val="334455"/>
                 </a:solidFill>
@@ -7866,7 +7866,7 @@
               </a:spcAft>
             </a:pPr>
             <a:r>
-              <a:rPr sz="2090">
+              <a:rPr sz="2242">
                 <a:solidFill>
                   <a:srgbClr val="334455"/>
                 </a:solidFill>
@@ -7993,7 +7993,7 @@
               </a:lnSpc>
             </a:pPr>
             <a:r>
-              <a:rPr sz="1650" b="0" i="1">
+              <a:rPr sz="1770" b="0" i="1">
                 <a:solidFill>
                   <a:srgbClr val="0F2A43"/>
                 </a:solidFill>
@@ -8076,7 +8076,7 @@
               </a:lnSpc>
             </a:pPr>
             <a:r>
-              <a:rPr sz="1210" b="0" i="0">
+              <a:rPr sz="1297" b="0" i="0">
                 <a:solidFill>
                   <a:srgbClr val="6B7682"/>
                 </a:solidFill>
@@ -8229,7 +8229,7 @@
               </a:lnSpc>
             </a:pPr>
             <a:r>
-              <a:rPr sz="1430" b="1" i="0">
+              <a:rPr sz="1534" b="1" i="0">
                 <a:solidFill>
                   <a:srgbClr val="C08A2B"/>
                 </a:solidFill>
@@ -8268,7 +8268,7 @@
               </a:lnSpc>
             </a:pPr>
             <a:r>
-              <a:rPr sz="2860" b="1" i="0">
+              <a:rPr sz="3068" b="1" i="0">
                 <a:solidFill>
                   <a:srgbClr val="FFFFFF"/>
                 </a:solidFill>
@@ -8310,7 +8310,7 @@
               </a:spcAft>
             </a:pPr>
             <a:r>
-              <a:rPr sz="1980">
+              <a:rPr sz="2124">
                 <a:solidFill>
                   <a:srgbClr val="334455"/>
                 </a:solidFill>
@@ -8329,7 +8329,7 @@
               </a:spcAft>
             </a:pPr>
             <a:r>
-              <a:rPr sz="1980">
+              <a:rPr sz="2124">
                 <a:solidFill>
                   <a:srgbClr val="334455"/>
                 </a:solidFill>
@@ -8348,7 +8348,7 @@
               </a:spcAft>
             </a:pPr>
             <a:r>
-              <a:rPr sz="1980">
+              <a:rPr sz="2124">
                 <a:solidFill>
                   <a:srgbClr val="334455"/>
                 </a:solidFill>
@@ -8367,7 +8367,7 @@
               </a:spcAft>
             </a:pPr>
             <a:r>
-              <a:rPr sz="1980">
+              <a:rPr sz="2124">
                 <a:solidFill>
                   <a:srgbClr val="334455"/>
                 </a:solidFill>
@@ -8494,7 +8494,7 @@
               </a:lnSpc>
             </a:pPr>
             <a:r>
-              <a:rPr sz="1540" b="1" i="0">
+              <a:rPr sz="1652" b="1" i="0">
                 <a:solidFill>
                   <a:srgbClr val="C08A2B"/>
                 </a:solidFill>
@@ -8533,7 +8533,7 @@
               </a:lnSpc>
             </a:pPr>
             <a:r>
-              <a:rPr sz="1650" b="0" i="1">
+              <a:rPr sz="1770" b="0" i="1">
                 <a:solidFill>
                   <a:srgbClr val="334455"/>
                 </a:solidFill>
@@ -8660,7 +8660,7 @@
               </a:lnSpc>
             </a:pPr>
             <a:r>
-              <a:rPr sz="1650" b="0" i="1">
+              <a:rPr sz="1770" b="0" i="1">
                 <a:solidFill>
                   <a:srgbClr val="0F2A43"/>
                 </a:solidFill>
@@ -8743,7 +8743,7 @@
               </a:lnSpc>
             </a:pPr>
             <a:r>
-              <a:rPr sz="1210" b="0" i="0">
+              <a:rPr sz="1297" b="0" i="0">
                 <a:solidFill>
                   <a:srgbClr val="6B7682"/>
                 </a:solidFill>
@@ -8896,7 +8896,7 @@
               </a:lnSpc>
             </a:pPr>
             <a:r>
-              <a:rPr sz="1430" b="1" i="0">
+              <a:rPr sz="1534" b="1" i="0">
                 <a:solidFill>
                   <a:srgbClr val="C08A2B"/>
                 </a:solidFill>
@@ -8935,7 +8935,7 @@
               </a:lnSpc>
             </a:pPr>
             <a:r>
-              <a:rPr sz="2860" b="1" i="0">
+              <a:rPr sz="3068" b="1" i="0">
                 <a:solidFill>
                   <a:srgbClr val="FFFFFF"/>
                 </a:solidFill>
@@ -9062,7 +9062,7 @@
               </a:lnSpc>
             </a:pPr>
             <a:r>
-              <a:rPr sz="2090" b="1" i="1">
+              <a:rPr sz="2242" b="1" i="1">
                 <a:solidFill>
                   <a:srgbClr val="0F2A43"/>
                 </a:solidFill>
@@ -9104,7 +9104,7 @@
               </a:spcAft>
             </a:pPr>
             <a:r>
-              <a:rPr sz="2090">
+              <a:rPr sz="2242">
                 <a:solidFill>
                   <a:srgbClr val="334455"/>
                 </a:solidFill>
@@ -9123,7 +9123,7 @@
               </a:spcAft>
             </a:pPr>
             <a:r>
-              <a:rPr sz="2090">
+              <a:rPr sz="2242">
                 <a:solidFill>
                   <a:srgbClr val="334455"/>
                 </a:solidFill>
@@ -9142,7 +9142,7 @@
               </a:spcAft>
             </a:pPr>
             <a:r>
-              <a:rPr sz="2090">
+              <a:rPr sz="2242">
                 <a:solidFill>
                   <a:srgbClr val="334455"/>
                 </a:solidFill>
@@ -9161,7 +9161,7 @@
               </a:spcAft>
             </a:pPr>
             <a:r>
-              <a:rPr sz="2090">
+              <a:rPr sz="2242">
                 <a:solidFill>
                   <a:srgbClr val="334455"/>
                 </a:solidFill>
@@ -9288,7 +9288,7 @@
               </a:lnSpc>
             </a:pPr>
             <a:r>
-              <a:rPr sz="1650" b="0" i="1">
+              <a:rPr sz="1770" b="0" i="1">
                 <a:solidFill>
                   <a:srgbClr val="0F2A43"/>
                 </a:solidFill>
@@ -9371,7 +9371,7 @@
               </a:lnSpc>
             </a:pPr>
             <a:r>
-              <a:rPr sz="1210" b="0" i="0">
+              <a:rPr sz="1297" b="0" i="0">
                 <a:solidFill>
                   <a:srgbClr val="6B7682"/>
                 </a:solidFill>
@@ -9524,7 +9524,7 @@
               </a:lnSpc>
             </a:pPr>
             <a:r>
-              <a:rPr sz="1430" b="1" i="0">
+              <a:rPr sz="1534" b="1" i="0">
                 <a:solidFill>
                   <a:srgbClr val="C08A2B"/>
                 </a:solidFill>
@@ -9563,7 +9563,7 @@
               </a:lnSpc>
             </a:pPr>
             <a:r>
-              <a:rPr sz="2860" b="1" i="0">
+              <a:rPr sz="3068" b="1" i="0">
                 <a:solidFill>
                   <a:srgbClr val="FFFFFF"/>
                 </a:solidFill>
@@ -9646,7 +9646,7 @@
               </a:lnSpc>
             </a:pPr>
             <a:r>
-              <a:rPr sz="2640" b="1" i="0">
+              <a:rPr sz="2832" b="1" i="0">
                 <a:solidFill>
                   <a:srgbClr val="FFFFFF"/>
                 </a:solidFill>
@@ -9685,7 +9685,7 @@
               </a:lnSpc>
             </a:pPr>
             <a:r>
-              <a:rPr sz="1980" b="1" i="0">
+              <a:rPr sz="2124" b="1" i="0">
                 <a:solidFill>
                   <a:srgbClr val="0F2A43"/>
                 </a:solidFill>
@@ -9724,7 +9724,7 @@
               </a:lnSpc>
             </a:pPr>
             <a:r>
-              <a:rPr sz="1540" b="0" i="1">
+              <a:rPr sz="1652" b="0" i="1">
                 <a:solidFill>
                   <a:srgbClr val="334455"/>
                 </a:solidFill>
@@ -9807,7 +9807,7 @@
               </a:lnSpc>
             </a:pPr>
             <a:r>
-              <a:rPr sz="2640" b="1" i="0">
+              <a:rPr sz="2832" b="1" i="0">
                 <a:solidFill>
                   <a:srgbClr val="FFFFFF"/>
                 </a:solidFill>
@@ -9846,7 +9846,7 @@
               </a:lnSpc>
             </a:pPr>
             <a:r>
-              <a:rPr sz="1980" b="1" i="0">
+              <a:rPr sz="2124" b="1" i="0">
                 <a:solidFill>
                   <a:srgbClr val="0F2A43"/>
                 </a:solidFill>
@@ -9885,7 +9885,7 @@
               </a:lnSpc>
             </a:pPr>
             <a:r>
-              <a:rPr sz="1540" b="0" i="1">
+              <a:rPr sz="1652" b="0" i="1">
                 <a:solidFill>
                   <a:srgbClr val="334455"/>
                 </a:solidFill>
@@ -9968,7 +9968,7 @@
               </a:lnSpc>
             </a:pPr>
             <a:r>
-              <a:rPr sz="2640" b="1" i="0">
+              <a:rPr sz="2832" b="1" i="0">
                 <a:solidFill>
                   <a:srgbClr val="FFFFFF"/>
                 </a:solidFill>
@@ -10007,7 +10007,7 @@
               </a:lnSpc>
             </a:pPr>
             <a:r>
-              <a:rPr sz="1980" b="1" i="0">
+              <a:rPr sz="2124" b="1" i="0">
                 <a:solidFill>
                   <a:srgbClr val="0F2A43"/>
                 </a:solidFill>
@@ -10046,7 +10046,7 @@
               </a:lnSpc>
             </a:pPr>
             <a:r>
-              <a:rPr sz="1540" b="0" i="1">
+              <a:rPr sz="1652" b="0" i="1">
                 <a:solidFill>
                   <a:srgbClr val="334455"/>
                 </a:solidFill>
@@ -10129,7 +10129,7 @@
               </a:lnSpc>
             </a:pPr>
             <a:r>
-              <a:rPr sz="2640" b="1" i="0">
+              <a:rPr sz="2832" b="1" i="0">
                 <a:solidFill>
                   <a:srgbClr val="FFFFFF"/>
                 </a:solidFill>
@@ -10168,7 +10168,7 @@
               </a:lnSpc>
             </a:pPr>
             <a:r>
-              <a:rPr sz="1980" b="1" i="0">
+              <a:rPr sz="2124" b="1" i="0">
                 <a:solidFill>
                   <a:srgbClr val="0F2A43"/>
                 </a:solidFill>
@@ -10207,7 +10207,7 @@
               </a:lnSpc>
             </a:pPr>
             <a:r>
-              <a:rPr sz="1540" b="0" i="1">
+              <a:rPr sz="1652" b="0" i="1">
                 <a:solidFill>
                   <a:srgbClr val="334455"/>
                 </a:solidFill>
@@ -10334,7 +10334,7 @@
               </a:lnSpc>
             </a:pPr>
             <a:r>
-              <a:rPr sz="1210" b="1" i="0">
+              <a:rPr sz="1297" b="1" i="0">
                 <a:solidFill>
                   <a:srgbClr val="C08A2B"/>
                 </a:solidFill>
@@ -10373,7 +10373,7 @@
               </a:lnSpc>
             </a:pPr>
             <a:r>
-              <a:rPr sz="1210" b="0" i="0">
+              <a:rPr sz="1297" b="0" i="0">
                 <a:solidFill>
                   <a:srgbClr val="334455"/>
                 </a:solidFill>
@@ -10456,7 +10456,7 @@
               </a:lnSpc>
             </a:pPr>
             <a:r>
-              <a:rPr sz="1210" b="0" i="0">
+              <a:rPr sz="1297" b="0" i="0">
                 <a:solidFill>
                   <a:srgbClr val="6B7682"/>
                 </a:solidFill>
@@ -10521,7 +10521,7 @@
               </a:lnSpc>
             </a:pPr>
             <a:r>
-              <a:rPr sz="23100" b="1" i="0">
+              <a:rPr sz="24780" b="1" i="0">
                 <a:solidFill>
                   <a:srgbClr val="1C3A56"/>
                 </a:solidFill>
@@ -10560,7 +10560,7 @@
               </a:lnSpc>
             </a:pPr>
             <a:r>
-              <a:rPr sz="1430" b="1" i="0">
+              <a:rPr sz="1534" b="1" i="0">
                 <a:solidFill>
                   <a:srgbClr val="C08A2B"/>
                 </a:solidFill>
@@ -10643,7 +10643,7 @@
               </a:lnSpc>
             </a:pPr>
             <a:r>
-              <a:rPr sz="3630" b="1" i="0">
+              <a:rPr sz="3894" b="1" i="0">
                 <a:solidFill>
                   <a:srgbClr val="FFFFFF"/>
                 </a:solidFill>
@@ -10659,7 +10659,7 @@
               </a:lnSpc>
             </a:pPr>
             <a:r>
-              <a:rPr sz="3630" b="1" i="0">
+              <a:rPr sz="3894" b="1" i="0">
                 <a:solidFill>
                   <a:srgbClr val="FFFFFF"/>
                 </a:solidFill>
@@ -10698,7 +10698,7 @@
               </a:lnSpc>
             </a:pPr>
             <a:r>
-              <a:rPr sz="1980" b="0" i="1">
+              <a:rPr sz="2124" b="0" i="1">
                 <a:solidFill>
                   <a:srgbClr val="F2F4F7"/>
                 </a:solidFill>
@@ -10781,7 +10781,7 @@
               </a:lnSpc>
             </a:pPr>
             <a:r>
-              <a:rPr sz="1210" b="0" i="0">
+              <a:rPr sz="1297" b="0" i="0">
                 <a:solidFill>
                   <a:srgbClr val="909CAA"/>
                 </a:solidFill>
@@ -10934,7 +10934,7 @@
               </a:lnSpc>
             </a:pPr>
             <a:r>
-              <a:rPr sz="1430" b="1" i="0">
+              <a:rPr sz="1534" b="1" i="0">
                 <a:solidFill>
                   <a:srgbClr val="C08A2B"/>
                 </a:solidFill>
@@ -10973,7 +10973,7 @@
               </a:lnSpc>
             </a:pPr>
             <a:r>
-              <a:rPr sz="2860" b="1" i="0">
+              <a:rPr sz="3068" b="1" i="0">
                 <a:solidFill>
                   <a:srgbClr val="FFFFFF"/>
                 </a:solidFill>
@@ -11015,7 +11015,7 @@
               </a:spcAft>
             </a:pPr>
             <a:r>
-              <a:rPr sz="1980">
+              <a:rPr sz="2124">
                 <a:solidFill>
                   <a:srgbClr val="334455"/>
                 </a:solidFill>
@@ -11034,7 +11034,7 @@
               </a:spcAft>
             </a:pPr>
             <a:r>
-              <a:rPr sz="1980" b="1">
+              <a:rPr sz="2124" b="1">
                 <a:solidFill>
                   <a:srgbClr val="0F2A43"/>
                 </a:solidFill>
@@ -11043,7 +11043,7 @@
               <a:t>•  2005–06: </a:t>
             </a:r>
             <a:r>
-              <a:rPr sz="1980">
+              <a:rPr sz="2124">
                 <a:solidFill>
                   <a:srgbClr val="334455"/>
                 </a:solidFill>
@@ -11062,7 +11062,7 @@
               </a:spcAft>
             </a:pPr>
             <a:r>
-              <a:rPr sz="1980" b="1">
+              <a:rPr sz="2124" b="1">
                 <a:solidFill>
                   <a:srgbClr val="0F2A43"/>
                 </a:solidFill>
@@ -11071,7 +11071,7 @@
               <a:t>•  2008: </a:t>
             </a:r>
             <a:r>
-              <a:rPr sz="1980">
+              <a:rPr sz="2124">
                 <a:solidFill>
                   <a:srgbClr val="334455"/>
                 </a:solidFill>
@@ -11090,7 +11090,7 @@
               </a:spcAft>
             </a:pPr>
             <a:r>
-              <a:rPr sz="1980" b="1">
+              <a:rPr sz="2124" b="1">
                 <a:solidFill>
                   <a:srgbClr val="0F2A43"/>
                 </a:solidFill>
@@ -11099,7 +11099,7 @@
               <a:t>•  2019: </a:t>
             </a:r>
             <a:r>
-              <a:rPr sz="1980">
+              <a:rPr sz="2124">
                 <a:solidFill>
                   <a:srgbClr val="334455"/>
                 </a:solidFill>
@@ -11118,7 +11118,7 @@
               </a:spcAft>
             </a:pPr>
             <a:r>
-              <a:rPr sz="1980">
+              <a:rPr sz="2124">
                 <a:solidFill>
                   <a:srgbClr val="334455"/>
                 </a:solidFill>
@@ -11245,7 +11245,7 @@
               </a:lnSpc>
             </a:pPr>
             <a:r>
-              <a:rPr sz="1540" b="1" i="0">
+              <a:rPr sz="1652" b="1" i="0">
                 <a:solidFill>
                   <a:srgbClr val="C08A2B"/>
                 </a:solidFill>
@@ -11284,7 +11284,7 @@
               </a:lnSpc>
             </a:pPr>
             <a:r>
-              <a:rPr sz="1760" b="0" i="1">
+              <a:rPr sz="1888" b="0" i="1">
                 <a:solidFill>
                   <a:srgbClr val="334455"/>
                 </a:solidFill>
@@ -11411,7 +11411,7 @@
               </a:lnSpc>
             </a:pPr>
             <a:r>
-              <a:rPr sz="1650" b="0" i="1">
+              <a:rPr sz="1770" b="0" i="1">
                 <a:solidFill>
                   <a:srgbClr val="0F2A43"/>
                 </a:solidFill>
@@ -11494,7 +11494,7 @@
               </a:lnSpc>
             </a:pPr>
             <a:r>
-              <a:rPr sz="1210" b="0" i="0">
+              <a:rPr sz="1297" b="0" i="0">
                 <a:solidFill>
                   <a:srgbClr val="6B7682"/>
                 </a:solidFill>
@@ -11647,7 +11647,7 @@
               </a:lnSpc>
             </a:pPr>
             <a:r>
-              <a:rPr sz="1430" b="1" i="0">
+              <a:rPr sz="1534" b="1" i="0">
                 <a:solidFill>
                   <a:srgbClr val="C08A2B"/>
                 </a:solidFill>
@@ -11686,7 +11686,7 @@
               </a:lnSpc>
             </a:pPr>
             <a:r>
-              <a:rPr sz="2860" b="1" i="0">
+              <a:rPr sz="3068" b="1" i="0">
                 <a:solidFill>
                   <a:srgbClr val="FFFFFF"/>
                 </a:solidFill>
@@ -11813,7 +11813,7 @@
               </a:lnSpc>
             </a:pPr>
             <a:r>
-              <a:rPr sz="3080" b="1" i="0">
+              <a:rPr sz="3304" b="1" i="0">
                 <a:solidFill>
                   <a:srgbClr val="FFFFFF"/>
                 </a:solidFill>
@@ -11896,7 +11896,7 @@
               </a:lnSpc>
             </a:pPr>
             <a:r>
-              <a:rPr sz="1540" b="0" i="0">
+              <a:rPr sz="1652" b="0" i="0">
                 <a:solidFill>
                   <a:srgbClr val="334455"/>
                 </a:solidFill>
@@ -11979,7 +11979,7 @@
               </a:lnSpc>
             </a:pPr>
             <a:r>
-              <a:rPr sz="3080" b="1" i="0">
+              <a:rPr sz="3304" b="1" i="0">
                 <a:solidFill>
                   <a:srgbClr val="FFFFFF"/>
                 </a:solidFill>
@@ -12062,7 +12062,7 @@
               </a:lnSpc>
             </a:pPr>
             <a:r>
-              <a:rPr sz="1540" b="0" i="0">
+              <a:rPr sz="1652" b="0" i="0">
                 <a:solidFill>
                   <a:srgbClr val="334455"/>
                 </a:solidFill>
@@ -12145,7 +12145,7 @@
               </a:lnSpc>
             </a:pPr>
             <a:r>
-              <a:rPr sz="3080" b="1" i="0">
+              <a:rPr sz="3304" b="1" i="0">
                 <a:solidFill>
                   <a:srgbClr val="FFFFFF"/>
                 </a:solidFill>
@@ -12228,7 +12228,7 @@
               </a:lnSpc>
             </a:pPr>
             <a:r>
-              <a:rPr sz="1540" b="0" i="0">
+              <a:rPr sz="1652" b="0" i="0">
                 <a:solidFill>
                   <a:srgbClr val="334455"/>
                 </a:solidFill>
@@ -12311,7 +12311,7 @@
               </a:lnSpc>
             </a:pPr>
             <a:r>
-              <a:rPr sz="3080" b="1" i="0">
+              <a:rPr sz="3304" b="1" i="0">
                 <a:solidFill>
                   <a:srgbClr val="FFFFFF"/>
                 </a:solidFill>
@@ -12394,7 +12394,7 @@
               </a:lnSpc>
             </a:pPr>
             <a:r>
-              <a:rPr sz="1540" b="0" i="0">
+              <a:rPr sz="1652" b="0" i="0">
                 <a:solidFill>
                   <a:srgbClr val="334455"/>
                 </a:solidFill>
@@ -12521,7 +12521,7 @@
               </a:lnSpc>
             </a:pPr>
             <a:r>
-              <a:rPr sz="1650" b="0" i="1">
+              <a:rPr sz="1770" b="0" i="1">
                 <a:solidFill>
                   <a:srgbClr val="0F2A43"/>
                 </a:solidFill>
@@ -12604,7 +12604,7 @@
               </a:lnSpc>
             </a:pPr>
             <a:r>
-              <a:rPr sz="1210" b="0" i="0">
+              <a:rPr sz="1297" b="0" i="0">
                 <a:solidFill>
                   <a:srgbClr val="6B7682"/>
                 </a:solidFill>
@@ -12757,7 +12757,7 @@
               </a:lnSpc>
             </a:pPr>
             <a:r>
-              <a:rPr sz="1430" b="1" i="0">
+              <a:rPr sz="1534" b="1" i="0">
                 <a:solidFill>
                   <a:srgbClr val="C08A2B"/>
                 </a:solidFill>
@@ -12796,7 +12796,7 @@
               </a:lnSpc>
             </a:pPr>
             <a:r>
-              <a:rPr sz="2860" b="1" i="0">
+              <a:rPr sz="3068" b="1" i="0">
                 <a:solidFill>
                   <a:srgbClr val="FFFFFF"/>
                 </a:solidFill>
@@ -12838,7 +12838,7 @@
               </a:spcAft>
             </a:pPr>
             <a:r>
-              <a:rPr sz="1980" b="1">
+              <a:rPr sz="2124" b="1">
                 <a:solidFill>
                   <a:srgbClr val="0F2A43"/>
                 </a:solidFill>
@@ -12847,7 +12847,7 @@
               <a:t>•  Recruitment: </a:t>
             </a:r>
             <a:r>
-              <a:rPr sz="1980">
+              <a:rPr sz="2124">
                 <a:solidFill>
                   <a:srgbClr val="334455"/>
                 </a:solidFill>
@@ -12866,7 +12866,7 @@
               </a:spcAft>
             </a:pPr>
             <a:r>
-              <a:rPr sz="1980" b="1">
+              <a:rPr sz="2124" b="1">
                 <a:solidFill>
                   <a:srgbClr val="0F2A43"/>
                 </a:solidFill>
@@ -12875,7 +12875,7 @@
               <a:t>•  Finance: </a:t>
             </a:r>
             <a:r>
-              <a:rPr sz="1980">
+              <a:rPr sz="2124">
                 <a:solidFill>
                   <a:srgbClr val="334455"/>
                 </a:solidFill>
@@ -12894,7 +12894,7 @@
               </a:spcAft>
             </a:pPr>
             <a:r>
-              <a:rPr sz="1980" b="1">
+              <a:rPr sz="2124" b="1">
                 <a:solidFill>
                   <a:srgbClr val="0F2A43"/>
                 </a:solidFill>
@@ -12903,7 +12903,7 @@
               <a:t>•  Property: </a:t>
             </a:r>
             <a:r>
-              <a:rPr sz="1980">
+              <a:rPr sz="2124">
                 <a:solidFill>
                   <a:srgbClr val="334455"/>
                 </a:solidFill>
@@ -12922,7 +12922,7 @@
               </a:spcAft>
             </a:pPr>
             <a:r>
-              <a:rPr sz="1980" b="1">
+              <a:rPr sz="2124" b="1">
                 <a:solidFill>
                   <a:srgbClr val="0F2A43"/>
                 </a:solidFill>
@@ -12931,7 +12931,7 @@
               <a:t>•  Identity: </a:t>
             </a:r>
             <a:r>
-              <a:rPr sz="1980">
+              <a:rPr sz="2124">
                 <a:solidFill>
                   <a:srgbClr val="334455"/>
                 </a:solidFill>
@@ -12950,7 +12950,7 @@
               </a:spcAft>
             </a:pPr>
             <a:r>
-              <a:rPr sz="1980" b="1">
+              <a:rPr sz="2124" b="1">
                 <a:solidFill>
                   <a:srgbClr val="0F2A43"/>
                 </a:solidFill>
@@ -12959,7 +12959,7 @@
               <a:t>•  Network: </a:t>
             </a:r>
             <a:r>
-              <a:rPr sz="1980">
+              <a:rPr sz="2124">
                 <a:solidFill>
                   <a:srgbClr val="334455"/>
                 </a:solidFill>
@@ -13086,7 +13086,7 @@
               </a:lnSpc>
             </a:pPr>
             <a:r>
-              <a:rPr sz="1540" b="1" i="0">
+              <a:rPr sz="1652" b="1" i="0">
                 <a:solidFill>
                   <a:srgbClr val="C08A2B"/>
                 </a:solidFill>
@@ -13125,7 +13125,7 @@
               </a:lnSpc>
             </a:pPr>
             <a:r>
-              <a:rPr sz="1760" b="0" i="1">
+              <a:rPr sz="1888" b="0" i="1">
                 <a:solidFill>
                   <a:srgbClr val="334455"/>
                 </a:solidFill>
@@ -13252,7 +13252,7 @@
               </a:lnSpc>
             </a:pPr>
             <a:r>
-              <a:rPr sz="1650" b="0" i="1">
+              <a:rPr sz="1770" b="0" i="1">
                 <a:solidFill>
                   <a:srgbClr val="0F2A43"/>
                 </a:solidFill>
@@ -13335,7 +13335,7 @@
               </a:lnSpc>
             </a:pPr>
             <a:r>
-              <a:rPr sz="1210" b="0" i="0">
+              <a:rPr sz="1297" b="0" i="0">
                 <a:solidFill>
                   <a:srgbClr val="6B7682"/>
                 </a:solidFill>
@@ -13400,7 +13400,7 @@
               </a:lnSpc>
             </a:pPr>
             <a:r>
-              <a:rPr sz="23100" b="1" i="0">
+              <a:rPr sz="24780" b="1" i="0">
                 <a:solidFill>
                   <a:srgbClr val="1C3A56"/>
                 </a:solidFill>
@@ -13439,7 +13439,7 @@
               </a:lnSpc>
             </a:pPr>
             <a:r>
-              <a:rPr sz="1430" b="1" i="0">
+              <a:rPr sz="1534" b="1" i="0">
                 <a:solidFill>
                   <a:srgbClr val="C08A2B"/>
                 </a:solidFill>
@@ -13522,7 +13522,7 @@
               </a:lnSpc>
             </a:pPr>
             <a:r>
-              <a:rPr sz="3630" b="1" i="0">
+              <a:rPr sz="3894" b="1" i="0">
                 <a:solidFill>
                   <a:srgbClr val="FFFFFF"/>
                 </a:solidFill>
@@ -13538,7 +13538,7 @@
               </a:lnSpc>
             </a:pPr>
             <a:r>
-              <a:rPr sz="3630" b="1" i="0">
+              <a:rPr sz="3894" b="1" i="0">
                 <a:solidFill>
                   <a:srgbClr val="FFFFFF"/>
                 </a:solidFill>
@@ -13577,7 +13577,7 @@
               </a:lnSpc>
             </a:pPr>
             <a:r>
-              <a:rPr sz="1980" b="0" i="1">
+              <a:rPr sz="2124" b="0" i="1">
                 <a:solidFill>
                   <a:srgbClr val="F2F4F7"/>
                 </a:solidFill>
@@ -13660,7 +13660,7 @@
               </a:lnSpc>
             </a:pPr>
             <a:r>
-              <a:rPr sz="1210" b="0" i="0">
+              <a:rPr sz="1297" b="0" i="0">
                 <a:solidFill>
                   <a:srgbClr val="909CAA"/>
                 </a:solidFill>
@@ -13813,7 +13813,7 @@
               </a:lnSpc>
             </a:pPr>
             <a:r>
-              <a:rPr sz="1430" b="1" i="0">
+              <a:rPr sz="1534" b="1" i="0">
                 <a:solidFill>
                   <a:srgbClr val="C08A2B"/>
                 </a:solidFill>
@@ -13852,7 +13852,7 @@
               </a:lnSpc>
             </a:pPr>
             <a:r>
-              <a:rPr sz="2860" b="1" i="0">
+              <a:rPr sz="3068" b="1" i="0">
                 <a:solidFill>
                   <a:srgbClr val="FFFFFF"/>
                 </a:solidFill>
@@ -13894,7 +13894,7 @@
               </a:spcAft>
             </a:pPr>
             <a:r>
-              <a:rPr sz="2090">
+              <a:rPr sz="2242">
                 <a:solidFill>
                   <a:srgbClr val="334455"/>
                 </a:solidFill>
@@ -13913,7 +13913,7 @@
               </a:spcAft>
             </a:pPr>
             <a:r>
-              <a:rPr sz="2090">
+              <a:rPr sz="2242">
                 <a:solidFill>
                   <a:srgbClr val="334455"/>
                 </a:solidFill>
@@ -13932,7 +13932,7 @@
               </a:spcAft>
             </a:pPr>
             <a:r>
-              <a:rPr sz="2090">
+              <a:rPr sz="2242">
                 <a:solidFill>
                   <a:srgbClr val="334455"/>
                 </a:solidFill>
@@ -13951,7 +13951,7 @@
               </a:spcAft>
             </a:pPr>
             <a:r>
-              <a:rPr sz="2090">
+              <a:rPr sz="2242">
                 <a:solidFill>
                   <a:srgbClr val="334455"/>
                 </a:solidFill>
@@ -14078,7 +14078,7 @@
               </a:lnSpc>
             </a:pPr>
             <a:r>
-              <a:rPr sz="1650" b="0" i="1">
+              <a:rPr sz="1770" b="0" i="1">
                 <a:solidFill>
                   <a:srgbClr val="0F2A43"/>
                 </a:solidFill>
@@ -14161,7 +14161,7 @@
               </a:lnSpc>
             </a:pPr>
             <a:r>
-              <a:rPr sz="1210" b="0" i="0">
+              <a:rPr sz="1297" b="0" i="0">
                 <a:solidFill>
                   <a:srgbClr val="6B7682"/>
                 </a:solidFill>
@@ -14314,7 +14314,7 @@
               </a:lnSpc>
             </a:pPr>
             <a:r>
-              <a:rPr sz="1430" b="1" i="0">
+              <a:rPr sz="1534" b="1" i="0">
                 <a:solidFill>
                   <a:srgbClr val="C08A2B"/>
                 </a:solidFill>
@@ -14353,7 +14353,7 @@
               </a:lnSpc>
             </a:pPr>
             <a:r>
-              <a:rPr sz="2860" b="1" i="0">
+              <a:rPr sz="3068" b="1" i="0">
                 <a:solidFill>
                   <a:srgbClr val="FFFFFF"/>
                 </a:solidFill>
@@ -14395,7 +14395,7 @@
               </a:spcAft>
             </a:pPr>
             <a:r>
-              <a:rPr sz="2090" b="1">
+              <a:rPr sz="2242" b="1">
                 <a:solidFill>
                   <a:srgbClr val="0F2A43"/>
                 </a:solidFill>
@@ -14404,7 +14404,7 @@
               <a:t>•  Full name: </a:t>
             </a:r>
             <a:r>
-              <a:rPr sz="2090">
+              <a:rPr sz="2242">
                 <a:solidFill>
                   <a:srgbClr val="334455"/>
                 </a:solidFill>
@@ -14423,7 +14423,7 @@
               </a:spcAft>
             </a:pPr>
             <a:r>
-              <a:rPr sz="2090">
+              <a:rPr sz="2242">
                 <a:solidFill>
                   <a:srgbClr val="334455"/>
                 </a:solidFill>
@@ -14442,7 +14442,7 @@
               </a:spcAft>
             </a:pPr>
             <a:r>
-              <a:rPr sz="2090" b="1">
+              <a:rPr sz="2242" b="1">
                 <a:solidFill>
                   <a:srgbClr val="0F2A43"/>
                 </a:solidFill>
@@ -14451,7 +14451,7 @@
               <a:t>•  Three elements: </a:t>
             </a:r>
             <a:r>
-              <a:rPr sz="2090">
+              <a:rPr sz="2242">
                 <a:solidFill>
                   <a:srgbClr val="334455"/>
                 </a:solidFill>
@@ -14470,7 +14470,7 @@
               </a:spcAft>
             </a:pPr>
             <a:r>
-              <a:rPr sz="2090">
+              <a:rPr sz="2242">
                 <a:solidFill>
                   <a:srgbClr val="334455"/>
                 </a:solidFill>
@@ -14489,7 +14489,7 @@
               </a:spcAft>
             </a:pPr>
             <a:r>
-              <a:rPr sz="2090">
+              <a:rPr sz="2242">
                 <a:solidFill>
                   <a:srgbClr val="334455"/>
                 </a:solidFill>
@@ -14616,7 +14616,7 @@
               </a:lnSpc>
             </a:pPr>
             <a:r>
-              <a:rPr sz="1650" b="0" i="1">
+              <a:rPr sz="1770" b="0" i="1">
                 <a:solidFill>
                   <a:srgbClr val="0F2A43"/>
                 </a:solidFill>
@@ -14699,7 +14699,7 @@
               </a:lnSpc>
             </a:pPr>
             <a:r>
-              <a:rPr sz="1210" b="0" i="0">
+              <a:rPr sz="1297" b="0" i="0">
                 <a:solidFill>
                   <a:srgbClr val="6B7682"/>
                 </a:solidFill>

</xml_diff>

<commit_message>
Add themed line-art icons (globe/scales/coins/doc) across deck; in-memory icon rendering
</commit_message>
<xml_diff>
--- a/Epstein_Transnational_Justice.pptx
+++ b/Epstein_Transnational_Justice.pptx
@@ -3364,9 +3364,33 @@
           </a:p>
         </p:txBody>
       </p:sp>
-      <p:sp>
-        <p:nvSpPr>
-          <p:cNvPr id="8" name="TextBox 7"/>
+      <p:pic>
+        <p:nvPicPr>
+          <p:cNvPr id="8" name="Picture 7" descr="image.png"/>
+          <p:cNvPicPr>
+            <a:picLocks noChangeAspect="1"/>
+          </p:cNvPicPr>
+          <p:nvPr/>
+        </p:nvPicPr>
+        <p:blipFill>
+          <a:blip r:embed="rId2"/>
+          <a:stretch>
+            <a:fillRect/>
+          </a:stretch>
+        </p:blipFill>
+        <p:spPr>
+          <a:xfrm>
+            <a:off x="5524347" y="4526280"/>
+            <a:ext cx="1143000" cy="1143000"/>
+          </a:xfrm>
+          <a:prstGeom prst="rect">
+            <a:avLst/>
+          </a:prstGeom>
+        </p:spPr>
+      </p:pic>
+      <p:sp>
+        <p:nvSpPr>
+          <p:cNvPr id="9" name="TextBox 8"/>
           <p:cNvSpPr txBox="1"/>
           <p:nvPr/>
         </p:nvSpPr>
@@ -3565,7 +3589,7 @@
         <p:spPr>
           <a:xfrm>
             <a:off x="548640" y="475488"/>
-            <a:ext cx="11064240" cy="731520"/>
+            <a:ext cx="10058400" cy="731520"/>
           </a:xfrm>
           <a:prstGeom prst="rect">
             <a:avLst/>
@@ -3595,9 +3619,33 @@
           </a:p>
         </p:txBody>
       </p:sp>
-      <p:sp>
-        <p:nvSpPr>
-          <p:cNvPr id="6" name="TextBox 5"/>
+      <p:pic>
+        <p:nvPicPr>
+          <p:cNvPr id="6" name="Picture 5" descr="image.png"/>
+          <p:cNvPicPr>
+            <a:picLocks noChangeAspect="1"/>
+          </p:cNvPicPr>
+          <p:nvPr/>
+        </p:nvPicPr>
+        <p:blipFill>
+          <a:blip r:embed="rId2"/>
+          <a:stretch>
+            <a:fillRect/>
+          </a:stretch>
+        </p:blipFill>
+        <p:spPr>
+          <a:xfrm>
+            <a:off x="11045952" y="301752"/>
+            <a:ext cx="548640" cy="548640"/>
+          </a:xfrm>
+          <a:prstGeom prst="rect">
+            <a:avLst/>
+          </a:prstGeom>
+        </p:spPr>
+      </p:pic>
+      <p:sp>
+        <p:nvSpPr>
+          <p:cNvPr id="7" name="TextBox 6"/>
           <p:cNvSpPr txBox="1"/>
           <p:nvPr/>
         </p:nvSpPr>
@@ -3724,7 +3772,7 @@
       </p:sp>
       <p:sp>
         <p:nvSpPr>
-          <p:cNvPr id="7" name="Rectangle 6"/>
+          <p:cNvPr id="8" name="Rectangle 7"/>
           <p:cNvSpPr/>
           <p:nvPr/>
         </p:nvSpPr>
@@ -3768,7 +3816,7 @@
       </p:sp>
       <p:sp>
         <p:nvSpPr>
-          <p:cNvPr id="8" name="Rectangle 7"/>
+          <p:cNvPr id="9" name="Rectangle 8"/>
           <p:cNvSpPr/>
           <p:nvPr/>
         </p:nvSpPr>
@@ -3812,7 +3860,7 @@
       </p:sp>
       <p:sp>
         <p:nvSpPr>
-          <p:cNvPr id="9" name="TextBox 8"/>
+          <p:cNvPr id="10" name="TextBox 9"/>
           <p:cNvSpPr txBox="1"/>
           <p:nvPr/>
         </p:nvSpPr>
@@ -3851,7 +3899,7 @@
       </p:sp>
       <p:sp>
         <p:nvSpPr>
-          <p:cNvPr id="10" name="Rectangle 9"/>
+          <p:cNvPr id="11" name="Rectangle 10"/>
           <p:cNvSpPr/>
           <p:nvPr/>
         </p:nvSpPr>
@@ -3895,7 +3943,7 @@
       </p:sp>
       <p:sp>
         <p:nvSpPr>
-          <p:cNvPr id="11" name="TextBox 10"/>
+          <p:cNvPr id="12" name="TextBox 11"/>
           <p:cNvSpPr txBox="1"/>
           <p:nvPr/>
         </p:nvSpPr>
@@ -4094,7 +4142,7 @@
         <p:spPr>
           <a:xfrm>
             <a:off x="548640" y="475488"/>
-            <a:ext cx="11064240" cy="731520"/>
+            <a:ext cx="10058400" cy="731520"/>
           </a:xfrm>
           <a:prstGeom prst="rect">
             <a:avLst/>
@@ -4124,9 +4172,33 @@
           </a:p>
         </p:txBody>
       </p:sp>
-      <p:sp>
-        <p:nvSpPr>
-          <p:cNvPr id="6" name="TextBox 5"/>
+      <p:pic>
+        <p:nvPicPr>
+          <p:cNvPr id="6" name="Picture 5" descr="image.png"/>
+          <p:cNvPicPr>
+            <a:picLocks noChangeAspect="1"/>
+          </p:cNvPicPr>
+          <p:nvPr/>
+        </p:nvPicPr>
+        <p:blipFill>
+          <a:blip r:embed="rId2"/>
+          <a:stretch>
+            <a:fillRect/>
+          </a:stretch>
+        </p:blipFill>
+        <p:spPr>
+          <a:xfrm>
+            <a:off x="11045952" y="301752"/>
+            <a:ext cx="548640" cy="548640"/>
+          </a:xfrm>
+          <a:prstGeom prst="rect">
+            <a:avLst/>
+          </a:prstGeom>
+        </p:spPr>
+      </p:pic>
+      <p:sp>
+        <p:nvSpPr>
+          <p:cNvPr id="7" name="TextBox 6"/>
           <p:cNvSpPr txBox="1"/>
           <p:nvPr/>
         </p:nvSpPr>
@@ -4289,7 +4361,7 @@
       </p:sp>
       <p:sp>
         <p:nvSpPr>
-          <p:cNvPr id="7" name="Rectangle 6"/>
+          <p:cNvPr id="8" name="Rectangle 7"/>
           <p:cNvSpPr/>
           <p:nvPr/>
         </p:nvSpPr>
@@ -4333,7 +4405,7 @@
       </p:sp>
       <p:sp>
         <p:nvSpPr>
-          <p:cNvPr id="8" name="Rectangle 7"/>
+          <p:cNvPr id="9" name="Rectangle 8"/>
           <p:cNvSpPr/>
           <p:nvPr/>
         </p:nvSpPr>
@@ -4377,7 +4449,7 @@
       </p:sp>
       <p:sp>
         <p:nvSpPr>
-          <p:cNvPr id="9" name="TextBox 8"/>
+          <p:cNvPr id="10" name="TextBox 9"/>
           <p:cNvSpPr txBox="1"/>
           <p:nvPr/>
         </p:nvSpPr>
@@ -4416,7 +4488,7 @@
       </p:sp>
       <p:sp>
         <p:nvSpPr>
-          <p:cNvPr id="10" name="Rectangle 9"/>
+          <p:cNvPr id="11" name="Rectangle 10"/>
           <p:cNvSpPr/>
           <p:nvPr/>
         </p:nvSpPr>
@@ -4460,7 +4532,7 @@
       </p:sp>
       <p:sp>
         <p:nvSpPr>
-          <p:cNvPr id="11" name="TextBox 10"/>
+          <p:cNvPr id="12" name="TextBox 11"/>
           <p:cNvSpPr txBox="1"/>
           <p:nvPr/>
         </p:nvSpPr>
@@ -4659,7 +4731,7 @@
         <p:spPr>
           <a:xfrm>
             <a:off x="548640" y="475488"/>
-            <a:ext cx="11064240" cy="731520"/>
+            <a:ext cx="10058400" cy="731520"/>
           </a:xfrm>
           <a:prstGeom prst="rect">
             <a:avLst/>
@@ -4689,9 +4761,33 @@
           </a:p>
         </p:txBody>
       </p:sp>
-      <p:sp>
-        <p:nvSpPr>
-          <p:cNvPr id="6" name="TextBox 5"/>
+      <p:pic>
+        <p:nvPicPr>
+          <p:cNvPr id="6" name="Picture 5" descr="image.png"/>
+          <p:cNvPicPr>
+            <a:picLocks noChangeAspect="1"/>
+          </p:cNvPicPr>
+          <p:nvPr/>
+        </p:nvPicPr>
+        <p:blipFill>
+          <a:blip r:embed="rId2"/>
+          <a:stretch>
+            <a:fillRect/>
+          </a:stretch>
+        </p:blipFill>
+        <p:spPr>
+          <a:xfrm>
+            <a:off x="11045952" y="301752"/>
+            <a:ext cx="548640" cy="548640"/>
+          </a:xfrm>
+          <a:prstGeom prst="rect">
+            <a:avLst/>
+          </a:prstGeom>
+        </p:spPr>
+      </p:pic>
+      <p:sp>
+        <p:nvSpPr>
+          <p:cNvPr id="7" name="TextBox 6"/>
           <p:cNvSpPr txBox="1"/>
           <p:nvPr/>
         </p:nvSpPr>
@@ -4808,7 +4904,7 @@
       </p:sp>
       <p:sp>
         <p:nvSpPr>
-          <p:cNvPr id="7" name="Rectangle 6"/>
+          <p:cNvPr id="8" name="Rectangle 7"/>
           <p:cNvSpPr/>
           <p:nvPr/>
         </p:nvSpPr>
@@ -4852,7 +4948,7 @@
       </p:sp>
       <p:sp>
         <p:nvSpPr>
-          <p:cNvPr id="8" name="Rectangle 7"/>
+          <p:cNvPr id="9" name="Rectangle 8"/>
           <p:cNvSpPr/>
           <p:nvPr/>
         </p:nvSpPr>
@@ -4896,7 +4992,7 @@
       </p:sp>
       <p:sp>
         <p:nvSpPr>
-          <p:cNvPr id="9" name="TextBox 8"/>
+          <p:cNvPr id="10" name="TextBox 9"/>
           <p:cNvSpPr txBox="1"/>
           <p:nvPr/>
         </p:nvSpPr>
@@ -4935,7 +5031,7 @@
       </p:sp>
       <p:sp>
         <p:nvSpPr>
-          <p:cNvPr id="10" name="Rectangle 9"/>
+          <p:cNvPr id="11" name="Rectangle 10"/>
           <p:cNvSpPr/>
           <p:nvPr/>
         </p:nvSpPr>
@@ -4979,7 +5075,7 @@
       </p:sp>
       <p:sp>
         <p:nvSpPr>
-          <p:cNvPr id="11" name="TextBox 10"/>
+          <p:cNvPr id="12" name="TextBox 11"/>
           <p:cNvSpPr txBox="1"/>
           <p:nvPr/>
         </p:nvSpPr>
@@ -5258,9 +5354,33 @@
           </a:p>
         </p:txBody>
       </p:sp>
-      <p:sp>
-        <p:nvSpPr>
-          <p:cNvPr id="7" name="Rectangle 6"/>
+      <p:pic>
+        <p:nvPicPr>
+          <p:cNvPr id="7" name="Picture 6" descr="image.png"/>
+          <p:cNvPicPr>
+            <a:picLocks noChangeAspect="1"/>
+          </p:cNvPicPr>
+          <p:nvPr/>
+        </p:nvPicPr>
+        <p:blipFill>
+          <a:blip r:embed="rId2"/>
+          <a:stretch>
+            <a:fillRect/>
+          </a:stretch>
+        </p:blipFill>
+        <p:spPr>
+          <a:xfrm>
+            <a:off x="9646920" y="4206240"/>
+            <a:ext cx="1691640" cy="1691640"/>
+          </a:xfrm>
+          <a:prstGeom prst="rect">
+            <a:avLst/>
+          </a:prstGeom>
+        </p:spPr>
+      </p:pic>
+      <p:sp>
+        <p:nvSpPr>
+          <p:cNvPr id="8" name="Rectangle 7"/>
           <p:cNvSpPr/>
           <p:nvPr/>
         </p:nvSpPr>
@@ -5304,7 +5424,7 @@
       </p:sp>
       <p:sp>
         <p:nvSpPr>
-          <p:cNvPr id="8" name="TextBox 7"/>
+          <p:cNvPr id="9" name="TextBox 8"/>
           <p:cNvSpPr txBox="1"/>
           <p:nvPr/>
         </p:nvSpPr>
@@ -5503,7 +5623,7 @@
         <p:spPr>
           <a:xfrm>
             <a:off x="548640" y="475488"/>
-            <a:ext cx="11064240" cy="731520"/>
+            <a:ext cx="10058400" cy="731520"/>
           </a:xfrm>
           <a:prstGeom prst="rect">
             <a:avLst/>
@@ -5533,9 +5653,33 @@
           </a:p>
         </p:txBody>
       </p:sp>
-      <p:sp>
-        <p:nvSpPr>
-          <p:cNvPr id="6" name="TextBox 5"/>
+      <p:pic>
+        <p:nvPicPr>
+          <p:cNvPr id="6" name="Picture 5" descr="image.png"/>
+          <p:cNvPicPr>
+            <a:picLocks noChangeAspect="1"/>
+          </p:cNvPicPr>
+          <p:nvPr/>
+        </p:nvPicPr>
+        <p:blipFill>
+          <a:blip r:embed="rId2"/>
+          <a:stretch>
+            <a:fillRect/>
+          </a:stretch>
+        </p:blipFill>
+        <p:spPr>
+          <a:xfrm>
+            <a:off x="11045952" y="301752"/>
+            <a:ext cx="548640" cy="548640"/>
+          </a:xfrm>
+          <a:prstGeom prst="rect">
+            <a:avLst/>
+          </a:prstGeom>
+        </p:spPr>
+      </p:pic>
+      <p:sp>
+        <p:nvSpPr>
+          <p:cNvPr id="7" name="TextBox 6"/>
           <p:cNvSpPr txBox="1"/>
           <p:nvPr/>
         </p:nvSpPr>
@@ -5653,7 +5797,7 @@
       </p:sp>
       <p:sp>
         <p:nvSpPr>
-          <p:cNvPr id="7" name="Rectangle 6"/>
+          <p:cNvPr id="8" name="Rectangle 7"/>
           <p:cNvSpPr/>
           <p:nvPr/>
         </p:nvSpPr>
@@ -5697,7 +5841,7 @@
       </p:sp>
       <p:sp>
         <p:nvSpPr>
-          <p:cNvPr id="8" name="Rectangle 7"/>
+          <p:cNvPr id="9" name="Rectangle 8"/>
           <p:cNvSpPr/>
           <p:nvPr/>
         </p:nvSpPr>
@@ -5741,7 +5885,7 @@
       </p:sp>
       <p:sp>
         <p:nvSpPr>
-          <p:cNvPr id="9" name="TextBox 8"/>
+          <p:cNvPr id="10" name="TextBox 9"/>
           <p:cNvSpPr txBox="1"/>
           <p:nvPr/>
         </p:nvSpPr>
@@ -5780,7 +5924,7 @@
       </p:sp>
       <p:sp>
         <p:nvSpPr>
-          <p:cNvPr id="10" name="Rectangle 9"/>
+          <p:cNvPr id="11" name="Rectangle 10"/>
           <p:cNvSpPr/>
           <p:nvPr/>
         </p:nvSpPr>
@@ -5824,7 +5968,7 @@
       </p:sp>
       <p:sp>
         <p:nvSpPr>
-          <p:cNvPr id="11" name="TextBox 10"/>
+          <p:cNvPr id="12" name="TextBox 11"/>
           <p:cNvSpPr txBox="1"/>
           <p:nvPr/>
         </p:nvSpPr>
@@ -6023,7 +6167,7 @@
         <p:spPr>
           <a:xfrm>
             <a:off x="548640" y="475488"/>
-            <a:ext cx="11064240" cy="731520"/>
+            <a:ext cx="10058400" cy="731520"/>
           </a:xfrm>
           <a:prstGeom prst="rect">
             <a:avLst/>
@@ -6053,9 +6197,33 @@
           </a:p>
         </p:txBody>
       </p:sp>
-      <p:sp>
-        <p:nvSpPr>
-          <p:cNvPr id="6" name="Rectangle 5"/>
+      <p:pic>
+        <p:nvPicPr>
+          <p:cNvPr id="6" name="Picture 5" descr="image.png"/>
+          <p:cNvPicPr>
+            <a:picLocks noChangeAspect="1"/>
+          </p:cNvPicPr>
+          <p:nvPr/>
+        </p:nvPicPr>
+        <p:blipFill>
+          <a:blip r:embed="rId2"/>
+          <a:stretch>
+            <a:fillRect/>
+          </a:stretch>
+        </p:blipFill>
+        <p:spPr>
+          <a:xfrm>
+            <a:off x="11045952" y="301752"/>
+            <a:ext cx="548640" cy="548640"/>
+          </a:xfrm>
+          <a:prstGeom prst="rect">
+            <a:avLst/>
+          </a:prstGeom>
+        </p:spPr>
+      </p:pic>
+      <p:sp>
+        <p:nvSpPr>
+          <p:cNvPr id="7" name="Rectangle 6"/>
           <p:cNvSpPr/>
           <p:nvPr/>
         </p:nvSpPr>
@@ -6099,7 +6267,7 @@
       </p:sp>
       <p:sp>
         <p:nvSpPr>
-          <p:cNvPr id="7" name="Rectangle 6"/>
+          <p:cNvPr id="8" name="Rectangle 7"/>
           <p:cNvSpPr/>
           <p:nvPr/>
         </p:nvSpPr>
@@ -6143,7 +6311,7 @@
       </p:sp>
       <p:sp>
         <p:nvSpPr>
-          <p:cNvPr id="8" name="TextBox 7"/>
+          <p:cNvPr id="9" name="TextBox 8"/>
           <p:cNvSpPr txBox="1"/>
           <p:nvPr/>
         </p:nvSpPr>
@@ -6182,7 +6350,7 @@
       </p:sp>
       <p:sp>
         <p:nvSpPr>
-          <p:cNvPr id="9" name="TextBox 8"/>
+          <p:cNvPr id="10" name="TextBox 9"/>
           <p:cNvSpPr txBox="1"/>
           <p:nvPr/>
         </p:nvSpPr>
@@ -6281,7 +6449,7 @@
       </p:sp>
       <p:sp>
         <p:nvSpPr>
-          <p:cNvPr id="10" name="Rectangle 9"/>
+          <p:cNvPr id="11" name="Rectangle 10"/>
           <p:cNvSpPr/>
           <p:nvPr/>
         </p:nvSpPr>
@@ -6325,7 +6493,7 @@
       </p:sp>
       <p:sp>
         <p:nvSpPr>
-          <p:cNvPr id="11" name="Rectangle 10"/>
+          <p:cNvPr id="12" name="Rectangle 11"/>
           <p:cNvSpPr/>
           <p:nvPr/>
         </p:nvSpPr>
@@ -6369,7 +6537,7 @@
       </p:sp>
       <p:sp>
         <p:nvSpPr>
-          <p:cNvPr id="12" name="TextBox 11"/>
+          <p:cNvPr id="13" name="TextBox 12"/>
           <p:cNvSpPr txBox="1"/>
           <p:nvPr/>
         </p:nvSpPr>
@@ -6408,7 +6576,7 @@
       </p:sp>
       <p:sp>
         <p:nvSpPr>
-          <p:cNvPr id="13" name="TextBox 12"/>
+          <p:cNvPr id="14" name="TextBox 13"/>
           <p:cNvSpPr txBox="1"/>
           <p:nvPr/>
         </p:nvSpPr>
@@ -6507,7 +6675,7 @@
       </p:sp>
       <p:sp>
         <p:nvSpPr>
-          <p:cNvPr id="14" name="Rectangle 13"/>
+          <p:cNvPr id="15" name="Rectangle 14"/>
           <p:cNvSpPr/>
           <p:nvPr/>
         </p:nvSpPr>
@@ -6551,7 +6719,7 @@
       </p:sp>
       <p:sp>
         <p:nvSpPr>
-          <p:cNvPr id="15" name="Rectangle 14"/>
+          <p:cNvPr id="16" name="Rectangle 15"/>
           <p:cNvSpPr/>
           <p:nvPr/>
         </p:nvSpPr>
@@ -6595,7 +6763,7 @@
       </p:sp>
       <p:sp>
         <p:nvSpPr>
-          <p:cNvPr id="16" name="TextBox 15"/>
+          <p:cNvPr id="17" name="TextBox 16"/>
           <p:cNvSpPr txBox="1"/>
           <p:nvPr/>
         </p:nvSpPr>
@@ -6634,7 +6802,7 @@
       </p:sp>
       <p:sp>
         <p:nvSpPr>
-          <p:cNvPr id="17" name="Rectangle 16"/>
+          <p:cNvPr id="18" name="Rectangle 17"/>
           <p:cNvSpPr/>
           <p:nvPr/>
         </p:nvSpPr>
@@ -6678,7 +6846,7 @@
       </p:sp>
       <p:sp>
         <p:nvSpPr>
-          <p:cNvPr id="18" name="TextBox 17"/>
+          <p:cNvPr id="19" name="TextBox 18"/>
           <p:cNvSpPr txBox="1"/>
           <p:nvPr/>
         </p:nvSpPr>
@@ -6877,7 +7045,7 @@
         <p:spPr>
           <a:xfrm>
             <a:off x="548640" y="475488"/>
-            <a:ext cx="11064240" cy="731520"/>
+            <a:ext cx="10058400" cy="731520"/>
           </a:xfrm>
           <a:prstGeom prst="rect">
             <a:avLst/>
@@ -6907,9 +7075,33 @@
           </a:p>
         </p:txBody>
       </p:sp>
-      <p:sp>
-        <p:nvSpPr>
-          <p:cNvPr id="6" name="TextBox 5"/>
+      <p:pic>
+        <p:nvPicPr>
+          <p:cNvPr id="6" name="Picture 5" descr="image.png"/>
+          <p:cNvPicPr>
+            <a:picLocks noChangeAspect="1"/>
+          </p:cNvPicPr>
+          <p:nvPr/>
+        </p:nvPicPr>
+        <p:blipFill>
+          <a:blip r:embed="rId2"/>
+          <a:stretch>
+            <a:fillRect/>
+          </a:stretch>
+        </p:blipFill>
+        <p:spPr>
+          <a:xfrm>
+            <a:off x="11045952" y="301752"/>
+            <a:ext cx="548640" cy="548640"/>
+          </a:xfrm>
+          <a:prstGeom prst="rect">
+            <a:avLst/>
+          </a:prstGeom>
+        </p:spPr>
+      </p:pic>
+      <p:sp>
+        <p:nvSpPr>
+          <p:cNvPr id="7" name="TextBox 6"/>
           <p:cNvSpPr txBox="1"/>
           <p:nvPr/>
         </p:nvSpPr>
@@ -7044,7 +7236,7 @@
       </p:sp>
       <p:sp>
         <p:nvSpPr>
-          <p:cNvPr id="7" name="Rectangle 6"/>
+          <p:cNvPr id="8" name="Rectangle 7"/>
           <p:cNvSpPr/>
           <p:nvPr/>
         </p:nvSpPr>
@@ -7088,7 +7280,7 @@
       </p:sp>
       <p:sp>
         <p:nvSpPr>
-          <p:cNvPr id="8" name="Rectangle 7"/>
+          <p:cNvPr id="9" name="Rectangle 8"/>
           <p:cNvSpPr/>
           <p:nvPr/>
         </p:nvSpPr>
@@ -7132,7 +7324,7 @@
       </p:sp>
       <p:sp>
         <p:nvSpPr>
-          <p:cNvPr id="9" name="TextBox 8"/>
+          <p:cNvPr id="10" name="TextBox 9"/>
           <p:cNvSpPr txBox="1"/>
           <p:nvPr/>
         </p:nvSpPr>
@@ -7171,7 +7363,7 @@
       </p:sp>
       <p:sp>
         <p:nvSpPr>
-          <p:cNvPr id="10" name="Rectangle 9"/>
+          <p:cNvPr id="11" name="Rectangle 10"/>
           <p:cNvSpPr/>
           <p:nvPr/>
         </p:nvSpPr>
@@ -7215,7 +7407,7 @@
       </p:sp>
       <p:sp>
         <p:nvSpPr>
-          <p:cNvPr id="11" name="TextBox 10"/>
+          <p:cNvPr id="12" name="TextBox 11"/>
           <p:cNvSpPr txBox="1"/>
           <p:nvPr/>
         </p:nvSpPr>
@@ -7494,9 +7686,33 @@
           </a:p>
         </p:txBody>
       </p:sp>
-      <p:sp>
-        <p:nvSpPr>
-          <p:cNvPr id="7" name="Rectangle 6"/>
+      <p:pic>
+        <p:nvPicPr>
+          <p:cNvPr id="7" name="Picture 6" descr="image.png"/>
+          <p:cNvPicPr>
+            <a:picLocks noChangeAspect="1"/>
+          </p:cNvPicPr>
+          <p:nvPr/>
+        </p:nvPicPr>
+        <p:blipFill>
+          <a:blip r:embed="rId2"/>
+          <a:stretch>
+            <a:fillRect/>
+          </a:stretch>
+        </p:blipFill>
+        <p:spPr>
+          <a:xfrm>
+            <a:off x="9646920" y="4206240"/>
+            <a:ext cx="1691640" cy="1691640"/>
+          </a:xfrm>
+          <a:prstGeom prst="rect">
+            <a:avLst/>
+          </a:prstGeom>
+        </p:spPr>
+      </p:pic>
+      <p:sp>
+        <p:nvSpPr>
+          <p:cNvPr id="8" name="Rectangle 7"/>
           <p:cNvSpPr/>
           <p:nvPr/>
         </p:nvSpPr>
@@ -7540,7 +7756,7 @@
       </p:sp>
       <p:sp>
         <p:nvSpPr>
-          <p:cNvPr id="8" name="TextBox 7"/>
+          <p:cNvPr id="9" name="TextBox 8"/>
           <p:cNvSpPr txBox="1"/>
           <p:nvPr/>
         </p:nvSpPr>
@@ -7739,7 +7955,7 @@
         <p:spPr>
           <a:xfrm>
             <a:off x="548640" y="475488"/>
-            <a:ext cx="11064240" cy="731520"/>
+            <a:ext cx="10058400" cy="731520"/>
           </a:xfrm>
           <a:prstGeom prst="rect">
             <a:avLst/>
@@ -7769,9 +7985,33 @@
           </a:p>
         </p:txBody>
       </p:sp>
-      <p:sp>
-        <p:nvSpPr>
-          <p:cNvPr id="6" name="TextBox 5"/>
+      <p:pic>
+        <p:nvPicPr>
+          <p:cNvPr id="6" name="Picture 5" descr="image.png"/>
+          <p:cNvPicPr>
+            <a:picLocks noChangeAspect="1"/>
+          </p:cNvPicPr>
+          <p:nvPr/>
+        </p:nvPicPr>
+        <p:blipFill>
+          <a:blip r:embed="rId2"/>
+          <a:stretch>
+            <a:fillRect/>
+          </a:stretch>
+        </p:blipFill>
+        <p:spPr>
+          <a:xfrm>
+            <a:off x="11045952" y="301752"/>
+            <a:ext cx="548640" cy="548640"/>
+          </a:xfrm>
+          <a:prstGeom prst="rect">
+            <a:avLst/>
+          </a:prstGeom>
+        </p:spPr>
+      </p:pic>
+      <p:sp>
+        <p:nvSpPr>
+          <p:cNvPr id="7" name="TextBox 6"/>
           <p:cNvSpPr txBox="1"/>
           <p:nvPr/>
         </p:nvSpPr>
@@ -7879,7 +8119,7 @@
       </p:sp>
       <p:sp>
         <p:nvSpPr>
-          <p:cNvPr id="7" name="Rectangle 6"/>
+          <p:cNvPr id="8" name="Rectangle 7"/>
           <p:cNvSpPr/>
           <p:nvPr/>
         </p:nvSpPr>
@@ -7923,7 +8163,7 @@
       </p:sp>
       <p:sp>
         <p:nvSpPr>
-          <p:cNvPr id="8" name="Rectangle 7"/>
+          <p:cNvPr id="9" name="Rectangle 8"/>
           <p:cNvSpPr/>
           <p:nvPr/>
         </p:nvSpPr>
@@ -7967,7 +8207,7 @@
       </p:sp>
       <p:sp>
         <p:nvSpPr>
-          <p:cNvPr id="9" name="TextBox 8"/>
+          <p:cNvPr id="10" name="TextBox 9"/>
           <p:cNvSpPr txBox="1"/>
           <p:nvPr/>
         </p:nvSpPr>
@@ -8006,7 +8246,7 @@
       </p:sp>
       <p:sp>
         <p:nvSpPr>
-          <p:cNvPr id="10" name="Rectangle 9"/>
+          <p:cNvPr id="11" name="Rectangle 10"/>
           <p:cNvSpPr/>
           <p:nvPr/>
         </p:nvSpPr>
@@ -8050,7 +8290,7 @@
       </p:sp>
       <p:sp>
         <p:nvSpPr>
-          <p:cNvPr id="11" name="TextBox 10"/>
+          <p:cNvPr id="12" name="TextBox 11"/>
           <p:cNvSpPr txBox="1"/>
           <p:nvPr/>
         </p:nvSpPr>
@@ -8249,7 +8489,7 @@
         <p:spPr>
           <a:xfrm>
             <a:off x="548640" y="475488"/>
-            <a:ext cx="11064240" cy="731520"/>
+            <a:ext cx="10058400" cy="731520"/>
           </a:xfrm>
           <a:prstGeom prst="rect">
             <a:avLst/>
@@ -8279,9 +8519,33 @@
           </a:p>
         </p:txBody>
       </p:sp>
-      <p:sp>
-        <p:nvSpPr>
-          <p:cNvPr id="6" name="TextBox 5"/>
+      <p:pic>
+        <p:nvPicPr>
+          <p:cNvPr id="6" name="Picture 5" descr="image.png"/>
+          <p:cNvPicPr>
+            <a:picLocks noChangeAspect="1"/>
+          </p:cNvPicPr>
+          <p:nvPr/>
+        </p:nvPicPr>
+        <p:blipFill>
+          <a:blip r:embed="rId2"/>
+          <a:stretch>
+            <a:fillRect/>
+          </a:stretch>
+        </p:blipFill>
+        <p:spPr>
+          <a:xfrm>
+            <a:off x="11045952" y="301752"/>
+            <a:ext cx="548640" cy="548640"/>
+          </a:xfrm>
+          <a:prstGeom prst="rect">
+            <a:avLst/>
+          </a:prstGeom>
+        </p:spPr>
+      </p:pic>
+      <p:sp>
+        <p:nvSpPr>
+          <p:cNvPr id="7" name="TextBox 6"/>
           <p:cNvSpPr txBox="1"/>
           <p:nvPr/>
         </p:nvSpPr>
@@ -8380,7 +8644,7 @@
       </p:sp>
       <p:sp>
         <p:nvSpPr>
-          <p:cNvPr id="7" name="Rectangle 6"/>
+          <p:cNvPr id="8" name="Rectangle 7"/>
           <p:cNvSpPr/>
           <p:nvPr/>
         </p:nvSpPr>
@@ -8424,7 +8688,7 @@
       </p:sp>
       <p:sp>
         <p:nvSpPr>
-          <p:cNvPr id="8" name="Rectangle 7"/>
+          <p:cNvPr id="9" name="Rectangle 8"/>
           <p:cNvSpPr/>
           <p:nvPr/>
         </p:nvSpPr>
@@ -8468,7 +8732,7 @@
       </p:sp>
       <p:sp>
         <p:nvSpPr>
-          <p:cNvPr id="9" name="TextBox 8"/>
+          <p:cNvPr id="10" name="TextBox 9"/>
           <p:cNvSpPr txBox="1"/>
           <p:nvPr/>
         </p:nvSpPr>
@@ -8507,7 +8771,7 @@
       </p:sp>
       <p:sp>
         <p:nvSpPr>
-          <p:cNvPr id="10" name="TextBox 9"/>
+          <p:cNvPr id="11" name="TextBox 10"/>
           <p:cNvSpPr txBox="1"/>
           <p:nvPr/>
         </p:nvSpPr>
@@ -8546,7 +8810,7 @@
       </p:sp>
       <p:sp>
         <p:nvSpPr>
-          <p:cNvPr id="11" name="Rectangle 10"/>
+          <p:cNvPr id="12" name="Rectangle 11"/>
           <p:cNvSpPr/>
           <p:nvPr/>
         </p:nvSpPr>
@@ -8590,7 +8854,7 @@
       </p:sp>
       <p:sp>
         <p:nvSpPr>
-          <p:cNvPr id="12" name="Rectangle 11"/>
+          <p:cNvPr id="13" name="Rectangle 12"/>
           <p:cNvSpPr/>
           <p:nvPr/>
         </p:nvSpPr>
@@ -8634,7 +8898,7 @@
       </p:sp>
       <p:sp>
         <p:nvSpPr>
-          <p:cNvPr id="13" name="TextBox 12"/>
+          <p:cNvPr id="14" name="TextBox 13"/>
           <p:cNvSpPr txBox="1"/>
           <p:nvPr/>
         </p:nvSpPr>
@@ -8673,7 +8937,7 @@
       </p:sp>
       <p:sp>
         <p:nvSpPr>
-          <p:cNvPr id="14" name="Rectangle 13"/>
+          <p:cNvPr id="15" name="Rectangle 14"/>
           <p:cNvSpPr/>
           <p:nvPr/>
         </p:nvSpPr>
@@ -8717,7 +8981,7 @@
       </p:sp>
       <p:sp>
         <p:nvSpPr>
-          <p:cNvPr id="15" name="TextBox 14"/>
+          <p:cNvPr id="16" name="TextBox 15"/>
           <p:cNvSpPr txBox="1"/>
           <p:nvPr/>
         </p:nvSpPr>
@@ -8916,7 +9180,7 @@
         <p:spPr>
           <a:xfrm>
             <a:off x="548640" y="475488"/>
-            <a:ext cx="11064240" cy="731520"/>
+            <a:ext cx="10058400" cy="731520"/>
           </a:xfrm>
           <a:prstGeom prst="rect">
             <a:avLst/>
@@ -8946,9 +9210,33 @@
           </a:p>
         </p:txBody>
       </p:sp>
-      <p:sp>
-        <p:nvSpPr>
-          <p:cNvPr id="6" name="Rectangle 5"/>
+      <p:pic>
+        <p:nvPicPr>
+          <p:cNvPr id="6" name="Picture 5" descr="image.png"/>
+          <p:cNvPicPr>
+            <a:picLocks noChangeAspect="1"/>
+          </p:cNvPicPr>
+          <p:nvPr/>
+        </p:nvPicPr>
+        <p:blipFill>
+          <a:blip r:embed="rId2"/>
+          <a:stretch>
+            <a:fillRect/>
+          </a:stretch>
+        </p:blipFill>
+        <p:spPr>
+          <a:xfrm>
+            <a:off x="11045952" y="301752"/>
+            <a:ext cx="548640" cy="548640"/>
+          </a:xfrm>
+          <a:prstGeom prst="rect">
+            <a:avLst/>
+          </a:prstGeom>
+        </p:spPr>
+      </p:pic>
+      <p:sp>
+        <p:nvSpPr>
+          <p:cNvPr id="7" name="Rectangle 6"/>
           <p:cNvSpPr/>
           <p:nvPr/>
         </p:nvSpPr>
@@ -8992,7 +9280,7 @@
       </p:sp>
       <p:sp>
         <p:nvSpPr>
-          <p:cNvPr id="7" name="Rectangle 6"/>
+          <p:cNvPr id="8" name="Rectangle 7"/>
           <p:cNvSpPr/>
           <p:nvPr/>
         </p:nvSpPr>
@@ -9036,7 +9324,7 @@
       </p:sp>
       <p:sp>
         <p:nvSpPr>
-          <p:cNvPr id="8" name="TextBox 7"/>
+          <p:cNvPr id="9" name="TextBox 8"/>
           <p:cNvSpPr txBox="1"/>
           <p:nvPr/>
         </p:nvSpPr>
@@ -9075,7 +9363,7 @@
       </p:sp>
       <p:sp>
         <p:nvSpPr>
-          <p:cNvPr id="9" name="TextBox 8"/>
+          <p:cNvPr id="10" name="TextBox 9"/>
           <p:cNvSpPr txBox="1"/>
           <p:nvPr/>
         </p:nvSpPr>
@@ -9174,7 +9462,7 @@
       </p:sp>
       <p:sp>
         <p:nvSpPr>
-          <p:cNvPr id="10" name="Rectangle 9"/>
+          <p:cNvPr id="11" name="Rectangle 10"/>
           <p:cNvSpPr/>
           <p:nvPr/>
         </p:nvSpPr>
@@ -9218,7 +9506,7 @@
       </p:sp>
       <p:sp>
         <p:nvSpPr>
-          <p:cNvPr id="11" name="Rectangle 10"/>
+          <p:cNvPr id="12" name="Rectangle 11"/>
           <p:cNvSpPr/>
           <p:nvPr/>
         </p:nvSpPr>
@@ -9262,7 +9550,7 @@
       </p:sp>
       <p:sp>
         <p:nvSpPr>
-          <p:cNvPr id="12" name="TextBox 11"/>
+          <p:cNvPr id="13" name="TextBox 12"/>
           <p:cNvSpPr txBox="1"/>
           <p:nvPr/>
         </p:nvSpPr>
@@ -9301,7 +9589,7 @@
       </p:sp>
       <p:sp>
         <p:nvSpPr>
-          <p:cNvPr id="13" name="Rectangle 12"/>
+          <p:cNvPr id="14" name="Rectangle 13"/>
           <p:cNvSpPr/>
           <p:nvPr/>
         </p:nvSpPr>
@@ -9345,7 +9633,7 @@
       </p:sp>
       <p:sp>
         <p:nvSpPr>
-          <p:cNvPr id="14" name="TextBox 13"/>
+          <p:cNvPr id="15" name="TextBox 14"/>
           <p:cNvSpPr txBox="1"/>
           <p:nvPr/>
         </p:nvSpPr>
@@ -9544,7 +9832,7 @@
         <p:spPr>
           <a:xfrm>
             <a:off x="548640" y="475488"/>
-            <a:ext cx="11064240" cy="731520"/>
+            <a:ext cx="10058400" cy="731520"/>
           </a:xfrm>
           <a:prstGeom prst="rect">
             <a:avLst/>
@@ -9574,9 +9862,33 @@
           </a:p>
         </p:txBody>
       </p:sp>
-      <p:sp>
-        <p:nvSpPr>
-          <p:cNvPr id="6" name="Rectangle 5"/>
+      <p:pic>
+        <p:nvPicPr>
+          <p:cNvPr id="6" name="Picture 5" descr="image.png"/>
+          <p:cNvPicPr>
+            <a:picLocks noChangeAspect="1"/>
+          </p:cNvPicPr>
+          <p:nvPr/>
+        </p:nvPicPr>
+        <p:blipFill>
+          <a:blip r:embed="rId2"/>
+          <a:stretch>
+            <a:fillRect/>
+          </a:stretch>
+        </p:blipFill>
+        <p:spPr>
+          <a:xfrm>
+            <a:off x="11045952" y="301752"/>
+            <a:ext cx="548640" cy="548640"/>
+          </a:xfrm>
+          <a:prstGeom prst="rect">
+            <a:avLst/>
+          </a:prstGeom>
+        </p:spPr>
+      </p:pic>
+      <p:sp>
+        <p:nvSpPr>
+          <p:cNvPr id="7" name="Rectangle 6"/>
           <p:cNvSpPr/>
           <p:nvPr/>
         </p:nvSpPr>
@@ -9620,7 +9932,7 @@
       </p:sp>
       <p:sp>
         <p:nvSpPr>
-          <p:cNvPr id="7" name="TextBox 6"/>
+          <p:cNvPr id="8" name="TextBox 7"/>
           <p:cNvSpPr txBox="1"/>
           <p:nvPr/>
         </p:nvSpPr>
@@ -9659,7 +9971,7 @@
       </p:sp>
       <p:sp>
         <p:nvSpPr>
-          <p:cNvPr id="8" name="TextBox 7"/>
+          <p:cNvPr id="9" name="TextBox 8"/>
           <p:cNvSpPr txBox="1"/>
           <p:nvPr/>
         </p:nvSpPr>
@@ -9698,7 +10010,7 @@
       </p:sp>
       <p:sp>
         <p:nvSpPr>
-          <p:cNvPr id="9" name="TextBox 8"/>
+          <p:cNvPr id="10" name="TextBox 9"/>
           <p:cNvSpPr txBox="1"/>
           <p:nvPr/>
         </p:nvSpPr>
@@ -9737,7 +10049,7 @@
       </p:sp>
       <p:sp>
         <p:nvSpPr>
-          <p:cNvPr id="10" name="Rectangle 9"/>
+          <p:cNvPr id="11" name="Rectangle 10"/>
           <p:cNvSpPr/>
           <p:nvPr/>
         </p:nvSpPr>
@@ -9781,7 +10093,7 @@
       </p:sp>
       <p:sp>
         <p:nvSpPr>
-          <p:cNvPr id="11" name="TextBox 10"/>
+          <p:cNvPr id="12" name="TextBox 11"/>
           <p:cNvSpPr txBox="1"/>
           <p:nvPr/>
         </p:nvSpPr>
@@ -9820,7 +10132,7 @@
       </p:sp>
       <p:sp>
         <p:nvSpPr>
-          <p:cNvPr id="12" name="TextBox 11"/>
+          <p:cNvPr id="13" name="TextBox 12"/>
           <p:cNvSpPr txBox="1"/>
           <p:nvPr/>
         </p:nvSpPr>
@@ -9859,7 +10171,7 @@
       </p:sp>
       <p:sp>
         <p:nvSpPr>
-          <p:cNvPr id="13" name="TextBox 12"/>
+          <p:cNvPr id="14" name="TextBox 13"/>
           <p:cNvSpPr txBox="1"/>
           <p:nvPr/>
         </p:nvSpPr>
@@ -9898,7 +10210,7 @@
       </p:sp>
       <p:sp>
         <p:nvSpPr>
-          <p:cNvPr id="14" name="Rectangle 13"/>
+          <p:cNvPr id="15" name="Rectangle 14"/>
           <p:cNvSpPr/>
           <p:nvPr/>
         </p:nvSpPr>
@@ -9942,7 +10254,7 @@
       </p:sp>
       <p:sp>
         <p:nvSpPr>
-          <p:cNvPr id="15" name="TextBox 14"/>
+          <p:cNvPr id="16" name="TextBox 15"/>
           <p:cNvSpPr txBox="1"/>
           <p:nvPr/>
         </p:nvSpPr>
@@ -9981,7 +10293,7 @@
       </p:sp>
       <p:sp>
         <p:nvSpPr>
-          <p:cNvPr id="16" name="TextBox 15"/>
+          <p:cNvPr id="17" name="TextBox 16"/>
           <p:cNvSpPr txBox="1"/>
           <p:nvPr/>
         </p:nvSpPr>
@@ -10020,7 +10332,7 @@
       </p:sp>
       <p:sp>
         <p:nvSpPr>
-          <p:cNvPr id="17" name="TextBox 16"/>
+          <p:cNvPr id="18" name="TextBox 17"/>
           <p:cNvSpPr txBox="1"/>
           <p:nvPr/>
         </p:nvSpPr>
@@ -10059,7 +10371,7 @@
       </p:sp>
       <p:sp>
         <p:nvSpPr>
-          <p:cNvPr id="18" name="Rectangle 17"/>
+          <p:cNvPr id="19" name="Rectangle 18"/>
           <p:cNvSpPr/>
           <p:nvPr/>
         </p:nvSpPr>
@@ -10103,7 +10415,7 @@
       </p:sp>
       <p:sp>
         <p:nvSpPr>
-          <p:cNvPr id="19" name="TextBox 18"/>
+          <p:cNvPr id="20" name="TextBox 19"/>
           <p:cNvSpPr txBox="1"/>
           <p:nvPr/>
         </p:nvSpPr>
@@ -10142,7 +10454,7 @@
       </p:sp>
       <p:sp>
         <p:nvSpPr>
-          <p:cNvPr id="20" name="TextBox 19"/>
+          <p:cNvPr id="21" name="TextBox 20"/>
           <p:cNvSpPr txBox="1"/>
           <p:nvPr/>
         </p:nvSpPr>
@@ -10181,7 +10493,7 @@
       </p:sp>
       <p:sp>
         <p:nvSpPr>
-          <p:cNvPr id="21" name="TextBox 20"/>
+          <p:cNvPr id="22" name="TextBox 21"/>
           <p:cNvSpPr txBox="1"/>
           <p:nvPr/>
         </p:nvSpPr>
@@ -10220,7 +10532,7 @@
       </p:sp>
       <p:sp>
         <p:nvSpPr>
-          <p:cNvPr id="22" name="Rectangle 21"/>
+          <p:cNvPr id="23" name="Rectangle 22"/>
           <p:cNvSpPr/>
           <p:nvPr/>
         </p:nvSpPr>
@@ -10264,7 +10576,7 @@
       </p:sp>
       <p:sp>
         <p:nvSpPr>
-          <p:cNvPr id="23" name="Rectangle 22"/>
+          <p:cNvPr id="24" name="Rectangle 23"/>
           <p:cNvSpPr/>
           <p:nvPr/>
         </p:nvSpPr>
@@ -10308,7 +10620,7 @@
       </p:sp>
       <p:sp>
         <p:nvSpPr>
-          <p:cNvPr id="24" name="TextBox 23"/>
+          <p:cNvPr id="25" name="TextBox 24"/>
           <p:cNvSpPr txBox="1"/>
           <p:nvPr/>
         </p:nvSpPr>
@@ -10347,7 +10659,7 @@
       </p:sp>
       <p:sp>
         <p:nvSpPr>
-          <p:cNvPr id="25" name="TextBox 24"/>
+          <p:cNvPr id="26" name="TextBox 25"/>
           <p:cNvSpPr txBox="1"/>
           <p:nvPr/>
         </p:nvSpPr>
@@ -10386,7 +10698,7 @@
       </p:sp>
       <p:sp>
         <p:nvSpPr>
-          <p:cNvPr id="26" name="Rectangle 25"/>
+          <p:cNvPr id="27" name="Rectangle 26"/>
           <p:cNvSpPr/>
           <p:nvPr/>
         </p:nvSpPr>
@@ -10430,7 +10742,7 @@
       </p:sp>
       <p:sp>
         <p:nvSpPr>
-          <p:cNvPr id="27" name="TextBox 26"/>
+          <p:cNvPr id="28" name="TextBox 27"/>
           <p:cNvSpPr txBox="1"/>
           <p:nvPr/>
         </p:nvSpPr>
@@ -10709,9 +11021,33 @@
           </a:p>
         </p:txBody>
       </p:sp>
-      <p:sp>
-        <p:nvSpPr>
-          <p:cNvPr id="7" name="Rectangle 6"/>
+      <p:pic>
+        <p:nvPicPr>
+          <p:cNvPr id="7" name="Picture 6" descr="image.png"/>
+          <p:cNvPicPr>
+            <a:picLocks noChangeAspect="1"/>
+          </p:cNvPicPr>
+          <p:nvPr/>
+        </p:nvPicPr>
+        <p:blipFill>
+          <a:blip r:embed="rId2"/>
+          <a:stretch>
+            <a:fillRect/>
+          </a:stretch>
+        </p:blipFill>
+        <p:spPr>
+          <a:xfrm>
+            <a:off x="9646920" y="4206240"/>
+            <a:ext cx="1691640" cy="1691640"/>
+          </a:xfrm>
+          <a:prstGeom prst="rect">
+            <a:avLst/>
+          </a:prstGeom>
+        </p:spPr>
+      </p:pic>
+      <p:sp>
+        <p:nvSpPr>
+          <p:cNvPr id="8" name="Rectangle 7"/>
           <p:cNvSpPr/>
           <p:nvPr/>
         </p:nvSpPr>
@@ -10755,7 +11091,7 @@
       </p:sp>
       <p:sp>
         <p:nvSpPr>
-          <p:cNvPr id="8" name="TextBox 7"/>
+          <p:cNvPr id="9" name="TextBox 8"/>
           <p:cNvSpPr txBox="1"/>
           <p:nvPr/>
         </p:nvSpPr>
@@ -10954,7 +11290,7 @@
         <p:spPr>
           <a:xfrm>
             <a:off x="548640" y="475488"/>
-            <a:ext cx="11064240" cy="731520"/>
+            <a:ext cx="10058400" cy="731520"/>
           </a:xfrm>
           <a:prstGeom prst="rect">
             <a:avLst/>
@@ -10984,9 +11320,33 @@
           </a:p>
         </p:txBody>
       </p:sp>
-      <p:sp>
-        <p:nvSpPr>
-          <p:cNvPr id="6" name="TextBox 5"/>
+      <p:pic>
+        <p:nvPicPr>
+          <p:cNvPr id="6" name="Picture 5" descr="image.png"/>
+          <p:cNvPicPr>
+            <a:picLocks noChangeAspect="1"/>
+          </p:cNvPicPr>
+          <p:nvPr/>
+        </p:nvPicPr>
+        <p:blipFill>
+          <a:blip r:embed="rId2"/>
+          <a:stretch>
+            <a:fillRect/>
+          </a:stretch>
+        </p:blipFill>
+        <p:spPr>
+          <a:xfrm>
+            <a:off x="11045952" y="301752"/>
+            <a:ext cx="548640" cy="548640"/>
+          </a:xfrm>
+          <a:prstGeom prst="rect">
+            <a:avLst/>
+          </a:prstGeom>
+        </p:spPr>
+      </p:pic>
+      <p:sp>
+        <p:nvSpPr>
+          <p:cNvPr id="7" name="TextBox 6"/>
           <p:cNvSpPr txBox="1"/>
           <p:nvPr/>
         </p:nvSpPr>
@@ -11131,7 +11491,7 @@
       </p:sp>
       <p:sp>
         <p:nvSpPr>
-          <p:cNvPr id="7" name="Rectangle 6"/>
+          <p:cNvPr id="8" name="Rectangle 7"/>
           <p:cNvSpPr/>
           <p:nvPr/>
         </p:nvSpPr>
@@ -11175,7 +11535,7 @@
       </p:sp>
       <p:sp>
         <p:nvSpPr>
-          <p:cNvPr id="8" name="Rectangle 7"/>
+          <p:cNvPr id="9" name="Rectangle 8"/>
           <p:cNvSpPr/>
           <p:nvPr/>
         </p:nvSpPr>
@@ -11219,7 +11579,7 @@
       </p:sp>
       <p:sp>
         <p:nvSpPr>
-          <p:cNvPr id="9" name="TextBox 8"/>
+          <p:cNvPr id="10" name="TextBox 9"/>
           <p:cNvSpPr txBox="1"/>
           <p:nvPr/>
         </p:nvSpPr>
@@ -11258,7 +11618,7 @@
       </p:sp>
       <p:sp>
         <p:nvSpPr>
-          <p:cNvPr id="10" name="TextBox 9"/>
+          <p:cNvPr id="11" name="TextBox 10"/>
           <p:cNvSpPr txBox="1"/>
           <p:nvPr/>
         </p:nvSpPr>
@@ -11297,7 +11657,7 @@
       </p:sp>
       <p:sp>
         <p:nvSpPr>
-          <p:cNvPr id="11" name="Rectangle 10"/>
+          <p:cNvPr id="12" name="Rectangle 11"/>
           <p:cNvSpPr/>
           <p:nvPr/>
         </p:nvSpPr>
@@ -11341,7 +11701,7 @@
       </p:sp>
       <p:sp>
         <p:nvSpPr>
-          <p:cNvPr id="12" name="Rectangle 11"/>
+          <p:cNvPr id="13" name="Rectangle 12"/>
           <p:cNvSpPr/>
           <p:nvPr/>
         </p:nvSpPr>
@@ -11385,7 +11745,7 @@
       </p:sp>
       <p:sp>
         <p:nvSpPr>
-          <p:cNvPr id="13" name="TextBox 12"/>
+          <p:cNvPr id="14" name="TextBox 13"/>
           <p:cNvSpPr txBox="1"/>
           <p:nvPr/>
         </p:nvSpPr>
@@ -11424,7 +11784,7 @@
       </p:sp>
       <p:sp>
         <p:nvSpPr>
-          <p:cNvPr id="14" name="Rectangle 13"/>
+          <p:cNvPr id="15" name="Rectangle 14"/>
           <p:cNvSpPr/>
           <p:nvPr/>
         </p:nvSpPr>
@@ -11468,7 +11828,7 @@
       </p:sp>
       <p:sp>
         <p:nvSpPr>
-          <p:cNvPr id="15" name="TextBox 14"/>
+          <p:cNvPr id="16" name="TextBox 15"/>
           <p:cNvSpPr txBox="1"/>
           <p:nvPr/>
         </p:nvSpPr>
@@ -11667,7 +12027,7 @@
         <p:spPr>
           <a:xfrm>
             <a:off x="548640" y="475488"/>
-            <a:ext cx="11064240" cy="731520"/>
+            <a:ext cx="10058400" cy="731520"/>
           </a:xfrm>
           <a:prstGeom prst="rect">
             <a:avLst/>
@@ -11697,9 +12057,33 @@
           </a:p>
         </p:txBody>
       </p:sp>
-      <p:sp>
-        <p:nvSpPr>
-          <p:cNvPr id="6" name="Rectangle 5"/>
+      <p:pic>
+        <p:nvPicPr>
+          <p:cNvPr id="6" name="Picture 5" descr="image.png"/>
+          <p:cNvPicPr>
+            <a:picLocks noChangeAspect="1"/>
+          </p:cNvPicPr>
+          <p:nvPr/>
+        </p:nvPicPr>
+        <p:blipFill>
+          <a:blip r:embed="rId2"/>
+          <a:stretch>
+            <a:fillRect/>
+          </a:stretch>
+        </p:blipFill>
+        <p:spPr>
+          <a:xfrm>
+            <a:off x="11045952" y="301752"/>
+            <a:ext cx="548640" cy="548640"/>
+          </a:xfrm>
+          <a:prstGeom prst="rect">
+            <a:avLst/>
+          </a:prstGeom>
+        </p:spPr>
+      </p:pic>
+      <p:sp>
+        <p:nvSpPr>
+          <p:cNvPr id="7" name="Rectangle 6"/>
           <p:cNvSpPr/>
           <p:nvPr/>
         </p:nvSpPr>
@@ -11743,7 +12127,7 @@
       </p:sp>
       <p:sp>
         <p:nvSpPr>
-          <p:cNvPr id="7" name="Rectangle 6"/>
+          <p:cNvPr id="8" name="Rectangle 7"/>
           <p:cNvSpPr/>
           <p:nvPr/>
         </p:nvSpPr>
@@ -11787,7 +12171,7 @@
       </p:sp>
       <p:sp>
         <p:nvSpPr>
-          <p:cNvPr id="8" name="TextBox 7"/>
+          <p:cNvPr id="9" name="TextBox 8"/>
           <p:cNvSpPr txBox="1"/>
           <p:nvPr/>
         </p:nvSpPr>
@@ -11826,7 +12210,7 @@
       </p:sp>
       <p:sp>
         <p:nvSpPr>
-          <p:cNvPr id="9" name="Rectangle 8"/>
+          <p:cNvPr id="10" name="Rectangle 9"/>
           <p:cNvSpPr/>
           <p:nvPr/>
         </p:nvSpPr>
@@ -11870,7 +12254,7 @@
       </p:sp>
       <p:sp>
         <p:nvSpPr>
-          <p:cNvPr id="10" name="TextBox 9"/>
+          <p:cNvPr id="11" name="TextBox 10"/>
           <p:cNvSpPr txBox="1"/>
           <p:nvPr/>
         </p:nvSpPr>
@@ -11909,7 +12293,7 @@
       </p:sp>
       <p:sp>
         <p:nvSpPr>
-          <p:cNvPr id="11" name="Rectangle 10"/>
+          <p:cNvPr id="12" name="Rectangle 11"/>
           <p:cNvSpPr/>
           <p:nvPr/>
         </p:nvSpPr>
@@ -11953,7 +12337,7 @@
       </p:sp>
       <p:sp>
         <p:nvSpPr>
-          <p:cNvPr id="12" name="TextBox 11"/>
+          <p:cNvPr id="13" name="TextBox 12"/>
           <p:cNvSpPr txBox="1"/>
           <p:nvPr/>
         </p:nvSpPr>
@@ -11992,7 +12376,7 @@
       </p:sp>
       <p:sp>
         <p:nvSpPr>
-          <p:cNvPr id="13" name="Rectangle 12"/>
+          <p:cNvPr id="14" name="Rectangle 13"/>
           <p:cNvSpPr/>
           <p:nvPr/>
         </p:nvSpPr>
@@ -12036,7 +12420,7 @@
       </p:sp>
       <p:sp>
         <p:nvSpPr>
-          <p:cNvPr id="14" name="TextBox 13"/>
+          <p:cNvPr id="15" name="TextBox 14"/>
           <p:cNvSpPr txBox="1"/>
           <p:nvPr/>
         </p:nvSpPr>
@@ -12075,7 +12459,7 @@
       </p:sp>
       <p:sp>
         <p:nvSpPr>
-          <p:cNvPr id="15" name="Rectangle 14"/>
+          <p:cNvPr id="16" name="Rectangle 15"/>
           <p:cNvSpPr/>
           <p:nvPr/>
         </p:nvSpPr>
@@ -12119,7 +12503,7 @@
       </p:sp>
       <p:sp>
         <p:nvSpPr>
-          <p:cNvPr id="16" name="TextBox 15"/>
+          <p:cNvPr id="17" name="TextBox 16"/>
           <p:cNvSpPr txBox="1"/>
           <p:nvPr/>
         </p:nvSpPr>
@@ -12158,7 +12542,7 @@
       </p:sp>
       <p:sp>
         <p:nvSpPr>
-          <p:cNvPr id="17" name="Rectangle 16"/>
+          <p:cNvPr id="18" name="Rectangle 17"/>
           <p:cNvSpPr/>
           <p:nvPr/>
         </p:nvSpPr>
@@ -12202,7 +12586,7 @@
       </p:sp>
       <p:sp>
         <p:nvSpPr>
-          <p:cNvPr id="18" name="TextBox 17"/>
+          <p:cNvPr id="19" name="TextBox 18"/>
           <p:cNvSpPr txBox="1"/>
           <p:nvPr/>
         </p:nvSpPr>
@@ -12241,7 +12625,7 @@
       </p:sp>
       <p:sp>
         <p:nvSpPr>
-          <p:cNvPr id="19" name="Rectangle 18"/>
+          <p:cNvPr id="20" name="Rectangle 19"/>
           <p:cNvSpPr/>
           <p:nvPr/>
         </p:nvSpPr>
@@ -12285,7 +12669,7 @@
       </p:sp>
       <p:sp>
         <p:nvSpPr>
-          <p:cNvPr id="20" name="TextBox 19"/>
+          <p:cNvPr id="21" name="TextBox 20"/>
           <p:cNvSpPr txBox="1"/>
           <p:nvPr/>
         </p:nvSpPr>
@@ -12324,7 +12708,7 @@
       </p:sp>
       <p:sp>
         <p:nvSpPr>
-          <p:cNvPr id="21" name="Rectangle 20"/>
+          <p:cNvPr id="22" name="Rectangle 21"/>
           <p:cNvSpPr/>
           <p:nvPr/>
         </p:nvSpPr>
@@ -12368,7 +12752,7 @@
       </p:sp>
       <p:sp>
         <p:nvSpPr>
-          <p:cNvPr id="22" name="TextBox 21"/>
+          <p:cNvPr id="23" name="TextBox 22"/>
           <p:cNvSpPr txBox="1"/>
           <p:nvPr/>
         </p:nvSpPr>
@@ -12407,7 +12791,7 @@
       </p:sp>
       <p:sp>
         <p:nvSpPr>
-          <p:cNvPr id="23" name="Rectangle 22"/>
+          <p:cNvPr id="24" name="Rectangle 23"/>
           <p:cNvSpPr/>
           <p:nvPr/>
         </p:nvSpPr>
@@ -12451,7 +12835,7 @@
       </p:sp>
       <p:sp>
         <p:nvSpPr>
-          <p:cNvPr id="24" name="Rectangle 23"/>
+          <p:cNvPr id="25" name="Rectangle 24"/>
           <p:cNvSpPr/>
           <p:nvPr/>
         </p:nvSpPr>
@@ -12495,7 +12879,7 @@
       </p:sp>
       <p:sp>
         <p:nvSpPr>
-          <p:cNvPr id="25" name="TextBox 24"/>
+          <p:cNvPr id="26" name="TextBox 25"/>
           <p:cNvSpPr txBox="1"/>
           <p:nvPr/>
         </p:nvSpPr>
@@ -12534,7 +12918,7 @@
       </p:sp>
       <p:sp>
         <p:nvSpPr>
-          <p:cNvPr id="26" name="Rectangle 25"/>
+          <p:cNvPr id="27" name="Rectangle 26"/>
           <p:cNvSpPr/>
           <p:nvPr/>
         </p:nvSpPr>
@@ -12578,7 +12962,7 @@
       </p:sp>
       <p:sp>
         <p:nvSpPr>
-          <p:cNvPr id="27" name="TextBox 26"/>
+          <p:cNvPr id="28" name="TextBox 27"/>
           <p:cNvSpPr txBox="1"/>
           <p:nvPr/>
         </p:nvSpPr>
@@ -12777,7 +13161,7 @@
         <p:spPr>
           <a:xfrm>
             <a:off x="548640" y="475488"/>
-            <a:ext cx="11064240" cy="731520"/>
+            <a:ext cx="10058400" cy="731520"/>
           </a:xfrm>
           <a:prstGeom prst="rect">
             <a:avLst/>
@@ -12807,9 +13191,33 @@
           </a:p>
         </p:txBody>
       </p:sp>
-      <p:sp>
-        <p:nvSpPr>
-          <p:cNvPr id="6" name="TextBox 5"/>
+      <p:pic>
+        <p:nvPicPr>
+          <p:cNvPr id="6" name="Picture 5" descr="image.png"/>
+          <p:cNvPicPr>
+            <a:picLocks noChangeAspect="1"/>
+          </p:cNvPicPr>
+          <p:nvPr/>
+        </p:nvPicPr>
+        <p:blipFill>
+          <a:blip r:embed="rId2"/>
+          <a:stretch>
+            <a:fillRect/>
+          </a:stretch>
+        </p:blipFill>
+        <p:spPr>
+          <a:xfrm>
+            <a:off x="11045952" y="301752"/>
+            <a:ext cx="548640" cy="548640"/>
+          </a:xfrm>
+          <a:prstGeom prst="rect">
+            <a:avLst/>
+          </a:prstGeom>
+        </p:spPr>
+      </p:pic>
+      <p:sp>
+        <p:nvSpPr>
+          <p:cNvPr id="7" name="TextBox 6"/>
           <p:cNvSpPr txBox="1"/>
           <p:nvPr/>
         </p:nvSpPr>
@@ -12972,7 +13380,7 @@
       </p:sp>
       <p:sp>
         <p:nvSpPr>
-          <p:cNvPr id="7" name="Rectangle 6"/>
+          <p:cNvPr id="8" name="Rectangle 7"/>
           <p:cNvSpPr/>
           <p:nvPr/>
         </p:nvSpPr>
@@ -13016,7 +13424,7 @@
       </p:sp>
       <p:sp>
         <p:nvSpPr>
-          <p:cNvPr id="8" name="Rectangle 7"/>
+          <p:cNvPr id="9" name="Rectangle 8"/>
           <p:cNvSpPr/>
           <p:nvPr/>
         </p:nvSpPr>
@@ -13060,7 +13468,7 @@
       </p:sp>
       <p:sp>
         <p:nvSpPr>
-          <p:cNvPr id="9" name="TextBox 8"/>
+          <p:cNvPr id="10" name="TextBox 9"/>
           <p:cNvSpPr txBox="1"/>
           <p:nvPr/>
         </p:nvSpPr>
@@ -13099,7 +13507,7 @@
       </p:sp>
       <p:sp>
         <p:nvSpPr>
-          <p:cNvPr id="10" name="TextBox 9"/>
+          <p:cNvPr id="11" name="TextBox 10"/>
           <p:cNvSpPr txBox="1"/>
           <p:nvPr/>
         </p:nvSpPr>
@@ -13138,7 +13546,7 @@
       </p:sp>
       <p:sp>
         <p:nvSpPr>
-          <p:cNvPr id="11" name="Rectangle 10"/>
+          <p:cNvPr id="12" name="Rectangle 11"/>
           <p:cNvSpPr/>
           <p:nvPr/>
         </p:nvSpPr>
@@ -13182,7 +13590,7 @@
       </p:sp>
       <p:sp>
         <p:nvSpPr>
-          <p:cNvPr id="12" name="Rectangle 11"/>
+          <p:cNvPr id="13" name="Rectangle 12"/>
           <p:cNvSpPr/>
           <p:nvPr/>
         </p:nvSpPr>
@@ -13226,7 +13634,7 @@
       </p:sp>
       <p:sp>
         <p:nvSpPr>
-          <p:cNvPr id="13" name="TextBox 12"/>
+          <p:cNvPr id="14" name="TextBox 13"/>
           <p:cNvSpPr txBox="1"/>
           <p:nvPr/>
         </p:nvSpPr>
@@ -13265,7 +13673,7 @@
       </p:sp>
       <p:sp>
         <p:nvSpPr>
-          <p:cNvPr id="14" name="Rectangle 13"/>
+          <p:cNvPr id="15" name="Rectangle 14"/>
           <p:cNvSpPr/>
           <p:nvPr/>
         </p:nvSpPr>
@@ -13309,7 +13717,7 @@
       </p:sp>
       <p:sp>
         <p:nvSpPr>
-          <p:cNvPr id="15" name="TextBox 14"/>
+          <p:cNvPr id="16" name="TextBox 15"/>
           <p:cNvSpPr txBox="1"/>
           <p:nvPr/>
         </p:nvSpPr>
@@ -13588,9 +13996,33 @@
           </a:p>
         </p:txBody>
       </p:sp>
-      <p:sp>
-        <p:nvSpPr>
-          <p:cNvPr id="7" name="Rectangle 6"/>
+      <p:pic>
+        <p:nvPicPr>
+          <p:cNvPr id="7" name="Picture 6" descr="image.png"/>
+          <p:cNvPicPr>
+            <a:picLocks noChangeAspect="1"/>
+          </p:cNvPicPr>
+          <p:nvPr/>
+        </p:nvPicPr>
+        <p:blipFill>
+          <a:blip r:embed="rId2"/>
+          <a:stretch>
+            <a:fillRect/>
+          </a:stretch>
+        </p:blipFill>
+        <p:spPr>
+          <a:xfrm>
+            <a:off x="9646920" y="4206240"/>
+            <a:ext cx="1691640" cy="1691640"/>
+          </a:xfrm>
+          <a:prstGeom prst="rect">
+            <a:avLst/>
+          </a:prstGeom>
+        </p:spPr>
+      </p:pic>
+      <p:sp>
+        <p:nvSpPr>
+          <p:cNvPr id="8" name="Rectangle 7"/>
           <p:cNvSpPr/>
           <p:nvPr/>
         </p:nvSpPr>
@@ -13634,7 +14066,7 @@
       </p:sp>
       <p:sp>
         <p:nvSpPr>
-          <p:cNvPr id="8" name="TextBox 7"/>
+          <p:cNvPr id="9" name="TextBox 8"/>
           <p:cNvSpPr txBox="1"/>
           <p:nvPr/>
         </p:nvSpPr>
@@ -13833,7 +14265,7 @@
         <p:spPr>
           <a:xfrm>
             <a:off x="548640" y="475488"/>
-            <a:ext cx="11064240" cy="731520"/>
+            <a:ext cx="10058400" cy="731520"/>
           </a:xfrm>
           <a:prstGeom prst="rect">
             <a:avLst/>
@@ -13863,9 +14295,33 @@
           </a:p>
         </p:txBody>
       </p:sp>
-      <p:sp>
-        <p:nvSpPr>
-          <p:cNvPr id="6" name="TextBox 5"/>
+      <p:pic>
+        <p:nvPicPr>
+          <p:cNvPr id="6" name="Picture 5" descr="image.png"/>
+          <p:cNvPicPr>
+            <a:picLocks noChangeAspect="1"/>
+          </p:cNvPicPr>
+          <p:nvPr/>
+        </p:nvPicPr>
+        <p:blipFill>
+          <a:blip r:embed="rId2"/>
+          <a:stretch>
+            <a:fillRect/>
+          </a:stretch>
+        </p:blipFill>
+        <p:spPr>
+          <a:xfrm>
+            <a:off x="11045952" y="301752"/>
+            <a:ext cx="548640" cy="548640"/>
+          </a:xfrm>
+          <a:prstGeom prst="rect">
+            <a:avLst/>
+          </a:prstGeom>
+        </p:spPr>
+      </p:pic>
+      <p:sp>
+        <p:nvSpPr>
+          <p:cNvPr id="7" name="TextBox 6"/>
           <p:cNvSpPr txBox="1"/>
           <p:nvPr/>
         </p:nvSpPr>
@@ -13964,7 +14420,7 @@
       </p:sp>
       <p:sp>
         <p:nvSpPr>
-          <p:cNvPr id="7" name="Rectangle 6"/>
+          <p:cNvPr id="8" name="Rectangle 7"/>
           <p:cNvSpPr/>
           <p:nvPr/>
         </p:nvSpPr>
@@ -14008,7 +14464,7 @@
       </p:sp>
       <p:sp>
         <p:nvSpPr>
-          <p:cNvPr id="8" name="Rectangle 7"/>
+          <p:cNvPr id="9" name="Rectangle 8"/>
           <p:cNvSpPr/>
           <p:nvPr/>
         </p:nvSpPr>
@@ -14052,7 +14508,7 @@
       </p:sp>
       <p:sp>
         <p:nvSpPr>
-          <p:cNvPr id="9" name="TextBox 8"/>
+          <p:cNvPr id="10" name="TextBox 9"/>
           <p:cNvSpPr txBox="1"/>
           <p:nvPr/>
         </p:nvSpPr>
@@ -14091,7 +14547,7 @@
       </p:sp>
       <p:sp>
         <p:nvSpPr>
-          <p:cNvPr id="10" name="Rectangle 9"/>
+          <p:cNvPr id="11" name="Rectangle 10"/>
           <p:cNvSpPr/>
           <p:nvPr/>
         </p:nvSpPr>
@@ -14135,7 +14591,7 @@
       </p:sp>
       <p:sp>
         <p:nvSpPr>
-          <p:cNvPr id="11" name="TextBox 10"/>
+          <p:cNvPr id="12" name="TextBox 11"/>
           <p:cNvSpPr txBox="1"/>
           <p:nvPr/>
         </p:nvSpPr>
@@ -14334,7 +14790,7 @@
         <p:spPr>
           <a:xfrm>
             <a:off x="548640" y="475488"/>
-            <a:ext cx="11064240" cy="731520"/>
+            <a:ext cx="10058400" cy="731520"/>
           </a:xfrm>
           <a:prstGeom prst="rect">
             <a:avLst/>
@@ -14364,9 +14820,33 @@
           </a:p>
         </p:txBody>
       </p:sp>
-      <p:sp>
-        <p:nvSpPr>
-          <p:cNvPr id="6" name="TextBox 5"/>
+      <p:pic>
+        <p:nvPicPr>
+          <p:cNvPr id="6" name="Picture 5" descr="image.png"/>
+          <p:cNvPicPr>
+            <a:picLocks noChangeAspect="1"/>
+          </p:cNvPicPr>
+          <p:nvPr/>
+        </p:nvPicPr>
+        <p:blipFill>
+          <a:blip r:embed="rId2"/>
+          <a:stretch>
+            <a:fillRect/>
+          </a:stretch>
+        </p:blipFill>
+        <p:spPr>
+          <a:xfrm>
+            <a:off x="11045952" y="301752"/>
+            <a:ext cx="548640" cy="548640"/>
+          </a:xfrm>
+          <a:prstGeom prst="rect">
+            <a:avLst/>
+          </a:prstGeom>
+        </p:spPr>
+      </p:pic>
+      <p:sp>
+        <p:nvSpPr>
+          <p:cNvPr id="7" name="TextBox 6"/>
           <p:cNvSpPr txBox="1"/>
           <p:nvPr/>
         </p:nvSpPr>
@@ -14502,7 +14982,7 @@
       </p:sp>
       <p:sp>
         <p:nvSpPr>
-          <p:cNvPr id="7" name="Rectangle 6"/>
+          <p:cNvPr id="8" name="Rectangle 7"/>
           <p:cNvSpPr/>
           <p:nvPr/>
         </p:nvSpPr>
@@ -14546,7 +15026,7 @@
       </p:sp>
       <p:sp>
         <p:nvSpPr>
-          <p:cNvPr id="8" name="Rectangle 7"/>
+          <p:cNvPr id="9" name="Rectangle 8"/>
           <p:cNvSpPr/>
           <p:nvPr/>
         </p:nvSpPr>
@@ -14590,7 +15070,7 @@
       </p:sp>
       <p:sp>
         <p:nvSpPr>
-          <p:cNvPr id="9" name="TextBox 8"/>
+          <p:cNvPr id="10" name="TextBox 9"/>
           <p:cNvSpPr txBox="1"/>
           <p:nvPr/>
         </p:nvSpPr>
@@ -14629,7 +15109,7 @@
       </p:sp>
       <p:sp>
         <p:nvSpPr>
-          <p:cNvPr id="10" name="Rectangle 9"/>
+          <p:cNvPr id="11" name="Rectangle 10"/>
           <p:cNvSpPr/>
           <p:nvPr/>
         </p:nvSpPr>
@@ -14673,7 +15153,7 @@
       </p:sp>
       <p:sp>
         <p:nvSpPr>
-          <p:cNvPr id="11" name="TextBox 10"/>
+          <p:cNvPr id="12" name="TextBox 11"/>
           <p:cNvSpPr txBox="1"/>
           <p:nvPr/>
         </p:nvSpPr>

</xml_diff>